<commit_message>
Soojung deck v3: correct HSP90 classification wording and figure, rule-leak terms, overclaims; add nanodisc appendix per Pro review
Co-Authored-By: Claude Opus 5 <noreply@anthropic.com>
</commit_message>
<xml_diff>
--- a/review/rules-agent-study-20260909/development-results/SOOJUNG_DISCUSSION_20260910_EN.pptx
+++ b/review/rules-agent-study-20260909/development-results/SOOJUNG_DISCUSSION_20260910_EN.pptx
@@ -31,9 +31,10 @@
     <p:sldId id="279" r:id="rId25"/>
     <p:sldId id="280" r:id="rId26"/>
     <p:sldId id="281" r:id="rId27"/>
+    <p:sldId id="282" r:id="rId28"/>
   </p:sldIdLst>
   <p:notesMasterIdLst>
-    <p:notesMasterId r:id="rId28"/>
+    <p:notesMasterId r:id="rId29"/>
   </p:notesMasterIdLst>
   <p:sldSz cx="9144000" cy="5143500"/>
   <p:notesSz cx="5143500" cy="9144000"/>
@@ -527,7 +528,7 @@
           <a:p>
             <a:r>
               <a:rPr lang="en-US" dirty="0"/>
-              <a:t>SAY: Last time you knew I was building a Rules Table prototype. Today I want to discuss how the whole system should be built. I'll show the original idea, the workflow a new system goes through, what happened when three real systems went through it, what each layer of the table measured, and three design options for the table. Headline first: putting rules into the AI's prompt did not help. The errors we made were at data entry and at the numbers going out. The one layer that met its criterion was framing the question explicitly, and that part is done by a person.
+              <a:t>SAY: Last time you knew I was building a Rules Table prototype. Today I want to discuss how the whole system should be built. I'll show the original idea, the workflow a new system goes through, what happened when three real systems went through it, what each layer of the table measured, and three design options for the table. Headline first: putting rules into the AI's prompt did not help on the two questions where we tried it. Most of the errors we could locate sat at data entry or in the reported numbers; that audit is retrospective, not a controlled test. The one use that met its pre-set criterion was framing the question explicitly, and that part is done by a person.
 GOAL: (1) is the workflow reasonable; (2) are the three systems right; (3) which form of the table to build toward.</a:t>
             </a:r>
             <a:endParaRPr lang="en-US" dirty="0"/>
@@ -616,7 +617,7 @@
           <a:p>
             <a:r>
               <a:rPr lang="en-US" dirty="0"/>
-              <a:t>SAY: Before testing the four uses we audited every answer we had: eight answers, thirteen observations, seven underlying causes, so correlated observations rather than thirteen independent cases. Grouped by the workflow step where each lives: input representation, numbers read from the wrong column or threshold, the sign of a difference read as arrival, imported conditions. Reminder text prevents none. Code before freezing or after submission could plausibly prevent most; two need the question asked better. That was a candidate attribution; the tests on the next slides check it. One detail for later: three of the thirteen were caught when we replayed the DHFR input checks; the conclusion checker on slide 15 caught zero of the seven numeric ones. Different subsets, both true.</a:t>
+              <a:t>SAY: Before testing the four uses we audited every answer we had: eight answers, thirteen observations, seven underlying causes, so correlated observations rather than thirteen independent cases. Grouped by the workflow step where each lives: input representation, numbers read from the wrong column or threshold, the sign of a difference read as arrival, imported conditions. Reminder text had no obvious hook in any of them; that is a judgement, not a test. Code before freezing or after submission could plausibly prevent most; two need the question asked better. That was a candidate attribution; the tests on the next slides check it. One detail for later: three of the thirteen were caught when we replayed the DHFR input checks; the conclusion checker on slide 15 caught zero of the seven numeric ones. Different subsets, both true.</a:t>
             </a:r>
             <a:endParaRPr lang="en-US" dirty="0"/>
           </a:p>
@@ -792,7 +793,7 @@
           <a:p>
             <a:r>
               <a:rPr lang="en-US" dirty="0"/>
-              <a:t>SAY: This is the current design and a direct answer to the original question of how the Agent should use the table. Framing: six rules become sub-questions and the grading key, never shown to the Agent. Data checks: ten rules become code before freezing, reaching the Agent only as a card of results. Method cards: eleven rules become short cards retrieved by method family, the only rule text the Agent reads. Conclusion checks: six rules become an automatic check after submission with one feedback message. Each use changes exactly one thing about what the Agent receives, so each can be tested on its own. The order follows the ensemble blog by Li, Thomasen and Cossio: decide which difference to distinguish, confirm it survives measurement and processing, then choose the method.
+              <a:t>SAY: This is the current design and a direct answer to the original question of how the Agent should use the table. Framing: six rules become sub-questions and the grading key, never shown to the Agent. Data checks: ten rules become code before freezing, reaching the Agent only as a card of results. Method cards: eleven rules become short cards retrieved by method family, the only rule text the Agent reads. Conclusion checks: six rules become an automatic check after submission with one feedback message. Each use changes exactly one thing about what the Agent receives, so each can be tested on its own. The ensemble blog by Li, Thomasen and Cossio motivates the order: decide which difference to distinguish, confirm it survives measurement and processing, then choose the method. The four-way split is our own design hypothesis, not a conclusion of the blog, and the uses overlap: whether a method applies matters in preparation, computation and interpretation alike.
 GRILL "is the split arbitrary": it follows the rule_class field in the table; the assignment is in the appendix and can be argued rule by rule.</a:t>
             </a:r>
             <a:endParaRPr lang="en-US" dirty="0"/>
@@ -1236,7 +1237,7 @@
           <a:p>
             <a:r>
               <a:rPr lang="en-US" dirty="0"/>
-              <a:t>SAY: Back to the criterion: MD plus an experiment that constrains the difference the question is about. HSP90 has two NOE references and CPMG; it fully qualifies and gave the one real cross-source result. DHFR has kinetics only; it tested the workflow, not the science, and exposed the missing data check. ADK has time-resolved scattering, but the deposited MD is ligand-free and nanoseconds against milliseconds; it broke my data check, framing helped on it, and it is the only system the rules had never seen. Question for you: is this the right criterion, and is there a fourth system with MD plus NMR, SAXS or single-molecule FRET data that constrains populations, ideally from the group's own work?
+              <a:t>SAY: Back to the criterion: MD plus an experiment that constrains the difference the question is about. HSP90 has two NOE references and CPMG; it fully qualifies, and together with the nanodisc development case it is where we have a cross-source result. DHFR has kinetics only; it tested the workflow, not the science, and exposed the missing data check. ADK has time-resolved scattering, but the deposited MD is ligand-free and nanoseconds against milliseconds; it broke my data check, framing helped on it, and it is the only system the rules had never seen. Question for you: is this the right criterion, and is there a fourth system with MD plus NMR, SAXS or single-molecule FRET data that constrains populations, ideally from the group's own work?
 GRILL "drop DHFR": as a science system yes; as a workflow regression test it earned its keep.</a:t>
             </a:r>
             <a:endParaRPr lang="en-US" dirty="0"/>
@@ -1325,7 +1326,7 @@
           <a:p>
             <a:r>
               <a:rPr lang="en-US" dirty="0"/>
-              <a:t>SAY: Three sentences. The three systems produced bounded, checkable results; HSP90 is the strongest and a real cross-source comparison. The table as prompt text did not earn its place; its content is still the raw material for executable checks and operation-indexed guidance, and framing the question explicitly, by a person, is the one use that measurably helped. The next build should put physical data checks inside preparation, make rules executable where they can be, and be tested against the seven-line protocol on new questions with independent scoring. Three decisions from you: is the workflow on slide 3 reasonable; which form of the table should we build toward; are these the right three systems, and is there a fourth.
+              <a:t>SAY: Three sentences. The three systems produced bounded, checkable results; HSP90 is the strongest and a real cross-source comparison. The table as prompt text did not earn its place; its content is still the raw material for executable checks and operation-indexed guidance, and framing the question explicitly, by a person, is the one use that measurably helped. The next build should put physical data checks inside preparation, make rules executable where they can be, and be tested against the seven-line protocol on new questions with independent scoring. Three decisions from you: is the workflow on slide 3 reasonable; which form of the table should we build toward; are these the right three systems, and is there a fourth. And one science question: in HSP90, is 1 Å on mean NOE violation the right test for being at the open state?
 Leave this slide up for discussion.</a:t>
             </a:r>
             <a:endParaRPr lang="en-US" dirty="0"/>
@@ -2119,6 +2120,94 @@
           <a:p>
             <a:r>
               <a:rPr lang="en-US" dirty="0"/>
+              <a:t>SAY if asked: this is the most direct cross-observable result we have. Same MD ensemble, weights adjusted to fit SAXS only. The SAXS penalty falls from 10.0 to 1.2, while the penalties for both NOE sets, computed with the same weights, get worse. A better fit to one observable does not bring agreement with another. It is a conditional answer, not proof that the experiments contradict each other; restraint reuse, error model, candidate construction and NOE averaging still limit it. The analysis was designed by the developer; Agent runs on this case carried the result through, they did not discover the method.</a:t>
+            </a:r>
+            <a:endParaRPr lang="en-US" dirty="0"/>
+          </a:p>
+        </p:txBody>
+      </p:sp>
+      <p:sp>
+        <p:nvSpPr>
+          <p:cNvPr id="4" name="Slide Number Placeholder 3"/>
+          <p:cNvSpPr>
+            <a:spLocks noGrp="1"/>
+          </p:cNvSpPr>
+          <p:nvPr>
+            <p:ph type="sldNum" sz="quarter" idx="10"/>
+          </p:nvPr>
+        </p:nvSpPr>
+        <p:spPr/>
+        <p:txBody>
+          <a:bodyPr/>
+          <a:lstStyle/>
+          <a:p>
+            <a:fld id="{F7021451-1387-4CA6-816F-3879F97B5CBC}" type="slidenum">
+              <a:rPr lang="en-US"/>
+              <a:t>26</a:t>
+            </a:fld>
+            <a:endParaRPr lang="en-US"/>
+          </a:p>
+        </p:txBody>
+      </p:sp>
+    </p:spTree>
+    <p:extLst>
+      <p:ext uri="{BB962C8B-B14F-4D97-AF65-F5344CB8AC3E}">
+        <p14:creationId xmlns:p14="http://schemas.microsoft.com/office/powerpoint/2010/main" val="1024086991"/>
+      </p:ext>
+    </p:extLst>
+  </p:cSld>
+  <p:clrMapOvr>
+    <a:masterClrMapping/>
+  </p:clrMapOvr>
+</p:notes>
+</file>
+
+<file path=ppt/notesSlides/notesSlide27.xml><?xml version="1.0" encoding="utf-8"?>
+<p:notes xmlns:a="http://schemas.openxmlformats.org/drawingml/2006/main" xmlns:r="http://schemas.openxmlformats.org/officeDocument/2006/relationships" xmlns:p="http://schemas.openxmlformats.org/presentationml/2006/main">
+  <p:cSld>
+    <p:spTree>
+      <p:nvGrpSpPr>
+        <p:cNvPr id="1" name=""/>
+        <p:cNvGrpSpPr/>
+        <p:nvPr/>
+      </p:nvGrpSpPr>
+      <p:grpSpPr>
+        <a:xfrm>
+          <a:off x="0" y="0"/>
+          <a:ext cx="0" cy="0"/>
+          <a:chOff x="0" y="0"/>
+          <a:chExt cx="0" cy="0"/>
+        </a:xfrm>
+      </p:grpSpPr>
+      <p:sp>
+        <p:nvSpPr>
+          <p:cNvPr id="2" name="Slide Image Placeholder 1"/>
+          <p:cNvSpPr>
+            <a:spLocks noGrp="1" noRot="1" noChangeAspect="1"/>
+          </p:cNvSpPr>
+          <p:nvPr>
+            <p:ph type="sldImg"/>
+          </p:nvPr>
+        </p:nvSpPr>
+        <p:spPr/>
+      </p:sp>
+      <p:sp>
+        <p:nvSpPr>
+          <p:cNvPr id="3" name="Notes Placeholder 2"/>
+          <p:cNvSpPr>
+            <a:spLocks noGrp="1"/>
+          </p:cNvSpPr>
+          <p:nvPr>
+            <p:ph type="body" idx="1"/>
+          </p:nvPr>
+        </p:nvSpPr>
+        <p:spPr/>
+        <p:txBody>
+          <a:bodyPr/>
+          <a:lstStyle/>
+          <a:p>
+            <a:r>
+              <a:rPr lang="en-US" dirty="0"/>
               <a:t/>
             </a:r>
             <a:endParaRPr lang="en-US" dirty="0"/>
@@ -2142,7 +2231,7 @@
           <a:p>
             <a:fld id="{F7021451-1387-4CA6-816F-3879F97B5CBC}" type="slidenum">
               <a:rPr lang="en-US"/>
-              <a:t>26</a:t>
+              <a:t>27</a:t>
             </a:fld>
             <a:endParaRPr lang="en-US"/>
           </a:p>
@@ -2207,7 +2296,7 @@
           <a:p>
             <a:r>
               <a:rPr lang="en-US" dirty="0"/>
-              <a:t>SAY: Left to right. Intake: download the authors' deposited data and write a source card, a one-page record of paper, SI, README, frame counts, units. Package: derived tables such as per-frame distances, field definitions, physical checks, then freeze. Freezing means hashing question, grading key and code before the first model call so nothing is tuned afterwards. Frame: a person decides which difference the question must distinguish and writes the grading key, the list of what a correct answer must contain. Run: the Agent works in a sealed container. Check: automatic checks on what it submitted. Report: every number linked to source, the claim limit in words. The bottom row shows where the table can act: data checks at step 2, question framing at step 3, method guidance at step 4, conclusion checks at step 5. Version one, July to early September, used the table only at step 4, as text pasted into the prompt. The three systems went through that version.
+              <a:t>SAY: Left to right. Intake: download the authors' deposited data and write a source card, a one-page record of paper, SI, README, frame counts, units. Package: derived tables such as per-frame distances, field definitions, physical checks, then freeze. Freezing means hashing question, grading key and code before the first model call so nothing is tuned afterwards. Frame: a person decides which difference the question must distinguish and writes the grading key, the list of what a correct answer must contain. Run: the Agent works in a sealed container. Check: automatic checks on what it submitted. Report: every number linked to source, the claim limit in words. The bottom row shows where the table can act: data checks at step 2, question framing at step 3, method guidance at step 4, conclusion checks at step 5. Before September we tested whether the selector picked the right checks: 41 of 41 pre-registered checks, among 146 generated. That is selection coverage, not scientific help. When the three systems ran, the table reached the Agent only at step 4, as selected rules pasted into the prompt.
 GRILL "where is the person": steps 1, 3, 6. Step 3 cannot be delegated: the competing explanations.</a:t>
             </a:r>
             <a:endParaRPr lang="en-US" dirty="0"/>
@@ -2296,7 +2385,7 @@
           <a:p>
             <a:r>
               <a:rPr lang="en-US" dirty="0"/>
-              <a:t>SAY: Before the systems, the vocabulary. Four cases appear in this talk. HSP90, DHFR and ADK are the systems you named; the nanodisc is a development case from Bengtsen's paper that we used in September to check that the Agent can compute at all, and it reappears in the later tests. The criterion I propose for a system: it needs MD plus an experiment that constrains the very difference the question is about; by that criterion only HSP90 fully qualifies, and I will come back to that on slide 17. The comparison design is always the same: same question, two or three conditions, four fresh runs per condition. A condition, or arm, differs in exactly one thing, for example rules in the prompt or not. Answers are scored against a grading key written from the public question, the data and the paper, frozen before the first run, never from the rules. Each question has five core units, the pieces a correct answer must contain, and we count units correct, errors, overclaims and omissions. Scoring is done on de-labelled answers and compared as medians of four.
+              <a:t>SAY: Before the systems, the vocabulary. Four cases appear in this talk. HSP90, DHFR and ADK are the systems you named; the nanodisc is a development case from Bengtsen's paper that we used in September to check that the Agent can compute at all, and it reappears in the later tests. The criterion I propose for a system: it needs MD plus an experiment that constrains the very difference the question is about; among the three systems you named only HSP90 fully qualifies; the nanodisc qualifies too but is a development case, and its cross-observable result is in appendix A6. I will come back to this on slide 17. The comparison design is always the same: same question, two or three conditions, four fresh runs per condition. A condition, or arm, differs in exactly one thing, for example rules in the prompt or not. Answers are scored against a grading key written from the public question, the data and the paper, frozen before the first run, never from the rules. Each question has five core units, the pieces a correct answer must contain, and we count units correct, errors, overclaims and omissions. Scoring is done on de-labelled answers and compared as medians of four.
 GRILL "why four": enough for an investment decision, not for a rate.</a:t>
             </a:r>
             <a:endParaRPr lang="en-US" dirty="0"/>
@@ -2385,7 +2474,7 @@
           <a:p>
             <a:r>
               <a:rPr lang="en-US" dirty="0"/>
-              <a:t>SAY: What the paper is. Henot and colleagues combine NMR with forty one-microsecond MD trajectories, twenty from the open crystal structure and twenty from a closed model, to argue that the closed state of the N-terminal domain is transiently populated. They classify the twenty closed-start runs as seven near-closed, about nine toward open, four neither, using NOE violations and clustering. They report millisecond exchange from CPMG and do not claim populations from MD. What we asked: does a trajectory show a sustained open direction, defined as the sign of two difference readouts staying open for five consecutive saved points, and does it ever reverse. The figure: of twenty closed-start runs, ten show a sustained open direction, five from the start and five later; ten never do; five later reverse. Open-start: none reverse. Same data, different question, so our ten need not match their nine.
+              <a:t>SAY: What the paper is. Henot and colleagues combine NMR with forty one-microsecond MD trajectories, twenty from the open crystal structure and twenty from a closed model, to argue that the closed state of the N-terminal domain is transiently populated. They classify the twenty closed-start runs as seven near-closed, about nine toward open, four neither, using NOE violations and clustering. They report millisecond exchange from CPMG and do not claim populations from MD. What we asked: does a trajectory show a sustained open direction, defined as the sign of two difference readouts staying open for five consecutive saved points, and does it ever reverse. The figure: of twenty closed-start runs, ten show a sustained open direction. For five, the first qualifying segment is already open-direction; that does not mean they were open at time zero. The other five first held a closed direction and turned open later; those are the same five counted as departures from the first sustained direction. Ten never show it. Open-start: none depart. Same data, different question, so our ten need not match their nine.
 GRILL "why 5 points": pre-registered 5, 20, 50; the reversal count 5/4/1 falls with the threshold because the threshold also changes which segment counts as the reference.</a:t>
             </a:r>
             <a:endParaRPr lang="en-US" dirty="0"/>
@@ -2474,8 +2563,9 @@
           <a:p>
             <a:r>
               <a:rPr lang="en-US" dirty="0"/>
-              <a:t>SAY: "Open direction" is the sign of a difference and says nothing about reaching the open state. So we compared every trajectory's last hundred points with the authors' deposited NOE violation series for both references. The scatter: x is violation of the closed references, y of the open references; near the left edge means near closed, near the bottom means near open. Open-start controls, the squares, sit at the bottom: eighteen of twenty within 1 Å of the open references, which is what validates the tolerance. The dark circles, our ten open-direction runs, have left the closed side but only one is partially within the open tolerance and none fully; nine are far from both. Leaving closed and arriving at open are two different questions. This agrees with the paper's phrase that these runs almost satisfy the open NOEs. What the system-level result is: the Agent reproduced direction counts; nothing in the rules made it ask "did it arrive". A person added that question. That is the framing use of the table.
-GRILL "why 1 Å": pre-registered 0.5, 1, 2. At 0.5 the controls drop to 7 of 20; at 2 Å three candidates become consistent. All three reported.</a:t>
+              <a:t>SAY: "Open direction" is the sign of a difference and says nothing about reaching the open state. So we read the authors' deposited NOE violation series for both references, point by point. For each trajectory we asked what share of its open-direction points lies within 1 Å of the open references; if at least half are far from both references, the run is called relative only. Nine of the ten are relative only, ES04 is partial, none reaches agreement. The open-start controls, the squares, agree in eighteen of twenty, which is what validates the tolerance. The scatter is for orientation: each point is the mean of the last hundred points. The runs have clearly left the closed side and several end near the open line. ES15 drops from 9.1 to 1.1 Å between its first and last hundred points, and ES04 and ES15 enter the control band (95th percentile of open-start values, 1.32 Å, held for 50 points) at 188 and 690 ns. So there is real structural change; moving closer is not the same as meeting the open tolerance most of the time. This agrees with the paper's phrase that these runs almost satisfy the open NOEs. System point: the Agent reproduced direction counts; the arrival question was added by a person. That is what the framing use of the table is for.
+ASK HER: is a 1 Å tolerance on mean NOE violation a sensible test for being at the open state? What would you use?
+GRILL "why 1 Å": pre-registered 0.5, 1, 2. At 0.5 the controls drop to 7 of 20; at 2 Å three candidates become consistent. All three reported. GRILL "did it open or not": some runs show an open direction and locally approach the open reference; they cannot all be counted as complete transitions. The control band is a same-source empirical comparison, not an independent state calibration.</a:t>
             </a:r>
             <a:endParaRPr lang="en-US" dirty="0"/>
           </a:p>
@@ -2563,7 +2653,7 @@
           <a:p>
             <a:r>
               <a:rPr lang="en-US" dirty="0"/>
-              <a:t>SAY: This was the first real use of the table, version one. Same question, four answers: two with only the data, two with the selected rules rendered into the prompt, seven rules, eight obligations, about 7,600 characters. Three of four got the main counts right; one mixed the five-point and fifty-point thresholds and did no calculation. The two rule answers were not more accurate, and both added requirements that belong to single-molecule FRET: an RMP restraint, a prior ensemble, a fit objective. Those came from a FRET calibration rule and a FRET-assisted modeling rule. The selector matched them because it works by method family, so a generic "MD uncertainty" check got mapped onto FRET-specific text. That is a concrete harm of the prompt form, not a vague one. Two runs per arm is not a verdict on rules; it was enough to stop expanding this form and to ask where the errors actually live.</a:t>
+              <a:t>SAY: This was the first real use of the table, in the form the three systems ran under. Same question, four answers: two with only the data, two with the selected rules rendered into the prompt, seven rules, eight obligations, about 7,600 characters. Three of four got the main counts right; one mixed the five-point and fifty-point thresholds and did no calculation. The two rule answers were not more accurate. One of them, B2, added a useful 10 of 20 count. Both carried RMP-restraint conditions that belong to FRET-assisted modeling. That text reached the prompt because an NMR reference-source check was mapped onto Dimura's FRET-assisted modeling rule, and an MD-uncertainty check onto a smFRET calibration rule with R0 and dye volume. The paper supports those conditions for its own method; making them required fields for any NMR or MD analysis was our addition. Two runs per arm, and both arms shared the hand-written question, tables and field notes, so this cannot separate the selector from the protocol, the curation or the text length. It was enough to stop expanding this form and ask where the errors actually live.</a:t>
             </a:r>
             <a:endParaRPr lang="en-US" dirty="0"/>
           </a:p>
@@ -2651,7 +2741,7 @@
           <a:p>
             <a:r>
               <a:rPr lang="en-US" dirty="0"/>
-              <a:t>SAY: What the paper is. Trimethoprim loses potency against the L28R mutant of DHFR; the analog 4′-DTMP recovers it. Their Table 1 inhibition constants: wild type 4.2 versus 5.1 nanomolar, L28R 65 versus 34. Their MD explanation: 4′-DTMP sits closer to atoms of the M20 loop and arginine 28. What we asked: the specified protein–ligand atom distances, one trajectory per condition, 990 frames. The figure: left is the frozen table, built from stored coordinates; a whole cluster of frames sits at fifty to ninety ångström. That is not a conformation; the ligand copy in a neighbouring periodic image was measured. Both Agent answers used these numbers; one called the tail conformational switching. Right is the corrected table, nearest periodic ligand image, cross-checked with VMD to ten to the minus five. M20 nitrogen to ligand O3P goes from 8.7 to 4.6 in wild type and 10.4 to 4.8 in L28R when TMP becomes 4′-DTMP; all six specified pairs move the same way as the paper's Figure 4. Gap: the paper frames hydrogen bonds; we have mean distances, no angles, one run each. Lesson: no rule text catches an input artifact. The check must sit at step 2, in code, before freezing. This was a preparation defect on my side.</a:t>
+              <a:t>SAY: What the paper is. Trimethoprim loses potency against the L28R mutant of DHFR; the analog 4′-DTMP recovers it. Their Table 1 inhibition constants: wild type 4.2 versus 5.1 nanomolar, L28R 65 versus 34. Their MD explanation: 4′-DTMP sits closer to atoms of the M20 loop and arginine 28. What we asked: the specified protein–ligand atom distances, one trajectory per condition, 990 frames. The figure: left is the frozen table, built from stored coordinates; a whole cluster of frames sits between 46 and 94 ångström. That is not a conformation; the ligand copy in a neighbouring periodic image was measured. Both Agent answers used these numbers; one called the tail conformational switching. Right is the corrected table, nearest periodic ligand image, cross-checked with VMD to ten to the minus five. M20 nitrogen to ligand O3P goes from 8.7 to 4.6 in wild type and 10.4 to 4.8 in L28R when TMP becomes 4′-DTMP; all six specified pairs move the same way as the paper's Figure 4. Gap: the paper frames hydrogen bonds; we have mean distances, no angles, one run each. Lesson: no rule text catches an input artifact. The check must sit at step 2, in code, before freezing. This was a preparation defect on my side.</a:t>
             </a:r>
             <a:endParaRPr lang="en-US" dirty="0"/>
           </a:p>
@@ -2739,7 +2829,7 @@
           <a:p>
             <a:r>
               <a:rPr lang="en-US" dirty="0"/>
-              <a:t>SAY: What the paper is. Photorelease of ATP, time-resolved X-ray solution scattering, a transient of about 4.3 milliseconds, interpreted with MD-derived candidate structures. The deposited MD: two trajectories, open-start 450 nanoseconds and closed-start 335, and no ATP or AMP in the coordinates. What we asked, the one thing computable: mean C-alpha distances between the LID or NMP domain and the CORE, comparing the first and last ten percent of frames, the shaded windows. All four changes are positive, the distributions overlap, and neither run shows both domains closing together. Gap: no ligand, no scattering recomputed, nanoseconds against milliseconds; this does not test the paper's mechanism. The system lesson concerns my own rule. After DHFR I wrote a data check: any distance above half the box length fails. Open ADK spans 56 ångström along one axis in a 98 to 100 ångström box, so C-alpha distances of 62 and 70 ångström are real, and GROMACS reproduces them. The rule was replaced by a physical criterion. Framing also helped here: the split version of the ADK question scored five of five.
+              <a:t>SAY: What the paper is. Photorelease of ATP, time-resolved X-ray solution scattering, a transient of about 4.3 milliseconds, interpreted with MD-derived candidate structures. The deposited MD: two trajectories, open-start 450 nanoseconds and closed-start 335, and no ATP or AMP in the coordinates. What we asked, the one thing computable: mean C-alpha distances between the LID or NMP domain and the CORE, comparing the first and last ten percent of frames, the shaded windows. All four changes are positive and the distributions overlap, so there is no net joint closure between the endpoint windows; this does not exclude closure episodes inside the runs. Gap: no ligand, no scattering recomputed, nanoseconds against milliseconds; this does not test the paper's mechanism. The system lesson concerns my own rule. After DHFR I wrote a data check: any distance above half the box length fails. Open ADK spans 56 ångström along one axis in a 98 to 100 ångström box, so C-alpha distances of 62 and 70 ångström are real, and GROMACS reproduces them. The rule was replaced by a physical criterion. DHFR asked a protein–ligand contact, so the nearest ligand image is right there; ADK asks a distance inside one protein, so the molecule must stay whole. The check has to follow the observable. Framing also helped here: the split version of the ADK question scored five of five.
 GRILL "why keep ADK": only system the rules and the selector had never seen; and the one you named.</a:t>
             </a:r>
             <a:endParaRPr lang="en-US" dirty="0"/>
@@ -3351,7 +3441,7 @@
                 <a:ea typeface="Arial" pitchFamily="34" charset="-122"/>
                 <a:cs typeface="Arial" pitchFamily="34" charset="-120"/>
               </a:rPr>
-              <a:t>Looking back at every answer so far: 13 error observations, none preventable by reminder text; they sit at data entry and at the numbers going out</a:t>
+              <a:t>Looking back at every answer so far: most of the 13 error observations sit at data entry or in the reported numbers, where reminder text had no obvious hook</a:t>
             </a:r>
             <a:endParaRPr lang="en-US" sz="1900" dirty="0"/>
           </a:p>
@@ -5051,6 +5141,45 @@
           </a:graphicData>
         </a:graphic>
       </p:graphicFrame>
+      <p:sp>
+        <p:nvSpPr>
+          <p:cNvPr id="7" name="Text 3"/>
+          <p:cNvSpPr/>
+          <p:nvPr/>
+        </p:nvSpPr>
+        <p:spPr>
+          <a:xfrm>
+            <a:off x="457200" y="4069080"/>
+            <a:ext cx="8229600" cy="457200"/>
+          </a:xfrm>
+          <a:prstGeom prst="rect">
+            <a:avLst/>
+          </a:prstGeom>
+          <a:noFill/>
+          <a:ln/>
+        </p:spPr>
+        <p:txBody>
+          <a:bodyPr wrap="square" rtlCol="0" anchor="ctr"/>
+          <a:lstStyle/>
+          <a:p>
+            <a:pPr indent="0" marL="0">
+              <a:buNone/>
+            </a:pPr>
+            <a:r>
+              <a:rPr lang="en-US" sz="1100" dirty="0">
+                <a:solidFill>
+                  <a:srgbClr val="777777"/>
+                </a:solidFill>
+                <a:latin typeface="Arial" pitchFamily="34" charset="0"/>
+                <a:ea typeface="Arial" pitchFamily="34" charset="-122"/>
+                <a:cs typeface="Arial" pitchFamily="34" charset="-120"/>
+              </a:rPr>
+              <a:t>Retrospective and not a random sample: the attributions are candidates without paired counterfactuals, which is why each use was then tested separately.</a:t>
+            </a:r>
+            <a:endParaRPr lang="en-US" sz="1100" dirty="0"/>
+          </a:p>
+        </p:txBody>
+      </p:sp>
     </p:spTree>
   </p:cSld>
   <p:clrMapOvr>
@@ -6196,7 +6325,7 @@
                 <a:ea typeface="Arial" pitchFamily="34" charset="-122"/>
                 <a:cs typeface="Arial" pitchFamily="34" charset="-120"/>
               </a:rPr>
-              <a:t>RULES_TABLE_ROLE_DESIGN_ZH.md §2; assignment by rule_class: 6 / 10 / 11 / 6 (appendix A2)</a:t>
+              <a:t>RULES_TABLE_ROLE_DESIGN_ZH.md §2; assignment by rule_class 6 / 10 / 11 / 6 (A2). The split is our design hypothesis; the uses overlap.</a:t>
             </a:r>
             <a:endParaRPr lang="en-US" sz="1000" dirty="0"/>
           </a:p>
@@ -11115,7 +11244,7 @@
                           <a:ea typeface="Arial" pitchFamily="34" charset="-122"/>
                           <a:cs typeface="Arial" pitchFamily="34" charset="-120"/>
                         </a:rPr>
-                        <a:t>1/3 questions improved (ADK), already better in initial drafts; 0/12 revisions reduced errors; 3 lost content; 0/9 warnings hit a real error</a:t>
+                        <a:t>1/3 questions improved (ADK), already better in initial drafts; 0/12 revisions reduced errors; 3 lost content (one had no warning); 0/9 warnings hit a real error</a:t>
                       </a:r>
                       <a:endParaRPr lang="en-US" sz="1100" dirty="0">
                         <a:latin typeface="Arial" charset="0"/>
@@ -14581,7 +14710,7 @@
                           <a:ea typeface="Arial" pitchFamily="34" charset="-122"/>
                           <a:cs typeface="Arial" pitchFamily="34" charset="-120"/>
                         </a:rPr>
-                        <a:t>10/20 direction; 9/10 far from both references at 1 Å; no populations</a:t>
+                        <a:t>10/20 direction; 9/10 relative only at 1 Å; no populations</a:t>
                       </a:r>
                       <a:endParaRPr lang="en-US" sz="1050" dirty="0">
                         <a:latin typeface="Arial" charset="0"/>
@@ -15835,7 +15964,7 @@
         <p:spPr>
           <a:xfrm>
             <a:off x="457200" y="1188720"/>
-            <a:ext cx="8229600" cy="2103120"/>
+            <a:ext cx="8229600" cy="1874520"/>
           </a:xfrm>
           <a:prstGeom prst="rect">
             <a:avLst/>
@@ -15855,7 +15984,7 @@
               <a:buChar char="•"/>
             </a:pPr>
             <a:r>
-              <a:rPr lang="en-US" sz="1400" dirty="0">
+              <a:rPr lang="en-US" sz="1350" dirty="0">
                 <a:solidFill>
                   <a:srgbClr val="2D2D2D"/>
                 </a:solidFill>
@@ -15863,9 +15992,9 @@
                 <a:ea typeface="Arial" pitchFamily="34" charset="-122"/>
                 <a:cs typeface="Arial" pitchFamily="34" charset="-120"/>
               </a:rPr>
-              <a:t>Workflow (slide 3): intake → package → frame → run → check → report; the table can act at steps 2–5, and the evidence says step 2 (in code) and step 3 (by a person) are where it earns its place.</a:t>
+              <a:t>Workflow (slide 3): intake → package → frame → run → check → report; the table can act at steps 2–5. So far the evidence points to step 3 (framing, by a person) and to physical checks at step 2 (from the DHFR and ADK lessons, not from the card test).</a:t>
             </a:r>
-            <a:endParaRPr lang="en-US" sz="1400" dirty="0"/>
+            <a:endParaRPr lang="en-US" sz="1350" dirty="0"/>
           </a:p>
           <a:p>
             <a:pPr marL="342900" indent="-342900">
@@ -15876,7 +16005,7 @@
               <a:buChar char="•"/>
             </a:pPr>
             <a:r>
-              <a:rPr lang="en-US" sz="1400" dirty="0">
+              <a:rPr lang="en-US" sz="1350" dirty="0">
                 <a:solidFill>
                   <a:srgbClr val="2D2D2D"/>
                 </a:solidFill>
@@ -15886,7 +16015,7 @@
               </a:rPr>
               <a:t>Three systems: HSP90 gave a real cross-source result (direction ≠ arrival); DHFR and ADK are single-source MD descriptions that exposed two data-check defects, one of them in my own rule.</a:t>
             </a:r>
-            <a:endParaRPr lang="en-US" sz="1400" dirty="0"/>
+            <a:endParaRPr lang="en-US" sz="1350" dirty="0"/>
           </a:p>
           <a:p>
             <a:pPr marL="342900" indent="-342900">
@@ -15897,7 +16026,7 @@
               <a:buChar char="•"/>
             </a:pPr>
             <a:r>
-              <a:rPr lang="en-US" sz="1400" dirty="0">
+              <a:rPr lang="en-US" sz="1350" dirty="0">
                 <a:solidFill>
                   <a:srgbClr val="2D2D2D"/>
                 </a:solidFill>
@@ -15907,7 +16036,7 @@
               </a:rPr>
               <a:t>Four-use test, 74 runs: only explicit sub-questions met its criterion; card delivery, method-family retrieval and number matching each failed for an identified reason.</a:t>
             </a:r>
-            <a:endParaRPr lang="en-US" sz="1400" dirty="0"/>
+            <a:endParaRPr lang="en-US" sz="1350" dirty="0"/>
           </a:p>
         </p:txBody>
       </p:sp>
@@ -15919,8 +16048,8 @@
         </p:nvSpPr>
         <p:spPr>
           <a:xfrm>
-            <a:off x="457200" y="3337560"/>
-            <a:ext cx="8229600" cy="1188720"/>
+            <a:off x="457200" y="3108960"/>
+            <a:ext cx="8229600" cy="1536192"/>
           </a:xfrm>
           <a:prstGeom prst="rect">
             <a:avLst/>
@@ -15944,8 +16073,8 @@
         </p:nvSpPr>
         <p:spPr>
           <a:xfrm>
-            <a:off x="457200" y="3337560"/>
-            <a:ext cx="8229600" cy="1188720"/>
+            <a:off x="457200" y="3108960"/>
+            <a:ext cx="8229600" cy="1536192"/>
           </a:xfrm>
           <a:prstGeom prst="rect">
             <a:avLst/>
@@ -15961,7 +16090,7 @@
               <a:buNone/>
             </a:pPr>
             <a:r>
-              <a:rPr lang="en-US" sz="1250" dirty="0">
+              <a:rPr lang="en-US" sz="1200" dirty="0">
                 <a:solidFill>
                   <a:srgbClr val="2D2D2D"/>
                 </a:solidFill>
@@ -15971,14 +16100,14 @@
               </a:rPr>
               <a:t>Decisions for today</a:t>
             </a:r>
-            <a:endParaRPr lang="en-US" sz="1250" dirty="0"/>
+            <a:endParaRPr lang="en-US" sz="1200" dirty="0"/>
           </a:p>
           <a:p>
             <a:pPr indent="0" marL="0">
               <a:buNone/>
             </a:pPr>
             <a:r>
-              <a:rPr lang="en-US" sz="1250" dirty="0">
+              <a:rPr lang="en-US" sz="1200" dirty="0">
                 <a:solidFill>
                   <a:srgbClr val="2D2D2D"/>
                 </a:solidFill>
@@ -15988,14 +16117,14 @@
               </a:rPr>
               <a:t>1. Is the workflow on slide 3 reasonable? What would you reorder, cut or add?</a:t>
             </a:r>
-            <a:endParaRPr lang="en-US" sz="1250" dirty="0"/>
+            <a:endParaRPr lang="en-US" sz="1200" dirty="0"/>
           </a:p>
           <a:p>
             <a:pPr indent="0" marL="0">
               <a:buNone/>
             </a:pPr>
             <a:r>
-              <a:rPr lang="en-US" sz="1250" dirty="0">
+              <a:rPr lang="en-US" sz="1200" dirty="0">
                 <a:solidFill>
                   <a:srgbClr val="2D2D2D"/>
                 </a:solidFill>
@@ -16005,14 +16134,14 @@
               </a:rPr>
               <a:t>2. Which form of the table (slide 16): repair the four uses, rules for the protocol writer, or rules as operator configuration?</a:t>
             </a:r>
-            <a:endParaRPr lang="en-US" sz="1250" dirty="0"/>
+            <a:endParaRPr lang="en-US" sz="1200" dirty="0"/>
           </a:p>
           <a:p>
             <a:pPr indent="0" marL="0">
               <a:buNone/>
             </a:pPr>
             <a:r>
-              <a:rPr lang="en-US" sz="1250" dirty="0">
+              <a:rPr lang="en-US" sz="1200" dirty="0">
                 <a:solidFill>
                   <a:srgbClr val="2D2D2D"/>
                 </a:solidFill>
@@ -16020,9 +16149,26 @@
                 <a:ea typeface="Arial" pitchFamily="34" charset="-122"/>
                 <a:cs typeface="Arial" pitchFamily="34" charset="-120"/>
               </a:rPr>
-              <a:t>3. Are HSP90 / DHFR / ADK the right systems by the criterion on slide 4, and is there a fourth with MD plus a population-constraining experiment?</a:t>
+              <a:t>3. Are HSP90 / DHFR / ADK the right systems (criterion on slide 4), and is there a fourth with MD plus a population-constraining experiment?</a:t>
             </a:r>
-            <a:endParaRPr lang="en-US" sz="1250" dirty="0"/>
+            <a:endParaRPr lang="en-US" sz="1200" dirty="0"/>
+          </a:p>
+          <a:p>
+            <a:pPr indent="0" marL="0">
+              <a:buNone/>
+            </a:pPr>
+            <a:r>
+              <a:rPr lang="en-US" sz="1200" dirty="0">
+                <a:solidFill>
+                  <a:srgbClr val="2D2D2D"/>
+                </a:solidFill>
+                <a:latin typeface="Arial" pitchFamily="34" charset="0"/>
+                <a:ea typeface="Arial" pitchFamily="34" charset="-122"/>
+                <a:cs typeface="Arial" pitchFamily="34" charset="-120"/>
+              </a:rPr>
+              <a:t>4. Science: in HSP90, is 1 Å on mean NOE violation the right test for being at the open state?</a:t>
+            </a:r>
+            <a:endParaRPr lang="en-US" sz="1200" dirty="0"/>
           </a:p>
         </p:txBody>
       </p:sp>
@@ -18156,7 +18302,7 @@
                 <a:ea typeface="Arial" pitchFamily="34" charset="-122"/>
                 <a:cs typeface="Arial" pitchFamily="34" charset="-120"/>
               </a:rPr>
-              <a:t>A1 what the evidence can and cannot support · A2 all 33 rules by use · A3 scores per condition · A4 cost · A5 HSP90 example trajectories · A6 terms</a:t>
+              <a:t>A1 what the evidence can and cannot support · A2 all 33 rules by use · A3 scores per condition · A4 cost · A5 HSP90 example trajectories · A6 nanodisc cross-observable result · A7 terms</a:t>
             </a:r>
             <a:endParaRPr lang="en-US" sz="1300" dirty="0"/>
           </a:p>
@@ -18337,17 +18483,17 @@
                 <a:gridCol w="4114800"/>
                 <a:gridCol w="4114800"/>
               </a:tblGrid>
-              <a:tr h="502920">
-                <a:tc>
-                  <a:txBody>
-                    <a:bodyPr/>
-                    <a:lstStyle/>
-                    <a:p>
-                      <a:pPr indent="0" marL="0">
-                        <a:buNone/>
-                      </a:pPr>
-                      <a:r>
-                        <a:rPr lang="en-US" sz="1200" b="1" dirty="0">
+              <a:tr h="384048">
+                <a:tc>
+                  <a:txBody>
+                    <a:bodyPr/>
+                    <a:lstStyle/>
+                    <a:p>
+                      <a:pPr indent="0" marL="0">
+                        <a:buNone/>
+                      </a:pPr>
+                      <a:r>
+                        <a:rPr lang="en-US" sz="1100" b="1" dirty="0">
                           <a:solidFill>
                             <a:srgbClr val="FFFFFF"/>
                           </a:solidFill>
@@ -18357,7 +18503,7 @@
                         </a:rPr>
                         <a:t>Can say</a:t>
                       </a:r>
-                      <a:endParaRPr lang="en-US" sz="1200" dirty="0">
+                      <a:endParaRPr lang="en-US" sz="1100" dirty="0">
                         <a:latin typeface="Arial" charset="0"/>
                         <a:ea typeface="Arial" charset="0"/>
                         <a:cs typeface="Arial" charset="0"/>
@@ -18415,7 +18561,7 @@
                         <a:buNone/>
                       </a:pPr>
                       <a:r>
-                        <a:rPr lang="en-US" sz="1200" b="1" dirty="0">
+                        <a:rPr lang="en-US" sz="1100" b="1" dirty="0">
                           <a:solidFill>
                             <a:srgbClr val="FFFFFF"/>
                           </a:solidFill>
@@ -18425,7 +18571,7 @@
                         </a:rPr>
                         <a:t>Cannot say</a:t>
                       </a:r>
-                      <a:endParaRPr lang="en-US" sz="1200" dirty="0">
+                      <a:endParaRPr lang="en-US" sz="1100" dirty="0">
                         <a:latin typeface="Arial" charset="0"/>
                         <a:ea typeface="Arial" charset="0"/>
                         <a:cs typeface="Arial" charset="0"/>
@@ -18475,17 +18621,17 @@
                   </a:tcPr>
                 </a:tc>
               </a:tr>
-              <a:tr h="502920">
-                <a:tc>
-                  <a:txBody>
-                    <a:bodyPr/>
-                    <a:lstStyle/>
-                    <a:p>
-                      <a:pPr indent="0" marL="0">
-                        <a:buNone/>
-                      </a:pPr>
-                      <a:r>
-                        <a:rPr lang="en-US" sz="1200" dirty="0">
+              <a:tr h="384048">
+                <a:tc>
+                  <a:txBody>
+                    <a:bodyPr/>
+                    <a:lstStyle/>
+                    <a:p>
+                      <a:pPr indent="0" marL="0">
+                        <a:buNone/>
+                      </a:pPr>
+                      <a:r>
+                        <a:rPr lang="en-US" sz="1100" dirty="0">
                           <a:solidFill>
                             <a:srgbClr val="2D2D2D"/>
                           </a:solidFill>
@@ -18495,62 +18641,62 @@
                         </a:rPr>
                         <a:t>pasting rules into the prompt showed no gain on 2 questions and one concrete harm</a:t>
                       </a:r>
-                      <a:endParaRPr lang="en-US" sz="1200" dirty="0">
-                        <a:latin typeface="Arial" charset="0"/>
-                        <a:ea typeface="Arial" charset="0"/>
-                        <a:cs typeface="Arial" charset="0"/>
-                      </a:endParaRPr>
-                    </a:p>
-                  </a:txBody>
-                  <a:tcPr marL="91440" marR="91440" marT="45720" marB="45720" anchor="ctr">
-                    <a:lnL w="6350" cap="flat" cmpd="sng" algn="ctr">
-                      <a:solidFill>
-                        <a:srgbClr val="CCCCCC"/>
-                      </a:solidFill>
-                      <a:prstDash val="solid"/>
-                      <a:round/>
-                      <a:headEnd type="none" w="med" len="med"/>
-                      <a:tailEnd type="none" w="med" len="med"/>
-                    </a:lnL>
-                    <a:lnR w="6350" cap="flat" cmpd="sng" algn="ctr">
-                      <a:solidFill>
-                        <a:srgbClr val="CCCCCC"/>
-                      </a:solidFill>
-                      <a:prstDash val="solid"/>
-                      <a:round/>
-                      <a:headEnd type="none" w="med" len="med"/>
-                      <a:tailEnd type="none" w="med" len="med"/>
-                    </a:lnR>
-                    <a:lnT w="6350" cap="flat" cmpd="sng" algn="ctr">
-                      <a:solidFill>
-                        <a:srgbClr val="CCCCCC"/>
-                      </a:solidFill>
-                      <a:prstDash val="solid"/>
-                      <a:round/>
-                      <a:headEnd type="none" w="med" len="med"/>
-                      <a:tailEnd type="none" w="med" len="med"/>
-                    </a:lnT>
-                    <a:lnB w="6350" cap="flat" cmpd="sng" algn="ctr">
-                      <a:solidFill>
-                        <a:srgbClr val="CCCCCC"/>
-                      </a:solidFill>
-                      <a:prstDash val="solid"/>
-                      <a:round/>
-                      <a:headEnd type="none" w="med" len="med"/>
-                      <a:tailEnd type="none" w="med" len="med"/>
-                    </a:lnB>
-                  </a:tcPr>
-                </a:tc>
-                <a:tc>
-                  <a:txBody>
-                    <a:bodyPr/>
-                    <a:lstStyle/>
-                    <a:p>
-                      <a:pPr indent="0" marL="0">
-                        <a:buNone/>
-                      </a:pPr>
-                      <a:r>
-                        <a:rPr lang="en-US" sz="1200" dirty="0">
+                      <a:endParaRPr lang="en-US" sz="1100" dirty="0">
+                        <a:latin typeface="Arial" charset="0"/>
+                        <a:ea typeface="Arial" charset="0"/>
+                        <a:cs typeface="Arial" charset="0"/>
+                      </a:endParaRPr>
+                    </a:p>
+                  </a:txBody>
+                  <a:tcPr marL="91440" marR="91440" marT="45720" marB="45720" anchor="ctr">
+                    <a:lnL w="6350" cap="flat" cmpd="sng" algn="ctr">
+                      <a:solidFill>
+                        <a:srgbClr val="CCCCCC"/>
+                      </a:solidFill>
+                      <a:prstDash val="solid"/>
+                      <a:round/>
+                      <a:headEnd type="none" w="med" len="med"/>
+                      <a:tailEnd type="none" w="med" len="med"/>
+                    </a:lnL>
+                    <a:lnR w="6350" cap="flat" cmpd="sng" algn="ctr">
+                      <a:solidFill>
+                        <a:srgbClr val="CCCCCC"/>
+                      </a:solidFill>
+                      <a:prstDash val="solid"/>
+                      <a:round/>
+                      <a:headEnd type="none" w="med" len="med"/>
+                      <a:tailEnd type="none" w="med" len="med"/>
+                    </a:lnR>
+                    <a:lnT w="6350" cap="flat" cmpd="sng" algn="ctr">
+                      <a:solidFill>
+                        <a:srgbClr val="CCCCCC"/>
+                      </a:solidFill>
+                      <a:prstDash val="solid"/>
+                      <a:round/>
+                      <a:headEnd type="none" w="med" len="med"/>
+                      <a:tailEnd type="none" w="med" len="med"/>
+                    </a:lnT>
+                    <a:lnB w="6350" cap="flat" cmpd="sng" algn="ctr">
+                      <a:solidFill>
+                        <a:srgbClr val="CCCCCC"/>
+                      </a:solidFill>
+                      <a:prstDash val="solid"/>
+                      <a:round/>
+                      <a:headEnd type="none" w="med" len="med"/>
+                      <a:tailEnd type="none" w="med" len="med"/>
+                    </a:lnB>
+                  </a:tcPr>
+                </a:tc>
+                <a:tc>
+                  <a:txBody>
+                    <a:bodyPr/>
+                    <a:lstStyle/>
+                    <a:p>
+                      <a:pPr indent="0" marL="0">
+                        <a:buNone/>
+                      </a:pPr>
+                      <a:r>
+                        <a:rPr lang="en-US" sz="1100" dirty="0">
                           <a:solidFill>
                             <a:srgbClr val="2D2D2D"/>
                           </a:solidFill>
@@ -18560,7 +18706,7 @@
                         </a:rPr>
                         <a:t>that rules are useless in general</a:t>
                       </a:r>
-                      <a:endParaRPr lang="en-US" sz="1200" dirty="0">
+                      <a:endParaRPr lang="en-US" sz="1100" dirty="0">
                         <a:latin typeface="Arial" charset="0"/>
                         <a:ea typeface="Arial" charset="0"/>
                         <a:cs typeface="Arial" charset="0"/>
@@ -18607,17 +18753,17 @@
                   </a:tcPr>
                 </a:tc>
               </a:tr>
-              <a:tr h="502920">
-                <a:tc>
-                  <a:txBody>
-                    <a:bodyPr/>
-                    <a:lstStyle/>
-                    <a:p>
-                      <a:pPr indent="0" marL="0">
-                        <a:buNone/>
-                      </a:pPr>
-                      <a:r>
-                        <a:rPr lang="en-US" sz="1200" dirty="0">
+              <a:tr h="384048">
+                <a:tc>
+                  <a:txBody>
+                    <a:bodyPr/>
+                    <a:lstStyle/>
+                    <a:p>
+                      <a:pPr indent="0" marL="0">
+                        <a:buNone/>
+                      </a:pPr>
+                      <a:r>
+                        <a:rPr lang="en-US" sz="1100" dirty="0">
                           <a:solidFill>
                             <a:srgbClr val="2D2D2D"/>
                           </a:solidFill>
@@ -18627,62 +18773,62 @@
                         </a:rPr>
                         <a:t>explicit sub-questions raised coverage on 2/2 questions without new overclaims</a:t>
                       </a:r>
-                      <a:endParaRPr lang="en-US" sz="1200" dirty="0">
-                        <a:latin typeface="Arial" charset="0"/>
-                        <a:ea typeface="Arial" charset="0"/>
-                        <a:cs typeface="Arial" charset="0"/>
-                      </a:endParaRPr>
-                    </a:p>
-                  </a:txBody>
-                  <a:tcPr marL="91440" marR="91440" marT="45720" marB="45720" anchor="ctr">
-                    <a:lnL w="6350" cap="flat" cmpd="sng" algn="ctr">
-                      <a:solidFill>
-                        <a:srgbClr val="CCCCCC"/>
-                      </a:solidFill>
-                      <a:prstDash val="solid"/>
-                      <a:round/>
-                      <a:headEnd type="none" w="med" len="med"/>
-                      <a:tailEnd type="none" w="med" len="med"/>
-                    </a:lnL>
-                    <a:lnR w="6350" cap="flat" cmpd="sng" algn="ctr">
-                      <a:solidFill>
-                        <a:srgbClr val="CCCCCC"/>
-                      </a:solidFill>
-                      <a:prstDash val="solid"/>
-                      <a:round/>
-                      <a:headEnd type="none" w="med" len="med"/>
-                      <a:tailEnd type="none" w="med" len="med"/>
-                    </a:lnR>
-                    <a:lnT w="6350" cap="flat" cmpd="sng" algn="ctr">
-                      <a:solidFill>
-                        <a:srgbClr val="CCCCCC"/>
-                      </a:solidFill>
-                      <a:prstDash val="solid"/>
-                      <a:round/>
-                      <a:headEnd type="none" w="med" len="med"/>
-                      <a:tailEnd type="none" w="med" len="med"/>
-                    </a:lnT>
-                    <a:lnB w="6350" cap="flat" cmpd="sng" algn="ctr">
-                      <a:solidFill>
-                        <a:srgbClr val="CCCCCC"/>
-                      </a:solidFill>
-                      <a:prstDash val="solid"/>
-                      <a:round/>
-                      <a:headEnd type="none" w="med" len="med"/>
-                      <a:tailEnd type="none" w="med" len="med"/>
-                    </a:lnB>
-                  </a:tcPr>
-                </a:tc>
-                <a:tc>
-                  <a:txBody>
-                    <a:bodyPr/>
-                    <a:lstStyle/>
-                    <a:p>
-                      <a:pPr indent="0" marL="0">
-                        <a:buNone/>
-                      </a:pPr>
-                      <a:r>
-                        <a:rPr lang="en-US" sz="1200" dirty="0">
+                      <a:endParaRPr lang="en-US" sz="1100" dirty="0">
+                        <a:latin typeface="Arial" charset="0"/>
+                        <a:ea typeface="Arial" charset="0"/>
+                        <a:cs typeface="Arial" charset="0"/>
+                      </a:endParaRPr>
+                    </a:p>
+                  </a:txBody>
+                  <a:tcPr marL="91440" marR="91440" marT="45720" marB="45720" anchor="ctr">
+                    <a:lnL w="6350" cap="flat" cmpd="sng" algn="ctr">
+                      <a:solidFill>
+                        <a:srgbClr val="CCCCCC"/>
+                      </a:solidFill>
+                      <a:prstDash val="solid"/>
+                      <a:round/>
+                      <a:headEnd type="none" w="med" len="med"/>
+                      <a:tailEnd type="none" w="med" len="med"/>
+                    </a:lnL>
+                    <a:lnR w="6350" cap="flat" cmpd="sng" algn="ctr">
+                      <a:solidFill>
+                        <a:srgbClr val="CCCCCC"/>
+                      </a:solidFill>
+                      <a:prstDash val="solid"/>
+                      <a:round/>
+                      <a:headEnd type="none" w="med" len="med"/>
+                      <a:tailEnd type="none" w="med" len="med"/>
+                    </a:lnR>
+                    <a:lnT w="6350" cap="flat" cmpd="sng" algn="ctr">
+                      <a:solidFill>
+                        <a:srgbClr val="CCCCCC"/>
+                      </a:solidFill>
+                      <a:prstDash val="solid"/>
+                      <a:round/>
+                      <a:headEnd type="none" w="med" len="med"/>
+                      <a:tailEnd type="none" w="med" len="med"/>
+                    </a:lnT>
+                    <a:lnB w="6350" cap="flat" cmpd="sng" algn="ctr">
+                      <a:solidFill>
+                        <a:srgbClr val="CCCCCC"/>
+                      </a:solidFill>
+                      <a:prstDash val="solid"/>
+                      <a:round/>
+                      <a:headEnd type="none" w="med" len="med"/>
+                      <a:tailEnd type="none" w="med" len="med"/>
+                    </a:lnB>
+                  </a:tcPr>
+                </a:tc>
+                <a:tc>
+                  <a:txBody>
+                    <a:bodyPr/>
+                    <a:lstStyle/>
+                    <a:p>
+                      <a:pPr indent="0" marL="0">
+                        <a:buNone/>
+                      </a:pPr>
+                      <a:r>
+                        <a:rPr lang="en-US" sz="1100" dirty="0">
                           <a:solidFill>
                             <a:srgbClr val="2D2D2D"/>
                           </a:solidFill>
@@ -18692,7 +18838,7 @@
                         </a:rPr>
                         <a:t>that the Agent discovers sub-questions on its own</a:t>
                       </a:r>
-                      <a:endParaRPr lang="en-US" sz="1200" dirty="0">
+                      <a:endParaRPr lang="en-US" sz="1100" dirty="0">
                         <a:latin typeface="Arial" charset="0"/>
                         <a:ea typeface="Arial" charset="0"/>
                         <a:cs typeface="Arial" charset="0"/>
@@ -18739,17 +18885,17 @@
                   </a:tcPr>
                 </a:tc>
               </a:tr>
-              <a:tr h="502920">
-                <a:tc>
-                  <a:txBody>
-                    <a:bodyPr/>
-                    <a:lstStyle/>
-                    <a:p>
-                      <a:pPr indent="0" marL="0">
-                        <a:buNone/>
-                      </a:pPr>
-                      <a:r>
-                        <a:rPr lang="en-US" sz="1200" dirty="0">
+              <a:tr h="384048">
+                <a:tc>
+                  <a:txBody>
+                    <a:bodyPr/>
+                    <a:lstStyle/>
+                    <a:p>
+                      <a:pPr indent="0" marL="0">
+                        <a:buNone/>
+                      </a:pPr>
+                      <a:r>
+                        <a:rPr lang="en-US" sz="1100" dirty="0">
                           <a:solidFill>
                             <a:srgbClr val="2D2D2D"/>
                           </a:solidFill>
@@ -18759,62 +18905,62 @@
                         </a:rPr>
                         <a:t>the current checker and card retrieval did not meet pre-set criteria; mechanisms identified</a:t>
                       </a:r>
-                      <a:endParaRPr lang="en-US" sz="1200" dirty="0">
-                        <a:latin typeface="Arial" charset="0"/>
-                        <a:ea typeface="Arial" charset="0"/>
-                        <a:cs typeface="Arial" charset="0"/>
-                      </a:endParaRPr>
-                    </a:p>
-                  </a:txBody>
-                  <a:tcPr marL="91440" marR="91440" marT="45720" marB="45720" anchor="ctr">
-                    <a:lnL w="6350" cap="flat" cmpd="sng" algn="ctr">
-                      <a:solidFill>
-                        <a:srgbClr val="CCCCCC"/>
-                      </a:solidFill>
-                      <a:prstDash val="solid"/>
-                      <a:round/>
-                      <a:headEnd type="none" w="med" len="med"/>
-                      <a:tailEnd type="none" w="med" len="med"/>
-                    </a:lnL>
-                    <a:lnR w="6350" cap="flat" cmpd="sng" algn="ctr">
-                      <a:solidFill>
-                        <a:srgbClr val="CCCCCC"/>
-                      </a:solidFill>
-                      <a:prstDash val="solid"/>
-                      <a:round/>
-                      <a:headEnd type="none" w="med" len="med"/>
-                      <a:tailEnd type="none" w="med" len="med"/>
-                    </a:lnR>
-                    <a:lnT w="6350" cap="flat" cmpd="sng" algn="ctr">
-                      <a:solidFill>
-                        <a:srgbClr val="CCCCCC"/>
-                      </a:solidFill>
-                      <a:prstDash val="solid"/>
-                      <a:round/>
-                      <a:headEnd type="none" w="med" len="med"/>
-                      <a:tailEnd type="none" w="med" len="med"/>
-                    </a:lnT>
-                    <a:lnB w="6350" cap="flat" cmpd="sng" algn="ctr">
-                      <a:solidFill>
-                        <a:srgbClr val="CCCCCC"/>
-                      </a:solidFill>
-                      <a:prstDash val="solid"/>
-                      <a:round/>
-                      <a:headEnd type="none" w="med" len="med"/>
-                      <a:tailEnd type="none" w="med" len="med"/>
-                    </a:lnB>
-                  </a:tcPr>
-                </a:tc>
-                <a:tc>
-                  <a:txBody>
-                    <a:bodyPr/>
-                    <a:lstStyle/>
-                    <a:p>
-                      <a:pPr indent="0" marL="0">
-                        <a:buNone/>
-                      </a:pPr>
-                      <a:r>
-                        <a:rPr lang="en-US" sz="1200" dirty="0">
+                      <a:endParaRPr lang="en-US" sz="1100" dirty="0">
+                        <a:latin typeface="Arial" charset="0"/>
+                        <a:ea typeface="Arial" charset="0"/>
+                        <a:cs typeface="Arial" charset="0"/>
+                      </a:endParaRPr>
+                    </a:p>
+                  </a:txBody>
+                  <a:tcPr marL="91440" marR="91440" marT="45720" marB="45720" anchor="ctr">
+                    <a:lnL w="6350" cap="flat" cmpd="sng" algn="ctr">
+                      <a:solidFill>
+                        <a:srgbClr val="CCCCCC"/>
+                      </a:solidFill>
+                      <a:prstDash val="solid"/>
+                      <a:round/>
+                      <a:headEnd type="none" w="med" len="med"/>
+                      <a:tailEnd type="none" w="med" len="med"/>
+                    </a:lnL>
+                    <a:lnR w="6350" cap="flat" cmpd="sng" algn="ctr">
+                      <a:solidFill>
+                        <a:srgbClr val="CCCCCC"/>
+                      </a:solidFill>
+                      <a:prstDash val="solid"/>
+                      <a:round/>
+                      <a:headEnd type="none" w="med" len="med"/>
+                      <a:tailEnd type="none" w="med" len="med"/>
+                    </a:lnR>
+                    <a:lnT w="6350" cap="flat" cmpd="sng" algn="ctr">
+                      <a:solidFill>
+                        <a:srgbClr val="CCCCCC"/>
+                      </a:solidFill>
+                      <a:prstDash val="solid"/>
+                      <a:round/>
+                      <a:headEnd type="none" w="med" len="med"/>
+                      <a:tailEnd type="none" w="med" len="med"/>
+                    </a:lnT>
+                    <a:lnB w="6350" cap="flat" cmpd="sng" algn="ctr">
+                      <a:solidFill>
+                        <a:srgbClr val="CCCCCC"/>
+                      </a:solidFill>
+                      <a:prstDash val="solid"/>
+                      <a:round/>
+                      <a:headEnd type="none" w="med" len="med"/>
+                      <a:tailEnd type="none" w="med" len="med"/>
+                    </a:lnB>
+                  </a:tcPr>
+                </a:tc>
+                <a:tc>
+                  <a:txBody>
+                    <a:bodyPr/>
+                    <a:lstStyle/>
+                    <a:p>
+                      <a:pPr indent="0" marL="0">
+                        <a:buNone/>
+                      </a:pPr>
+                      <a:r>
+                        <a:rPr lang="en-US" sz="1100" dirty="0">
                           <a:solidFill>
                             <a:srgbClr val="2D2D2D"/>
                           </a:solidFill>
@@ -18824,7 +18970,7 @@
                         </a:rPr>
                         <a:t>a population-level correctness rate for any condition</a:t>
                       </a:r>
-                      <a:endParaRPr lang="en-US" sz="1200" dirty="0">
+                      <a:endParaRPr lang="en-US" sz="1100" dirty="0">
                         <a:latin typeface="Arial" charset="0"/>
                         <a:ea typeface="Arial" charset="0"/>
                         <a:cs typeface="Arial" charset="0"/>
@@ -18871,17 +19017,17 @@
                   </a:tcPr>
                 </a:tc>
               </a:tr>
-              <a:tr h="502920">
-                <a:tc>
-                  <a:txBody>
-                    <a:bodyPr/>
-                    <a:lstStyle/>
-                    <a:p>
-                      <a:pPr indent="0" marL="0">
-                        <a:buNone/>
-                      </a:pPr>
-                      <a:r>
-                        <a:rPr lang="en-US" sz="1200" dirty="0">
+              <a:tr h="384048">
+                <a:tc>
+                  <a:txBody>
+                    <a:bodyPr/>
+                    <a:lstStyle/>
+                    <a:p>
+                      <a:pPr indent="0" marL="0">
+                        <a:buNone/>
+                      </a:pPr>
+                      <a:r>
+                        <a:rPr lang="en-US" sz="1100" dirty="0">
                           <a:solidFill>
                             <a:srgbClr val="2D2D2D"/>
                           </a:solidFill>
@@ -18891,62 +19037,62 @@
                         </a:rPr>
                         <a:t>HSP90: leaving closed ≠ reaching open, at three tolerances</a:t>
                       </a:r>
-                      <a:endParaRPr lang="en-US" sz="1200" dirty="0">
-                        <a:latin typeface="Arial" charset="0"/>
-                        <a:ea typeface="Arial" charset="0"/>
-                        <a:cs typeface="Arial" charset="0"/>
-                      </a:endParaRPr>
-                    </a:p>
-                  </a:txBody>
-                  <a:tcPr marL="91440" marR="91440" marT="45720" marB="45720" anchor="ctr">
-                    <a:lnL w="6350" cap="flat" cmpd="sng" algn="ctr">
-                      <a:solidFill>
-                        <a:srgbClr val="CCCCCC"/>
-                      </a:solidFill>
-                      <a:prstDash val="solid"/>
-                      <a:round/>
-                      <a:headEnd type="none" w="med" len="med"/>
-                      <a:tailEnd type="none" w="med" len="med"/>
-                    </a:lnL>
-                    <a:lnR w="6350" cap="flat" cmpd="sng" algn="ctr">
-                      <a:solidFill>
-                        <a:srgbClr val="CCCCCC"/>
-                      </a:solidFill>
-                      <a:prstDash val="solid"/>
-                      <a:round/>
-                      <a:headEnd type="none" w="med" len="med"/>
-                      <a:tailEnd type="none" w="med" len="med"/>
-                    </a:lnR>
-                    <a:lnT w="6350" cap="flat" cmpd="sng" algn="ctr">
-                      <a:solidFill>
-                        <a:srgbClr val="CCCCCC"/>
-                      </a:solidFill>
-                      <a:prstDash val="solid"/>
-                      <a:round/>
-                      <a:headEnd type="none" w="med" len="med"/>
-                      <a:tailEnd type="none" w="med" len="med"/>
-                    </a:lnT>
-                    <a:lnB w="6350" cap="flat" cmpd="sng" algn="ctr">
-                      <a:solidFill>
-                        <a:srgbClr val="CCCCCC"/>
-                      </a:solidFill>
-                      <a:prstDash val="solid"/>
-                      <a:round/>
-                      <a:headEnd type="none" w="med" len="med"/>
-                      <a:tailEnd type="none" w="med" len="med"/>
-                    </a:lnB>
-                  </a:tcPr>
-                </a:tc>
-                <a:tc>
-                  <a:txBody>
-                    <a:bodyPr/>
-                    <a:lstStyle/>
-                    <a:p>
-                      <a:pPr indent="0" marL="0">
-                        <a:buNone/>
-                      </a:pPr>
-                      <a:r>
-                        <a:rPr lang="en-US" sz="1200" dirty="0">
+                      <a:endParaRPr lang="en-US" sz="1100" dirty="0">
+                        <a:latin typeface="Arial" charset="0"/>
+                        <a:ea typeface="Arial" charset="0"/>
+                        <a:cs typeface="Arial" charset="0"/>
+                      </a:endParaRPr>
+                    </a:p>
+                  </a:txBody>
+                  <a:tcPr marL="91440" marR="91440" marT="45720" marB="45720" anchor="ctr">
+                    <a:lnL w="6350" cap="flat" cmpd="sng" algn="ctr">
+                      <a:solidFill>
+                        <a:srgbClr val="CCCCCC"/>
+                      </a:solidFill>
+                      <a:prstDash val="solid"/>
+                      <a:round/>
+                      <a:headEnd type="none" w="med" len="med"/>
+                      <a:tailEnd type="none" w="med" len="med"/>
+                    </a:lnL>
+                    <a:lnR w="6350" cap="flat" cmpd="sng" algn="ctr">
+                      <a:solidFill>
+                        <a:srgbClr val="CCCCCC"/>
+                      </a:solidFill>
+                      <a:prstDash val="solid"/>
+                      <a:round/>
+                      <a:headEnd type="none" w="med" len="med"/>
+                      <a:tailEnd type="none" w="med" len="med"/>
+                    </a:lnR>
+                    <a:lnT w="6350" cap="flat" cmpd="sng" algn="ctr">
+                      <a:solidFill>
+                        <a:srgbClr val="CCCCCC"/>
+                      </a:solidFill>
+                      <a:prstDash val="solid"/>
+                      <a:round/>
+                      <a:headEnd type="none" w="med" len="med"/>
+                      <a:tailEnd type="none" w="med" len="med"/>
+                    </a:lnT>
+                    <a:lnB w="6350" cap="flat" cmpd="sng" algn="ctr">
+                      <a:solidFill>
+                        <a:srgbClr val="CCCCCC"/>
+                      </a:solidFill>
+                      <a:prstDash val="solid"/>
+                      <a:round/>
+                      <a:headEnd type="none" w="med" len="med"/>
+                      <a:tailEnd type="none" w="med" len="med"/>
+                    </a:lnB>
+                  </a:tcPr>
+                </a:tc>
+                <a:tc>
+                  <a:txBody>
+                    <a:bodyPr/>
+                    <a:lstStyle/>
+                    <a:p>
+                      <a:pPr indent="0" marL="0">
+                        <a:buNone/>
+                      </a:pPr>
+                      <a:r>
+                        <a:rPr lang="en-US" sz="1100" dirty="0">
                           <a:solidFill>
                             <a:srgbClr val="2D2D2D"/>
                           </a:solidFill>
@@ -18956,7 +19102,7 @@
                         </a:rPr>
                         <a:t>populations or rates for HSP90; H-bonds or mechanism for DHFR; anything about ADK's ATP response</a:t>
                       </a:r>
-                      <a:endParaRPr lang="en-US" sz="1200" dirty="0">
+                      <a:endParaRPr lang="en-US" sz="1100" dirty="0">
                         <a:latin typeface="Arial" charset="0"/>
                         <a:ea typeface="Arial" charset="0"/>
                         <a:cs typeface="Arial" charset="0"/>
@@ -19003,17 +19149,17 @@
                   </a:tcPr>
                 </a:tc>
               </a:tr>
-              <a:tr h="502920">
-                <a:tc>
-                  <a:txBody>
-                    <a:bodyPr/>
-                    <a:lstStyle/>
-                    <a:p>
-                      <a:pPr indent="0" marL="0">
-                        <a:buNone/>
-                      </a:pPr>
-                      <a:r>
-                        <a:rPr lang="en-US" sz="1200" dirty="0">
+              <a:tr h="384048">
+                <a:tc>
+                  <a:txBody>
+                    <a:bodyPr/>
+                    <a:lstStyle/>
+                    <a:p>
+                      <a:pPr indent="0" marL="0">
+                        <a:buNone/>
+                      </a:pPr>
+                      <a:r>
+                        <a:rPr lang="en-US" sz="1100" dirty="0">
                           <a:solidFill>
                             <a:srgbClr val="2D2D2D"/>
                           </a:solidFill>
@@ -19021,64 +19167,328 @@
                           <a:ea typeface="Arial" pitchFamily="34" charset="-122"/>
                           <a:cs typeface="Arial" pitchFamily="34" charset="-120"/>
                         </a:rPr>
+                        <a:t>most located errors sat at data entry or in reported numbers</a:t>
+                      </a:r>
+                      <a:endParaRPr lang="en-US" sz="1100" dirty="0">
+                        <a:latin typeface="Arial" charset="0"/>
+                        <a:ea typeface="Arial" charset="0"/>
+                        <a:cs typeface="Arial" charset="0"/>
+                      </a:endParaRPr>
+                    </a:p>
+                  </a:txBody>
+                  <a:tcPr marL="91440" marR="91440" marT="45720" marB="45720" anchor="ctr">
+                    <a:lnL w="6350" cap="flat" cmpd="sng" algn="ctr">
+                      <a:solidFill>
+                        <a:srgbClr val="CCCCCC"/>
+                      </a:solidFill>
+                      <a:prstDash val="solid"/>
+                      <a:round/>
+                      <a:headEnd type="none" w="med" len="med"/>
+                      <a:tailEnd type="none" w="med" len="med"/>
+                    </a:lnL>
+                    <a:lnR w="6350" cap="flat" cmpd="sng" algn="ctr">
+                      <a:solidFill>
+                        <a:srgbClr val="CCCCCC"/>
+                      </a:solidFill>
+                      <a:prstDash val="solid"/>
+                      <a:round/>
+                      <a:headEnd type="none" w="med" len="med"/>
+                      <a:tailEnd type="none" w="med" len="med"/>
+                    </a:lnR>
+                    <a:lnT w="6350" cap="flat" cmpd="sng" algn="ctr">
+                      <a:solidFill>
+                        <a:srgbClr val="CCCCCC"/>
+                      </a:solidFill>
+                      <a:prstDash val="solid"/>
+                      <a:round/>
+                      <a:headEnd type="none" w="med" len="med"/>
+                      <a:tailEnd type="none" w="med" len="med"/>
+                    </a:lnT>
+                    <a:lnB w="6350" cap="flat" cmpd="sng" algn="ctr">
+                      <a:solidFill>
+                        <a:srgbClr val="CCCCCC"/>
+                      </a:solidFill>
+                      <a:prstDash val="solid"/>
+                      <a:round/>
+                      <a:headEnd type="none" w="med" len="med"/>
+                      <a:tailEnd type="none" w="med" len="med"/>
+                    </a:lnB>
+                  </a:tcPr>
+                </a:tc>
+                <a:tc>
+                  <a:txBody>
+                    <a:bodyPr/>
+                    <a:lstStyle/>
+                    <a:p>
+                      <a:pPr indent="0" marL="0">
+                        <a:buNone/>
+                      </a:pPr>
+                      <a:r>
+                        <a:rPr lang="en-US" sz="1100" dirty="0">
+                          <a:solidFill>
+                            <a:srgbClr val="2D2D2D"/>
+                          </a:solidFill>
+                          <a:latin typeface="Arial" pitchFamily="34" charset="0"/>
+                          <a:ea typeface="Arial" pitchFamily="34" charset="-122"/>
+                          <a:cs typeface="Arial" pitchFamily="34" charset="-120"/>
+                        </a:rPr>
+                        <a:t>that this is the general distribution of errors (retrospective audit, not a random sample)</a:t>
+                      </a:r>
+                      <a:endParaRPr lang="en-US" sz="1100" dirty="0">
+                        <a:latin typeface="Arial" charset="0"/>
+                        <a:ea typeface="Arial" charset="0"/>
+                        <a:cs typeface="Arial" charset="0"/>
+                      </a:endParaRPr>
+                    </a:p>
+                  </a:txBody>
+                  <a:tcPr marL="91440" marR="91440" marT="45720" marB="45720" anchor="ctr">
+                    <a:lnL w="6350" cap="flat" cmpd="sng" algn="ctr">
+                      <a:solidFill>
+                        <a:srgbClr val="CCCCCC"/>
+                      </a:solidFill>
+                      <a:prstDash val="solid"/>
+                      <a:round/>
+                      <a:headEnd type="none" w="med" len="med"/>
+                      <a:tailEnd type="none" w="med" len="med"/>
+                    </a:lnL>
+                    <a:lnR w="6350" cap="flat" cmpd="sng" algn="ctr">
+                      <a:solidFill>
+                        <a:srgbClr val="CCCCCC"/>
+                      </a:solidFill>
+                      <a:prstDash val="solid"/>
+                      <a:round/>
+                      <a:headEnd type="none" w="med" len="med"/>
+                      <a:tailEnd type="none" w="med" len="med"/>
+                    </a:lnR>
+                    <a:lnT w="6350" cap="flat" cmpd="sng" algn="ctr">
+                      <a:solidFill>
+                        <a:srgbClr val="CCCCCC"/>
+                      </a:solidFill>
+                      <a:prstDash val="solid"/>
+                      <a:round/>
+                      <a:headEnd type="none" w="med" len="med"/>
+                      <a:tailEnd type="none" w="med" len="med"/>
+                    </a:lnT>
+                    <a:lnB w="6350" cap="flat" cmpd="sng" algn="ctr">
+                      <a:solidFill>
+                        <a:srgbClr val="CCCCCC"/>
+                      </a:solidFill>
+                      <a:prstDash val="solid"/>
+                      <a:round/>
+                      <a:headEnd type="none" w="med" len="med"/>
+                      <a:tailEnd type="none" w="med" len="med"/>
+                    </a:lnB>
+                  </a:tcPr>
+                </a:tc>
+              </a:tr>
+              <a:tr h="384048">
+                <a:tc>
+                  <a:txBody>
+                    <a:bodyPr/>
+                    <a:lstStyle/>
+                    <a:p>
+                      <a:pPr indent="0" marL="0">
+                        <a:buNone/>
+                      </a:pPr>
+                      <a:r>
+                        <a:rPr lang="en-US" sz="1100" dirty="0">
+                          <a:solidFill>
+                            <a:srgbClr val="2D2D2D"/>
+                          </a:solidFill>
+                          <a:latin typeface="Arial" pitchFamily="34" charset="0"/>
+                          <a:ea typeface="Arial" pitchFamily="34" charset="-122"/>
+                          <a:cs typeface="Arial" pitchFamily="34" charset="-120"/>
+                        </a:rPr>
+                        <a:t>scores measure delivery of pre-defined content</a:t>
+                      </a:r>
+                      <a:endParaRPr lang="en-US" sz="1100" dirty="0">
+                        <a:latin typeface="Arial" charset="0"/>
+                        <a:ea typeface="Arial" charset="0"/>
+                        <a:cs typeface="Arial" charset="0"/>
+                      </a:endParaRPr>
+                    </a:p>
+                  </a:txBody>
+                  <a:tcPr marL="91440" marR="91440" marT="45720" marB="45720" anchor="ctr">
+                    <a:lnL w="6350" cap="flat" cmpd="sng" algn="ctr">
+                      <a:solidFill>
+                        <a:srgbClr val="CCCCCC"/>
+                      </a:solidFill>
+                      <a:prstDash val="solid"/>
+                      <a:round/>
+                      <a:headEnd type="none" w="med" len="med"/>
+                      <a:tailEnd type="none" w="med" len="med"/>
+                    </a:lnL>
+                    <a:lnR w="6350" cap="flat" cmpd="sng" algn="ctr">
+                      <a:solidFill>
+                        <a:srgbClr val="CCCCCC"/>
+                      </a:solidFill>
+                      <a:prstDash val="solid"/>
+                      <a:round/>
+                      <a:headEnd type="none" w="med" len="med"/>
+                      <a:tailEnd type="none" w="med" len="med"/>
+                    </a:lnR>
+                    <a:lnT w="6350" cap="flat" cmpd="sng" algn="ctr">
+                      <a:solidFill>
+                        <a:srgbClr val="CCCCCC"/>
+                      </a:solidFill>
+                      <a:prstDash val="solid"/>
+                      <a:round/>
+                      <a:headEnd type="none" w="med" len="med"/>
+                      <a:tailEnd type="none" w="med" len="med"/>
+                    </a:lnT>
+                    <a:lnB w="6350" cap="flat" cmpd="sng" algn="ctr">
+                      <a:solidFill>
+                        <a:srgbClr val="CCCCCC"/>
+                      </a:solidFill>
+                      <a:prstDash val="solid"/>
+                      <a:round/>
+                      <a:headEnd type="none" w="med" len="med"/>
+                      <a:tailEnd type="none" w="med" len="med"/>
+                    </a:lnB>
+                  </a:tcPr>
+                </a:tc>
+                <a:tc>
+                  <a:txBody>
+                    <a:bodyPr/>
+                    <a:lstStyle/>
+                    <a:p>
+                      <a:pPr indent="0" marL="0">
+                        <a:buNone/>
+                      </a:pPr>
+                      <a:r>
+                        <a:rPr lang="en-US" sz="1100" dirty="0">
+                          <a:solidFill>
+                            <a:srgbClr val="2D2D2D"/>
+                          </a:solidFill>
+                          <a:latin typeface="Arial" pitchFamily="34" charset="0"/>
+                          <a:ea typeface="Arial" pitchFamily="34" charset="-122"/>
+                          <a:cs typeface="Arial" pitchFamily="34" charset="-120"/>
+                        </a:rPr>
+                        <a:t>that scores capture all scientific content (bundled units can drop partial credit)</a:t>
+                      </a:r>
+                      <a:endParaRPr lang="en-US" sz="1100" dirty="0">
+                        <a:latin typeface="Arial" charset="0"/>
+                        <a:ea typeface="Arial" charset="0"/>
+                        <a:cs typeface="Arial" charset="0"/>
+                      </a:endParaRPr>
+                    </a:p>
+                  </a:txBody>
+                  <a:tcPr marL="91440" marR="91440" marT="45720" marB="45720" anchor="ctr">
+                    <a:lnL w="6350" cap="flat" cmpd="sng" algn="ctr">
+                      <a:solidFill>
+                        <a:srgbClr val="CCCCCC"/>
+                      </a:solidFill>
+                      <a:prstDash val="solid"/>
+                      <a:round/>
+                      <a:headEnd type="none" w="med" len="med"/>
+                      <a:tailEnd type="none" w="med" len="med"/>
+                    </a:lnL>
+                    <a:lnR w="6350" cap="flat" cmpd="sng" algn="ctr">
+                      <a:solidFill>
+                        <a:srgbClr val="CCCCCC"/>
+                      </a:solidFill>
+                      <a:prstDash val="solid"/>
+                      <a:round/>
+                      <a:headEnd type="none" w="med" len="med"/>
+                      <a:tailEnd type="none" w="med" len="med"/>
+                    </a:lnR>
+                    <a:lnT w="6350" cap="flat" cmpd="sng" algn="ctr">
+                      <a:solidFill>
+                        <a:srgbClr val="CCCCCC"/>
+                      </a:solidFill>
+                      <a:prstDash val="solid"/>
+                      <a:round/>
+                      <a:headEnd type="none" w="med" len="med"/>
+                      <a:tailEnd type="none" w="med" len="med"/>
+                    </a:lnT>
+                    <a:lnB w="6350" cap="flat" cmpd="sng" algn="ctr">
+                      <a:solidFill>
+                        <a:srgbClr val="CCCCCC"/>
+                      </a:solidFill>
+                      <a:prstDash val="solid"/>
+                      <a:round/>
+                      <a:headEnd type="none" w="med" len="med"/>
+                      <a:tailEnd type="none" w="med" len="med"/>
+                    </a:lnB>
+                  </a:tcPr>
+                </a:tc>
+              </a:tr>
+              <a:tr h="384048">
+                <a:tc>
+                  <a:txBody>
+                    <a:bodyPr/>
+                    <a:lstStyle/>
+                    <a:p>
+                      <a:pPr indent="0" marL="0">
+                        <a:buNone/>
+                      </a:pPr>
+                      <a:r>
+                        <a:rPr lang="en-US" sz="1100" dirty="0">
+                          <a:solidFill>
+                            <a:srgbClr val="2D2D2D"/>
+                          </a:solidFill>
+                          <a:latin typeface="Arial" pitchFamily="34" charset="0"/>
+                          <a:ea typeface="Arial" pitchFamily="34" charset="-122"/>
+                          <a:cs typeface="Arial" pitchFamily="34" charset="-120"/>
+                        </a:rPr>
                         <a:t>74 runs, $1.20, all preserved with logs and sealed scores</a:t>
                       </a:r>
-                      <a:endParaRPr lang="en-US" sz="1200" dirty="0">
-                        <a:latin typeface="Arial" charset="0"/>
-                        <a:ea typeface="Arial" charset="0"/>
-                        <a:cs typeface="Arial" charset="0"/>
-                      </a:endParaRPr>
-                    </a:p>
-                  </a:txBody>
-                  <a:tcPr marL="91440" marR="91440" marT="45720" marB="45720" anchor="ctr">
-                    <a:lnL w="6350" cap="flat" cmpd="sng" algn="ctr">
-                      <a:solidFill>
-                        <a:srgbClr val="CCCCCC"/>
-                      </a:solidFill>
-                      <a:prstDash val="solid"/>
-                      <a:round/>
-                      <a:headEnd type="none" w="med" len="med"/>
-                      <a:tailEnd type="none" w="med" len="med"/>
-                    </a:lnL>
-                    <a:lnR w="6350" cap="flat" cmpd="sng" algn="ctr">
-                      <a:solidFill>
-                        <a:srgbClr val="CCCCCC"/>
-                      </a:solidFill>
-                      <a:prstDash val="solid"/>
-                      <a:round/>
-                      <a:headEnd type="none" w="med" len="med"/>
-                      <a:tailEnd type="none" w="med" len="med"/>
-                    </a:lnR>
-                    <a:lnT w="6350" cap="flat" cmpd="sng" algn="ctr">
-                      <a:solidFill>
-                        <a:srgbClr val="CCCCCC"/>
-                      </a:solidFill>
-                      <a:prstDash val="solid"/>
-                      <a:round/>
-                      <a:headEnd type="none" w="med" len="med"/>
-                      <a:tailEnd type="none" w="med" len="med"/>
-                    </a:lnT>
-                    <a:lnB w="6350" cap="flat" cmpd="sng" algn="ctr">
-                      <a:solidFill>
-                        <a:srgbClr val="CCCCCC"/>
-                      </a:solidFill>
-                      <a:prstDash val="solid"/>
-                      <a:round/>
-                      <a:headEnd type="none" w="med" len="med"/>
-                      <a:tailEnd type="none" w="med" len="med"/>
-                    </a:lnB>
-                  </a:tcPr>
-                </a:tc>
-                <a:tc>
-                  <a:txBody>
-                    <a:bodyPr/>
-                    <a:lstStyle/>
-                    <a:p>
-                      <a:pPr indent="0" marL="0">
-                        <a:buNone/>
-                      </a:pPr>
-                      <a:r>
-                        <a:rPr lang="en-US" sz="1200" dirty="0">
+                      <a:endParaRPr lang="en-US" sz="1100" dirty="0">
+                        <a:latin typeface="Arial" charset="0"/>
+                        <a:ea typeface="Arial" charset="0"/>
+                        <a:cs typeface="Arial" charset="0"/>
+                      </a:endParaRPr>
+                    </a:p>
+                  </a:txBody>
+                  <a:tcPr marL="91440" marR="91440" marT="45720" marB="45720" anchor="ctr">
+                    <a:lnL w="6350" cap="flat" cmpd="sng" algn="ctr">
+                      <a:solidFill>
+                        <a:srgbClr val="CCCCCC"/>
+                      </a:solidFill>
+                      <a:prstDash val="solid"/>
+                      <a:round/>
+                      <a:headEnd type="none" w="med" len="med"/>
+                      <a:tailEnd type="none" w="med" len="med"/>
+                    </a:lnL>
+                    <a:lnR w="6350" cap="flat" cmpd="sng" algn="ctr">
+                      <a:solidFill>
+                        <a:srgbClr val="CCCCCC"/>
+                      </a:solidFill>
+                      <a:prstDash val="solid"/>
+                      <a:round/>
+                      <a:headEnd type="none" w="med" len="med"/>
+                      <a:tailEnd type="none" w="med" len="med"/>
+                    </a:lnR>
+                    <a:lnT w="6350" cap="flat" cmpd="sng" algn="ctr">
+                      <a:solidFill>
+                        <a:srgbClr val="CCCCCC"/>
+                      </a:solidFill>
+                      <a:prstDash val="solid"/>
+                      <a:round/>
+                      <a:headEnd type="none" w="med" len="med"/>
+                      <a:tailEnd type="none" w="med" len="med"/>
+                    </a:lnT>
+                    <a:lnB w="6350" cap="flat" cmpd="sng" algn="ctr">
+                      <a:solidFill>
+                        <a:srgbClr val="CCCCCC"/>
+                      </a:solidFill>
+                      <a:prstDash val="solid"/>
+                      <a:round/>
+                      <a:headEnd type="none" w="med" len="med"/>
+                      <a:tailEnd type="none" w="med" len="med"/>
+                    </a:lnB>
+                  </a:tcPr>
+                </a:tc>
+                <a:tc>
+                  <a:txBody>
+                    <a:bodyPr/>
+                    <a:lstStyle/>
+                    <a:p>
+                      <a:pPr indent="0" marL="0">
+                        <a:buNone/>
+                      </a:pPr>
+                      <a:r>
+                        <a:rPr lang="en-US" sz="1100" dirty="0">
                           <a:solidFill>
                             <a:srgbClr val="2D2D2D"/>
                           </a:solidFill>
@@ -19088,7 +19498,7 @@
                         </a:rPr>
                         <a:t>that scoring was independent of case preparation; that human time was saved (not measured)</a:t>
                       </a:r>
-                      <a:endParaRPr lang="en-US" sz="1200" dirty="0">
+                      <a:endParaRPr lang="en-US" sz="1100" dirty="0">
                         <a:latin typeface="Arial" charset="0"/>
                         <a:ea typeface="Arial" charset="0"/>
                         <a:cs typeface="Arial" charset="0"/>
@@ -27622,7 +28032,7 @@
                 <a:ea typeface="Arial" pitchFamily="34" charset="-122"/>
                 <a:cs typeface="Arial" pitchFamily="34" charset="-120"/>
               </a:rPr>
-              <a:t>A6. Terms as used in this deck</a:t>
+              <a:t>A6. Nanodisc (development case): reweighting to fit SAXS improved the SAXS fit but not the agreement with either NOE set</a:t>
             </a:r>
             <a:endParaRPr lang="en-US" sz="2100" dirty="0"/>
           </a:p>
@@ -27631,6 +28041,45 @@
       <p:sp>
         <p:nvSpPr>
           <p:cNvPr id="3" name="Text 1"/>
+          <p:cNvSpPr/>
+          <p:nvPr/>
+        </p:nvSpPr>
+        <p:spPr>
+          <a:xfrm>
+            <a:off x="457200" y="4736592"/>
+            <a:ext cx="7680960" cy="274320"/>
+          </a:xfrm>
+          <a:prstGeom prst="rect">
+            <a:avLst/>
+          </a:prstGeom>
+          <a:noFill/>
+          <a:ln/>
+        </p:spPr>
+        <p:txBody>
+          <a:bodyPr wrap="square" rtlCol="0" anchor="ctr"/>
+          <a:lstStyle/>
+          <a:p>
+            <a:pPr indent="0" marL="0">
+              <a:buNone/>
+            </a:pPr>
+            <a:r>
+              <a:rPr lang="en-US" sz="1000" dirty="0">
+                <a:solidFill>
+                  <a:srgbClr val="777777"/>
+                </a:solidFill>
+                <a:latin typeface="Arial" pitchFamily="34" charset="0"/>
+                <a:ea typeface="Arial" pitchFamily="34" charset="-122"/>
+                <a:cs typeface="Arial" pitchFamily="34" charset="-120"/>
+              </a:rPr>
+              <a:t>Bengtsen et al. 2020 eLife; Q05 frozen analysis, main setting θ = 6; 90 SAXS points, 292 amide and 40 methyl NOE restraints; developer-designed, exposed during development</a:t>
+            </a:r>
+            <a:endParaRPr lang="en-US" sz="1000" dirty="0"/>
+          </a:p>
+        </p:txBody>
+      </p:sp>
+      <p:sp>
+        <p:nvSpPr>
+          <p:cNvPr id="4" name="Text 2"/>
           <p:cNvSpPr/>
           <p:nvPr/>
         </p:nvSpPr>
@@ -27670,6 +28119,1293 @@
       <p:graphicFrame>
         <p:nvGraphicFramePr>
           <p:cNvPr id="27" name="Table 0"/>
+          <p:cNvGraphicFramePr>
+            <a:graphicFrameLocks noGrp="1"/>
+          </p:cNvGraphicFramePr>
+          <p:nvPr>
+            <p:extLst>
+              <p:ext uri="{D42A27DB-BD31-4B8C-83A1-F6EECF244321}">
+                <p14:modId xmlns:p14="http://schemas.microsoft.com/office/powerpoint/2010/main" val="1579011935"/>
+              </p:ext>
+            </p:extLst>
+          </p:nvPr>
+        </p:nvGraphicFramePr>
+        <p:xfrm>
+          <a:off x="457200" y="1188720"/>
+          <a:ext cx="8229600" cy="914400"/>
+        </p:xfrm>
+        <a:graphic>
+          <a:graphicData uri="http://schemas.openxmlformats.org/drawingml/2006/table">
+            <a:tbl>
+              <a:tblPr/>
+              <a:tblGrid>
+                <a:gridCol w="3291840"/>
+                <a:gridCol w="1554480"/>
+                <a:gridCol w="2103120"/>
+                <a:gridCol w="1280160"/>
+              </a:tblGrid>
+              <a:tr h="411480">
+                <a:tc>
+                  <a:txBody>
+                    <a:bodyPr/>
+                    <a:lstStyle/>
+                    <a:p>
+                      <a:pPr indent="0" marL="0">
+                        <a:buNone/>
+                      </a:pPr>
+                      <a:r>
+                        <a:rPr lang="en-US" sz="1250" b="1" dirty="0">
+                          <a:solidFill>
+                            <a:srgbClr val="FFFFFF"/>
+                          </a:solidFill>
+                          <a:latin typeface="Arial" pitchFamily="34" charset="0"/>
+                          <a:ea typeface="Arial" pitchFamily="34" charset="-122"/>
+                          <a:cs typeface="Arial" pitchFamily="34" charset="-120"/>
+                        </a:rPr>
+                        <a:t>Quantity (same weights applied to all three)</a:t>
+                      </a:r>
+                      <a:endParaRPr lang="en-US" sz="1250" dirty="0">
+                        <a:latin typeface="Arial" charset="0"/>
+                        <a:ea typeface="Arial" charset="0"/>
+                        <a:cs typeface="Arial" charset="0"/>
+                      </a:endParaRPr>
+                    </a:p>
+                  </a:txBody>
+                  <a:tcPr marL="91440" marR="91440" marT="45720" marB="45720" anchor="ctr">
+                    <a:lnL w="6350" cap="flat" cmpd="sng" algn="ctr">
+                      <a:solidFill>
+                        <a:srgbClr val="CCCCCC"/>
+                      </a:solidFill>
+                      <a:prstDash val="solid"/>
+                      <a:round/>
+                      <a:headEnd type="none" w="med" len="med"/>
+                      <a:tailEnd type="none" w="med" len="med"/>
+                    </a:lnL>
+                    <a:lnR w="6350" cap="flat" cmpd="sng" algn="ctr">
+                      <a:solidFill>
+                        <a:srgbClr val="CCCCCC"/>
+                      </a:solidFill>
+                      <a:prstDash val="solid"/>
+                      <a:round/>
+                      <a:headEnd type="none" w="med" len="med"/>
+                      <a:tailEnd type="none" w="med" len="med"/>
+                    </a:lnR>
+                    <a:lnT w="6350" cap="flat" cmpd="sng" algn="ctr">
+                      <a:solidFill>
+                        <a:srgbClr val="CCCCCC"/>
+                      </a:solidFill>
+                      <a:prstDash val="solid"/>
+                      <a:round/>
+                      <a:headEnd type="none" w="med" len="med"/>
+                      <a:tailEnd type="none" w="med" len="med"/>
+                    </a:lnT>
+                    <a:lnB w="6350" cap="flat" cmpd="sng" algn="ctr">
+                      <a:solidFill>
+                        <a:srgbClr val="CCCCCC"/>
+                      </a:solidFill>
+                      <a:prstDash val="solid"/>
+                      <a:round/>
+                      <a:headEnd type="none" w="med" len="med"/>
+                      <a:tailEnd type="none" w="med" len="med"/>
+                    </a:lnB>
+                    <a:solidFill>
+                      <a:srgbClr val="1F4E79"/>
+                    </a:solidFill>
+                  </a:tcPr>
+                </a:tc>
+                <a:tc>
+                  <a:txBody>
+                    <a:bodyPr/>
+                    <a:lstStyle/>
+                    <a:p>
+                      <a:pPr indent="0" marL="0">
+                        <a:buNone/>
+                      </a:pPr>
+                      <a:r>
+                        <a:rPr lang="en-US" sz="1250" b="1" dirty="0">
+                          <a:solidFill>
+                            <a:srgbClr val="FFFFFF"/>
+                          </a:solidFill>
+                          <a:latin typeface="Arial" pitchFamily="34" charset="0"/>
+                          <a:ea typeface="Arial" pitchFamily="34" charset="-122"/>
+                          <a:cs typeface="Arial" pitchFamily="34" charset="-120"/>
+                        </a:rPr>
+                        <a:t>Before reweighting</a:t>
+                      </a:r>
+                      <a:endParaRPr lang="en-US" sz="1250" dirty="0">
+                        <a:latin typeface="Arial" charset="0"/>
+                        <a:ea typeface="Arial" charset="0"/>
+                        <a:cs typeface="Arial" charset="0"/>
+                      </a:endParaRPr>
+                    </a:p>
+                  </a:txBody>
+                  <a:tcPr marL="91440" marR="91440" marT="45720" marB="45720" anchor="ctr">
+                    <a:lnL w="6350" cap="flat" cmpd="sng" algn="ctr">
+                      <a:solidFill>
+                        <a:srgbClr val="CCCCCC"/>
+                      </a:solidFill>
+                      <a:prstDash val="solid"/>
+                      <a:round/>
+                      <a:headEnd type="none" w="med" len="med"/>
+                      <a:tailEnd type="none" w="med" len="med"/>
+                    </a:lnL>
+                    <a:lnR w="6350" cap="flat" cmpd="sng" algn="ctr">
+                      <a:solidFill>
+                        <a:srgbClr val="CCCCCC"/>
+                      </a:solidFill>
+                      <a:prstDash val="solid"/>
+                      <a:round/>
+                      <a:headEnd type="none" w="med" len="med"/>
+                      <a:tailEnd type="none" w="med" len="med"/>
+                    </a:lnR>
+                    <a:lnT w="6350" cap="flat" cmpd="sng" algn="ctr">
+                      <a:solidFill>
+                        <a:srgbClr val="CCCCCC"/>
+                      </a:solidFill>
+                      <a:prstDash val="solid"/>
+                      <a:round/>
+                      <a:headEnd type="none" w="med" len="med"/>
+                      <a:tailEnd type="none" w="med" len="med"/>
+                    </a:lnT>
+                    <a:lnB w="6350" cap="flat" cmpd="sng" algn="ctr">
+                      <a:solidFill>
+                        <a:srgbClr val="CCCCCC"/>
+                      </a:solidFill>
+                      <a:prstDash val="solid"/>
+                      <a:round/>
+                      <a:headEnd type="none" w="med" len="med"/>
+                      <a:tailEnd type="none" w="med" len="med"/>
+                    </a:lnB>
+                    <a:solidFill>
+                      <a:srgbClr val="1F4E79"/>
+                    </a:solidFill>
+                  </a:tcPr>
+                </a:tc>
+                <a:tc>
+                  <a:txBody>
+                    <a:bodyPr/>
+                    <a:lstStyle/>
+                    <a:p>
+                      <a:pPr indent="0" marL="0">
+                        <a:buNone/>
+                      </a:pPr>
+                      <a:r>
+                        <a:rPr lang="en-US" sz="1250" b="1" dirty="0">
+                          <a:solidFill>
+                            <a:srgbClr val="FFFFFF"/>
+                          </a:solidFill>
+                          <a:latin typeface="Arial" pitchFamily="34" charset="0"/>
+                          <a:ea typeface="Arial" pitchFamily="34" charset="-122"/>
+                          <a:cs typeface="Arial" pitchFamily="34" charset="-120"/>
+                        </a:rPr>
+                        <a:t>After SAXS-only reweighting</a:t>
+                      </a:r>
+                      <a:endParaRPr lang="en-US" sz="1250" dirty="0">
+                        <a:latin typeface="Arial" charset="0"/>
+                        <a:ea typeface="Arial" charset="0"/>
+                        <a:cs typeface="Arial" charset="0"/>
+                      </a:endParaRPr>
+                    </a:p>
+                  </a:txBody>
+                  <a:tcPr marL="91440" marR="91440" marT="45720" marB="45720" anchor="ctr">
+                    <a:lnL w="6350" cap="flat" cmpd="sng" algn="ctr">
+                      <a:solidFill>
+                        <a:srgbClr val="CCCCCC"/>
+                      </a:solidFill>
+                      <a:prstDash val="solid"/>
+                      <a:round/>
+                      <a:headEnd type="none" w="med" len="med"/>
+                      <a:tailEnd type="none" w="med" len="med"/>
+                    </a:lnL>
+                    <a:lnR w="6350" cap="flat" cmpd="sng" algn="ctr">
+                      <a:solidFill>
+                        <a:srgbClr val="CCCCCC"/>
+                      </a:solidFill>
+                      <a:prstDash val="solid"/>
+                      <a:round/>
+                      <a:headEnd type="none" w="med" len="med"/>
+                      <a:tailEnd type="none" w="med" len="med"/>
+                    </a:lnR>
+                    <a:lnT w="6350" cap="flat" cmpd="sng" algn="ctr">
+                      <a:solidFill>
+                        <a:srgbClr val="CCCCCC"/>
+                      </a:solidFill>
+                      <a:prstDash val="solid"/>
+                      <a:round/>
+                      <a:headEnd type="none" w="med" len="med"/>
+                      <a:tailEnd type="none" w="med" len="med"/>
+                    </a:lnT>
+                    <a:lnB w="6350" cap="flat" cmpd="sng" algn="ctr">
+                      <a:solidFill>
+                        <a:srgbClr val="CCCCCC"/>
+                      </a:solidFill>
+                      <a:prstDash val="solid"/>
+                      <a:round/>
+                      <a:headEnd type="none" w="med" len="med"/>
+                      <a:tailEnd type="none" w="med" len="med"/>
+                    </a:lnB>
+                    <a:solidFill>
+                      <a:srgbClr val="1F4E79"/>
+                    </a:solidFill>
+                  </a:tcPr>
+                </a:tc>
+                <a:tc>
+                  <a:txBody>
+                    <a:bodyPr/>
+                    <a:lstStyle/>
+                    <a:p>
+                      <a:pPr indent="0" marL="0">
+                        <a:buNone/>
+                      </a:pPr>
+                      <a:r>
+                        <a:rPr lang="en-US" sz="1250" b="1" dirty="0">
+                          <a:solidFill>
+                            <a:srgbClr val="FFFFFF"/>
+                          </a:solidFill>
+                          <a:latin typeface="Arial" pitchFamily="34" charset="0"/>
+                          <a:ea typeface="Arial" pitchFamily="34" charset="-122"/>
+                          <a:cs typeface="Arial" pitchFamily="34" charset="-120"/>
+                        </a:rPr>
+                        <a:t>Direction</a:t>
+                      </a:r>
+                      <a:endParaRPr lang="en-US" sz="1250" dirty="0">
+                        <a:latin typeface="Arial" charset="0"/>
+                        <a:ea typeface="Arial" charset="0"/>
+                        <a:cs typeface="Arial" charset="0"/>
+                      </a:endParaRPr>
+                    </a:p>
+                  </a:txBody>
+                  <a:tcPr marL="91440" marR="91440" marT="45720" marB="45720" anchor="ctr">
+                    <a:lnL w="6350" cap="flat" cmpd="sng" algn="ctr">
+                      <a:solidFill>
+                        <a:srgbClr val="CCCCCC"/>
+                      </a:solidFill>
+                      <a:prstDash val="solid"/>
+                      <a:round/>
+                      <a:headEnd type="none" w="med" len="med"/>
+                      <a:tailEnd type="none" w="med" len="med"/>
+                    </a:lnL>
+                    <a:lnR w="6350" cap="flat" cmpd="sng" algn="ctr">
+                      <a:solidFill>
+                        <a:srgbClr val="CCCCCC"/>
+                      </a:solidFill>
+                      <a:prstDash val="solid"/>
+                      <a:round/>
+                      <a:headEnd type="none" w="med" len="med"/>
+                      <a:tailEnd type="none" w="med" len="med"/>
+                    </a:lnR>
+                    <a:lnT w="6350" cap="flat" cmpd="sng" algn="ctr">
+                      <a:solidFill>
+                        <a:srgbClr val="CCCCCC"/>
+                      </a:solidFill>
+                      <a:prstDash val="solid"/>
+                      <a:round/>
+                      <a:headEnd type="none" w="med" len="med"/>
+                      <a:tailEnd type="none" w="med" len="med"/>
+                    </a:lnT>
+                    <a:lnB w="6350" cap="flat" cmpd="sng" algn="ctr">
+                      <a:solidFill>
+                        <a:srgbClr val="CCCCCC"/>
+                      </a:solidFill>
+                      <a:prstDash val="solid"/>
+                      <a:round/>
+                      <a:headEnd type="none" w="med" len="med"/>
+                      <a:tailEnd type="none" w="med" len="med"/>
+                    </a:lnB>
+                    <a:solidFill>
+                      <a:srgbClr val="1F4E79"/>
+                    </a:solidFill>
+                  </a:tcPr>
+                </a:tc>
+              </a:tr>
+              <a:tr h="411480">
+                <a:tc>
+                  <a:txBody>
+                    <a:bodyPr/>
+                    <a:lstStyle/>
+                    <a:p>
+                      <a:pPr indent="0" marL="0">
+                        <a:buNone/>
+                      </a:pPr>
+                      <a:r>
+                        <a:rPr lang="en-US" sz="1250" dirty="0">
+                          <a:solidFill>
+                            <a:srgbClr val="2D2D2D"/>
+                          </a:solidFill>
+                          <a:latin typeface="Arial" pitchFamily="34" charset="0"/>
+                          <a:ea typeface="Arial" pitchFamily="34" charset="-122"/>
+                          <a:cs typeface="Arial" pitchFamily="34" charset="-120"/>
+                        </a:rPr>
+                        <a:t>SAXS mean penalty (90 points)</a:t>
+                      </a:r>
+                      <a:endParaRPr lang="en-US" sz="1250" dirty="0">
+                        <a:latin typeface="Arial" charset="0"/>
+                        <a:ea typeface="Arial" charset="0"/>
+                        <a:cs typeface="Arial" charset="0"/>
+                      </a:endParaRPr>
+                    </a:p>
+                  </a:txBody>
+                  <a:tcPr marL="91440" marR="91440" marT="45720" marB="45720" anchor="ctr">
+                    <a:lnL w="6350" cap="flat" cmpd="sng" algn="ctr">
+                      <a:solidFill>
+                        <a:srgbClr val="CCCCCC"/>
+                      </a:solidFill>
+                      <a:prstDash val="solid"/>
+                      <a:round/>
+                      <a:headEnd type="none" w="med" len="med"/>
+                      <a:tailEnd type="none" w="med" len="med"/>
+                    </a:lnL>
+                    <a:lnR w="6350" cap="flat" cmpd="sng" algn="ctr">
+                      <a:solidFill>
+                        <a:srgbClr val="CCCCCC"/>
+                      </a:solidFill>
+                      <a:prstDash val="solid"/>
+                      <a:round/>
+                      <a:headEnd type="none" w="med" len="med"/>
+                      <a:tailEnd type="none" w="med" len="med"/>
+                    </a:lnR>
+                    <a:lnT w="6350" cap="flat" cmpd="sng" algn="ctr">
+                      <a:solidFill>
+                        <a:srgbClr val="CCCCCC"/>
+                      </a:solidFill>
+                      <a:prstDash val="solid"/>
+                      <a:round/>
+                      <a:headEnd type="none" w="med" len="med"/>
+                      <a:tailEnd type="none" w="med" len="med"/>
+                    </a:lnT>
+                    <a:lnB w="6350" cap="flat" cmpd="sng" algn="ctr">
+                      <a:solidFill>
+                        <a:srgbClr val="CCCCCC"/>
+                      </a:solidFill>
+                      <a:prstDash val="solid"/>
+                      <a:round/>
+                      <a:headEnd type="none" w="med" len="med"/>
+                      <a:tailEnd type="none" w="med" len="med"/>
+                    </a:lnB>
+                  </a:tcPr>
+                </a:tc>
+                <a:tc>
+                  <a:txBody>
+                    <a:bodyPr/>
+                    <a:lstStyle/>
+                    <a:p>
+                      <a:pPr indent="0" marL="0">
+                        <a:buNone/>
+                      </a:pPr>
+                      <a:r>
+                        <a:rPr lang="en-US" sz="1250" dirty="0">
+                          <a:solidFill>
+                            <a:srgbClr val="2D2D2D"/>
+                          </a:solidFill>
+                          <a:latin typeface="Arial" pitchFamily="34" charset="0"/>
+                          <a:ea typeface="Arial" pitchFamily="34" charset="-122"/>
+                          <a:cs typeface="Arial" pitchFamily="34" charset="-120"/>
+                        </a:rPr>
+                        <a:t>10.0188</a:t>
+                      </a:r>
+                      <a:endParaRPr lang="en-US" sz="1250" dirty="0">
+                        <a:latin typeface="Arial" charset="0"/>
+                        <a:ea typeface="Arial" charset="0"/>
+                        <a:cs typeface="Arial" charset="0"/>
+                      </a:endParaRPr>
+                    </a:p>
+                  </a:txBody>
+                  <a:tcPr marL="91440" marR="91440" marT="45720" marB="45720" anchor="ctr">
+                    <a:lnL w="6350" cap="flat" cmpd="sng" algn="ctr">
+                      <a:solidFill>
+                        <a:srgbClr val="CCCCCC"/>
+                      </a:solidFill>
+                      <a:prstDash val="solid"/>
+                      <a:round/>
+                      <a:headEnd type="none" w="med" len="med"/>
+                      <a:tailEnd type="none" w="med" len="med"/>
+                    </a:lnL>
+                    <a:lnR w="6350" cap="flat" cmpd="sng" algn="ctr">
+                      <a:solidFill>
+                        <a:srgbClr val="CCCCCC"/>
+                      </a:solidFill>
+                      <a:prstDash val="solid"/>
+                      <a:round/>
+                      <a:headEnd type="none" w="med" len="med"/>
+                      <a:tailEnd type="none" w="med" len="med"/>
+                    </a:lnR>
+                    <a:lnT w="6350" cap="flat" cmpd="sng" algn="ctr">
+                      <a:solidFill>
+                        <a:srgbClr val="CCCCCC"/>
+                      </a:solidFill>
+                      <a:prstDash val="solid"/>
+                      <a:round/>
+                      <a:headEnd type="none" w="med" len="med"/>
+                      <a:tailEnd type="none" w="med" len="med"/>
+                    </a:lnT>
+                    <a:lnB w="6350" cap="flat" cmpd="sng" algn="ctr">
+                      <a:solidFill>
+                        <a:srgbClr val="CCCCCC"/>
+                      </a:solidFill>
+                      <a:prstDash val="solid"/>
+                      <a:round/>
+                      <a:headEnd type="none" w="med" len="med"/>
+                      <a:tailEnd type="none" w="med" len="med"/>
+                    </a:lnB>
+                  </a:tcPr>
+                </a:tc>
+                <a:tc>
+                  <a:txBody>
+                    <a:bodyPr/>
+                    <a:lstStyle/>
+                    <a:p>
+                      <a:pPr indent="0" marL="0">
+                        <a:buNone/>
+                      </a:pPr>
+                      <a:r>
+                        <a:rPr lang="en-US" sz="1250" dirty="0">
+                          <a:solidFill>
+                            <a:srgbClr val="2D2D2D"/>
+                          </a:solidFill>
+                          <a:latin typeface="Arial" pitchFamily="34" charset="0"/>
+                          <a:ea typeface="Arial" pitchFamily="34" charset="-122"/>
+                          <a:cs typeface="Arial" pitchFamily="34" charset="-120"/>
+                        </a:rPr>
+                        <a:t>1.1707</a:t>
+                      </a:r>
+                      <a:endParaRPr lang="en-US" sz="1250" dirty="0">
+                        <a:latin typeface="Arial" charset="0"/>
+                        <a:ea typeface="Arial" charset="0"/>
+                        <a:cs typeface="Arial" charset="0"/>
+                      </a:endParaRPr>
+                    </a:p>
+                  </a:txBody>
+                  <a:tcPr marL="91440" marR="91440" marT="45720" marB="45720" anchor="ctr">
+                    <a:lnL w="6350" cap="flat" cmpd="sng" algn="ctr">
+                      <a:solidFill>
+                        <a:srgbClr val="CCCCCC"/>
+                      </a:solidFill>
+                      <a:prstDash val="solid"/>
+                      <a:round/>
+                      <a:headEnd type="none" w="med" len="med"/>
+                      <a:tailEnd type="none" w="med" len="med"/>
+                    </a:lnL>
+                    <a:lnR w="6350" cap="flat" cmpd="sng" algn="ctr">
+                      <a:solidFill>
+                        <a:srgbClr val="CCCCCC"/>
+                      </a:solidFill>
+                      <a:prstDash val="solid"/>
+                      <a:round/>
+                      <a:headEnd type="none" w="med" len="med"/>
+                      <a:tailEnd type="none" w="med" len="med"/>
+                    </a:lnR>
+                    <a:lnT w="6350" cap="flat" cmpd="sng" algn="ctr">
+                      <a:solidFill>
+                        <a:srgbClr val="CCCCCC"/>
+                      </a:solidFill>
+                      <a:prstDash val="solid"/>
+                      <a:round/>
+                      <a:headEnd type="none" w="med" len="med"/>
+                      <a:tailEnd type="none" w="med" len="med"/>
+                    </a:lnT>
+                    <a:lnB w="6350" cap="flat" cmpd="sng" algn="ctr">
+                      <a:solidFill>
+                        <a:srgbClr val="CCCCCC"/>
+                      </a:solidFill>
+                      <a:prstDash val="solid"/>
+                      <a:round/>
+                      <a:headEnd type="none" w="med" len="med"/>
+                      <a:tailEnd type="none" w="med" len="med"/>
+                    </a:lnB>
+                  </a:tcPr>
+                </a:tc>
+                <a:tc>
+                  <a:txBody>
+                    <a:bodyPr/>
+                    <a:lstStyle/>
+                    <a:p>
+                      <a:pPr indent="0" marL="0">
+                        <a:buNone/>
+                      </a:pPr>
+                      <a:r>
+                        <a:rPr lang="en-US" sz="1250" b="1" dirty="0">
+                          <a:solidFill>
+                            <a:srgbClr val="2E7D32"/>
+                          </a:solidFill>
+                          <a:latin typeface="Arial" pitchFamily="34" charset="0"/>
+                          <a:ea typeface="Arial" pitchFamily="34" charset="-122"/>
+                          <a:cs typeface="Arial" pitchFamily="34" charset="-120"/>
+                        </a:rPr>
+                        <a:t>better</a:t>
+                      </a:r>
+                      <a:endParaRPr lang="en-US" sz="1250" dirty="0">
+                        <a:latin typeface="Arial" charset="0"/>
+                        <a:ea typeface="Arial" charset="0"/>
+                        <a:cs typeface="Arial" charset="0"/>
+                      </a:endParaRPr>
+                    </a:p>
+                  </a:txBody>
+                  <a:tcPr marL="91440" marR="91440" marT="45720" marB="45720" anchor="ctr">
+                    <a:lnL w="6350" cap="flat" cmpd="sng" algn="ctr">
+                      <a:solidFill>
+                        <a:srgbClr val="CCCCCC"/>
+                      </a:solidFill>
+                      <a:prstDash val="solid"/>
+                      <a:round/>
+                      <a:headEnd type="none" w="med" len="med"/>
+                      <a:tailEnd type="none" w="med" len="med"/>
+                    </a:lnL>
+                    <a:lnR w="6350" cap="flat" cmpd="sng" algn="ctr">
+                      <a:solidFill>
+                        <a:srgbClr val="CCCCCC"/>
+                      </a:solidFill>
+                      <a:prstDash val="solid"/>
+                      <a:round/>
+                      <a:headEnd type="none" w="med" len="med"/>
+                      <a:tailEnd type="none" w="med" len="med"/>
+                    </a:lnR>
+                    <a:lnT w="6350" cap="flat" cmpd="sng" algn="ctr">
+                      <a:solidFill>
+                        <a:srgbClr val="CCCCCC"/>
+                      </a:solidFill>
+                      <a:prstDash val="solid"/>
+                      <a:round/>
+                      <a:headEnd type="none" w="med" len="med"/>
+                      <a:tailEnd type="none" w="med" len="med"/>
+                    </a:lnT>
+                    <a:lnB w="6350" cap="flat" cmpd="sng" algn="ctr">
+                      <a:solidFill>
+                        <a:srgbClr val="CCCCCC"/>
+                      </a:solidFill>
+                      <a:prstDash val="solid"/>
+                      <a:round/>
+                      <a:headEnd type="none" w="med" len="med"/>
+                      <a:tailEnd type="none" w="med" len="med"/>
+                    </a:lnB>
+                  </a:tcPr>
+                </a:tc>
+              </a:tr>
+              <a:tr h="411480">
+                <a:tc>
+                  <a:txBody>
+                    <a:bodyPr/>
+                    <a:lstStyle/>
+                    <a:p>
+                      <a:pPr indent="0" marL="0">
+                        <a:buNone/>
+                      </a:pPr>
+                      <a:r>
+                        <a:rPr lang="en-US" sz="1250" dirty="0">
+                          <a:solidFill>
+                            <a:srgbClr val="2D2D2D"/>
+                          </a:solidFill>
+                          <a:latin typeface="Arial" pitchFamily="34" charset="0"/>
+                          <a:ea typeface="Arial" pitchFamily="34" charset="-122"/>
+                          <a:cs typeface="Arial" pitchFamily="34" charset="-120"/>
+                        </a:rPr>
+                        <a:t>amide NOE penalty (292 restraints)</a:t>
+                      </a:r>
+                      <a:endParaRPr lang="en-US" sz="1250" dirty="0">
+                        <a:latin typeface="Arial" charset="0"/>
+                        <a:ea typeface="Arial" charset="0"/>
+                        <a:cs typeface="Arial" charset="0"/>
+                      </a:endParaRPr>
+                    </a:p>
+                  </a:txBody>
+                  <a:tcPr marL="91440" marR="91440" marT="45720" marB="45720" anchor="ctr">
+                    <a:lnL w="6350" cap="flat" cmpd="sng" algn="ctr">
+                      <a:solidFill>
+                        <a:srgbClr val="CCCCCC"/>
+                      </a:solidFill>
+                      <a:prstDash val="solid"/>
+                      <a:round/>
+                      <a:headEnd type="none" w="med" len="med"/>
+                      <a:tailEnd type="none" w="med" len="med"/>
+                    </a:lnL>
+                    <a:lnR w="6350" cap="flat" cmpd="sng" algn="ctr">
+                      <a:solidFill>
+                        <a:srgbClr val="CCCCCC"/>
+                      </a:solidFill>
+                      <a:prstDash val="solid"/>
+                      <a:round/>
+                      <a:headEnd type="none" w="med" len="med"/>
+                      <a:tailEnd type="none" w="med" len="med"/>
+                    </a:lnR>
+                    <a:lnT w="6350" cap="flat" cmpd="sng" algn="ctr">
+                      <a:solidFill>
+                        <a:srgbClr val="CCCCCC"/>
+                      </a:solidFill>
+                      <a:prstDash val="solid"/>
+                      <a:round/>
+                      <a:headEnd type="none" w="med" len="med"/>
+                      <a:tailEnd type="none" w="med" len="med"/>
+                    </a:lnT>
+                    <a:lnB w="6350" cap="flat" cmpd="sng" algn="ctr">
+                      <a:solidFill>
+                        <a:srgbClr val="CCCCCC"/>
+                      </a:solidFill>
+                      <a:prstDash val="solid"/>
+                      <a:round/>
+                      <a:headEnd type="none" w="med" len="med"/>
+                      <a:tailEnd type="none" w="med" len="med"/>
+                    </a:lnB>
+                  </a:tcPr>
+                </a:tc>
+                <a:tc>
+                  <a:txBody>
+                    <a:bodyPr/>
+                    <a:lstStyle/>
+                    <a:p>
+                      <a:pPr indent="0" marL="0">
+                        <a:buNone/>
+                      </a:pPr>
+                      <a:r>
+                        <a:rPr lang="en-US" sz="1250" dirty="0">
+                          <a:solidFill>
+                            <a:srgbClr val="2D2D2D"/>
+                          </a:solidFill>
+                          <a:latin typeface="Arial" pitchFamily="34" charset="0"/>
+                          <a:ea typeface="Arial" pitchFamily="34" charset="-122"/>
+                          <a:cs typeface="Arial" pitchFamily="34" charset="-120"/>
+                        </a:rPr>
+                        <a:t>0.9334</a:t>
+                      </a:r>
+                      <a:endParaRPr lang="en-US" sz="1250" dirty="0">
+                        <a:latin typeface="Arial" charset="0"/>
+                        <a:ea typeface="Arial" charset="0"/>
+                        <a:cs typeface="Arial" charset="0"/>
+                      </a:endParaRPr>
+                    </a:p>
+                  </a:txBody>
+                  <a:tcPr marL="91440" marR="91440" marT="45720" marB="45720" anchor="ctr">
+                    <a:lnL w="6350" cap="flat" cmpd="sng" algn="ctr">
+                      <a:solidFill>
+                        <a:srgbClr val="CCCCCC"/>
+                      </a:solidFill>
+                      <a:prstDash val="solid"/>
+                      <a:round/>
+                      <a:headEnd type="none" w="med" len="med"/>
+                      <a:tailEnd type="none" w="med" len="med"/>
+                    </a:lnL>
+                    <a:lnR w="6350" cap="flat" cmpd="sng" algn="ctr">
+                      <a:solidFill>
+                        <a:srgbClr val="CCCCCC"/>
+                      </a:solidFill>
+                      <a:prstDash val="solid"/>
+                      <a:round/>
+                      <a:headEnd type="none" w="med" len="med"/>
+                      <a:tailEnd type="none" w="med" len="med"/>
+                    </a:lnR>
+                    <a:lnT w="6350" cap="flat" cmpd="sng" algn="ctr">
+                      <a:solidFill>
+                        <a:srgbClr val="CCCCCC"/>
+                      </a:solidFill>
+                      <a:prstDash val="solid"/>
+                      <a:round/>
+                      <a:headEnd type="none" w="med" len="med"/>
+                      <a:tailEnd type="none" w="med" len="med"/>
+                    </a:lnT>
+                    <a:lnB w="6350" cap="flat" cmpd="sng" algn="ctr">
+                      <a:solidFill>
+                        <a:srgbClr val="CCCCCC"/>
+                      </a:solidFill>
+                      <a:prstDash val="solid"/>
+                      <a:round/>
+                      <a:headEnd type="none" w="med" len="med"/>
+                      <a:tailEnd type="none" w="med" len="med"/>
+                    </a:lnB>
+                  </a:tcPr>
+                </a:tc>
+                <a:tc>
+                  <a:txBody>
+                    <a:bodyPr/>
+                    <a:lstStyle/>
+                    <a:p>
+                      <a:pPr indent="0" marL="0">
+                        <a:buNone/>
+                      </a:pPr>
+                      <a:r>
+                        <a:rPr lang="en-US" sz="1250" dirty="0">
+                          <a:solidFill>
+                            <a:srgbClr val="2D2D2D"/>
+                          </a:solidFill>
+                          <a:latin typeface="Arial" pitchFamily="34" charset="0"/>
+                          <a:ea typeface="Arial" pitchFamily="34" charset="-122"/>
+                          <a:cs typeface="Arial" pitchFamily="34" charset="-120"/>
+                        </a:rPr>
+                        <a:t>0.9647</a:t>
+                      </a:r>
+                      <a:endParaRPr lang="en-US" sz="1250" dirty="0">
+                        <a:latin typeface="Arial" charset="0"/>
+                        <a:ea typeface="Arial" charset="0"/>
+                        <a:cs typeface="Arial" charset="0"/>
+                      </a:endParaRPr>
+                    </a:p>
+                  </a:txBody>
+                  <a:tcPr marL="91440" marR="91440" marT="45720" marB="45720" anchor="ctr">
+                    <a:lnL w="6350" cap="flat" cmpd="sng" algn="ctr">
+                      <a:solidFill>
+                        <a:srgbClr val="CCCCCC"/>
+                      </a:solidFill>
+                      <a:prstDash val="solid"/>
+                      <a:round/>
+                      <a:headEnd type="none" w="med" len="med"/>
+                      <a:tailEnd type="none" w="med" len="med"/>
+                    </a:lnL>
+                    <a:lnR w="6350" cap="flat" cmpd="sng" algn="ctr">
+                      <a:solidFill>
+                        <a:srgbClr val="CCCCCC"/>
+                      </a:solidFill>
+                      <a:prstDash val="solid"/>
+                      <a:round/>
+                      <a:headEnd type="none" w="med" len="med"/>
+                      <a:tailEnd type="none" w="med" len="med"/>
+                    </a:lnR>
+                    <a:lnT w="6350" cap="flat" cmpd="sng" algn="ctr">
+                      <a:solidFill>
+                        <a:srgbClr val="CCCCCC"/>
+                      </a:solidFill>
+                      <a:prstDash val="solid"/>
+                      <a:round/>
+                      <a:headEnd type="none" w="med" len="med"/>
+                      <a:tailEnd type="none" w="med" len="med"/>
+                    </a:lnT>
+                    <a:lnB w="6350" cap="flat" cmpd="sng" algn="ctr">
+                      <a:solidFill>
+                        <a:srgbClr val="CCCCCC"/>
+                      </a:solidFill>
+                      <a:prstDash val="solid"/>
+                      <a:round/>
+                      <a:headEnd type="none" w="med" len="med"/>
+                      <a:tailEnd type="none" w="med" len="med"/>
+                    </a:lnB>
+                  </a:tcPr>
+                </a:tc>
+                <a:tc>
+                  <a:txBody>
+                    <a:bodyPr/>
+                    <a:lstStyle/>
+                    <a:p>
+                      <a:pPr indent="0" marL="0">
+                        <a:buNone/>
+                      </a:pPr>
+                      <a:r>
+                        <a:rPr lang="en-US" sz="1250" b="1" dirty="0">
+                          <a:solidFill>
+                            <a:srgbClr val="C0392B"/>
+                          </a:solidFill>
+                          <a:latin typeface="Arial" pitchFamily="34" charset="0"/>
+                          <a:ea typeface="Arial" pitchFamily="34" charset="-122"/>
+                          <a:cs typeface="Arial" pitchFamily="34" charset="-120"/>
+                        </a:rPr>
+                        <a:t>slightly worse</a:t>
+                      </a:r>
+                      <a:endParaRPr lang="en-US" sz="1250" dirty="0">
+                        <a:latin typeface="Arial" charset="0"/>
+                        <a:ea typeface="Arial" charset="0"/>
+                        <a:cs typeface="Arial" charset="0"/>
+                      </a:endParaRPr>
+                    </a:p>
+                  </a:txBody>
+                  <a:tcPr marL="91440" marR="91440" marT="45720" marB="45720" anchor="ctr">
+                    <a:lnL w="6350" cap="flat" cmpd="sng" algn="ctr">
+                      <a:solidFill>
+                        <a:srgbClr val="CCCCCC"/>
+                      </a:solidFill>
+                      <a:prstDash val="solid"/>
+                      <a:round/>
+                      <a:headEnd type="none" w="med" len="med"/>
+                      <a:tailEnd type="none" w="med" len="med"/>
+                    </a:lnL>
+                    <a:lnR w="6350" cap="flat" cmpd="sng" algn="ctr">
+                      <a:solidFill>
+                        <a:srgbClr val="CCCCCC"/>
+                      </a:solidFill>
+                      <a:prstDash val="solid"/>
+                      <a:round/>
+                      <a:headEnd type="none" w="med" len="med"/>
+                      <a:tailEnd type="none" w="med" len="med"/>
+                    </a:lnR>
+                    <a:lnT w="6350" cap="flat" cmpd="sng" algn="ctr">
+                      <a:solidFill>
+                        <a:srgbClr val="CCCCCC"/>
+                      </a:solidFill>
+                      <a:prstDash val="solid"/>
+                      <a:round/>
+                      <a:headEnd type="none" w="med" len="med"/>
+                      <a:tailEnd type="none" w="med" len="med"/>
+                    </a:lnT>
+                    <a:lnB w="6350" cap="flat" cmpd="sng" algn="ctr">
+                      <a:solidFill>
+                        <a:srgbClr val="CCCCCC"/>
+                      </a:solidFill>
+                      <a:prstDash val="solid"/>
+                      <a:round/>
+                      <a:headEnd type="none" w="med" len="med"/>
+                      <a:tailEnd type="none" w="med" len="med"/>
+                    </a:lnB>
+                  </a:tcPr>
+                </a:tc>
+              </a:tr>
+              <a:tr h="411480">
+                <a:tc>
+                  <a:txBody>
+                    <a:bodyPr/>
+                    <a:lstStyle/>
+                    <a:p>
+                      <a:pPr indent="0" marL="0">
+                        <a:buNone/>
+                      </a:pPr>
+                      <a:r>
+                        <a:rPr lang="en-US" sz="1250" dirty="0">
+                          <a:solidFill>
+                            <a:srgbClr val="2D2D2D"/>
+                          </a:solidFill>
+                          <a:latin typeface="Arial" pitchFamily="34" charset="0"/>
+                          <a:ea typeface="Arial" pitchFamily="34" charset="-122"/>
+                          <a:cs typeface="Arial" pitchFamily="34" charset="-120"/>
+                        </a:rPr>
+                        <a:t>methyl NOE penalty (40 restraints)</a:t>
+                      </a:r>
+                      <a:endParaRPr lang="en-US" sz="1250" dirty="0">
+                        <a:latin typeface="Arial" charset="0"/>
+                        <a:ea typeface="Arial" charset="0"/>
+                        <a:cs typeface="Arial" charset="0"/>
+                      </a:endParaRPr>
+                    </a:p>
+                  </a:txBody>
+                  <a:tcPr marL="91440" marR="91440" marT="45720" marB="45720" anchor="ctr">
+                    <a:lnL w="6350" cap="flat" cmpd="sng" algn="ctr">
+                      <a:solidFill>
+                        <a:srgbClr val="CCCCCC"/>
+                      </a:solidFill>
+                      <a:prstDash val="solid"/>
+                      <a:round/>
+                      <a:headEnd type="none" w="med" len="med"/>
+                      <a:tailEnd type="none" w="med" len="med"/>
+                    </a:lnL>
+                    <a:lnR w="6350" cap="flat" cmpd="sng" algn="ctr">
+                      <a:solidFill>
+                        <a:srgbClr val="CCCCCC"/>
+                      </a:solidFill>
+                      <a:prstDash val="solid"/>
+                      <a:round/>
+                      <a:headEnd type="none" w="med" len="med"/>
+                      <a:tailEnd type="none" w="med" len="med"/>
+                    </a:lnR>
+                    <a:lnT w="6350" cap="flat" cmpd="sng" algn="ctr">
+                      <a:solidFill>
+                        <a:srgbClr val="CCCCCC"/>
+                      </a:solidFill>
+                      <a:prstDash val="solid"/>
+                      <a:round/>
+                      <a:headEnd type="none" w="med" len="med"/>
+                      <a:tailEnd type="none" w="med" len="med"/>
+                    </a:lnT>
+                    <a:lnB w="6350" cap="flat" cmpd="sng" algn="ctr">
+                      <a:solidFill>
+                        <a:srgbClr val="CCCCCC"/>
+                      </a:solidFill>
+                      <a:prstDash val="solid"/>
+                      <a:round/>
+                      <a:headEnd type="none" w="med" len="med"/>
+                      <a:tailEnd type="none" w="med" len="med"/>
+                    </a:lnB>
+                  </a:tcPr>
+                </a:tc>
+                <a:tc>
+                  <a:txBody>
+                    <a:bodyPr/>
+                    <a:lstStyle/>
+                    <a:p>
+                      <a:pPr indent="0" marL="0">
+                        <a:buNone/>
+                      </a:pPr>
+                      <a:r>
+                        <a:rPr lang="en-US" sz="1250" dirty="0">
+                          <a:solidFill>
+                            <a:srgbClr val="2D2D2D"/>
+                          </a:solidFill>
+                          <a:latin typeface="Arial" pitchFamily="34" charset="0"/>
+                          <a:ea typeface="Arial" pitchFamily="34" charset="-122"/>
+                          <a:cs typeface="Arial" pitchFamily="34" charset="-120"/>
+                        </a:rPr>
+                        <a:t>3.8931</a:t>
+                      </a:r>
+                      <a:endParaRPr lang="en-US" sz="1250" dirty="0">
+                        <a:latin typeface="Arial" charset="0"/>
+                        <a:ea typeface="Arial" charset="0"/>
+                        <a:cs typeface="Arial" charset="0"/>
+                      </a:endParaRPr>
+                    </a:p>
+                  </a:txBody>
+                  <a:tcPr marL="91440" marR="91440" marT="45720" marB="45720" anchor="ctr">
+                    <a:lnL w="6350" cap="flat" cmpd="sng" algn="ctr">
+                      <a:solidFill>
+                        <a:srgbClr val="CCCCCC"/>
+                      </a:solidFill>
+                      <a:prstDash val="solid"/>
+                      <a:round/>
+                      <a:headEnd type="none" w="med" len="med"/>
+                      <a:tailEnd type="none" w="med" len="med"/>
+                    </a:lnL>
+                    <a:lnR w="6350" cap="flat" cmpd="sng" algn="ctr">
+                      <a:solidFill>
+                        <a:srgbClr val="CCCCCC"/>
+                      </a:solidFill>
+                      <a:prstDash val="solid"/>
+                      <a:round/>
+                      <a:headEnd type="none" w="med" len="med"/>
+                      <a:tailEnd type="none" w="med" len="med"/>
+                    </a:lnR>
+                    <a:lnT w="6350" cap="flat" cmpd="sng" algn="ctr">
+                      <a:solidFill>
+                        <a:srgbClr val="CCCCCC"/>
+                      </a:solidFill>
+                      <a:prstDash val="solid"/>
+                      <a:round/>
+                      <a:headEnd type="none" w="med" len="med"/>
+                      <a:tailEnd type="none" w="med" len="med"/>
+                    </a:lnT>
+                    <a:lnB w="6350" cap="flat" cmpd="sng" algn="ctr">
+                      <a:solidFill>
+                        <a:srgbClr val="CCCCCC"/>
+                      </a:solidFill>
+                      <a:prstDash val="solid"/>
+                      <a:round/>
+                      <a:headEnd type="none" w="med" len="med"/>
+                      <a:tailEnd type="none" w="med" len="med"/>
+                    </a:lnB>
+                  </a:tcPr>
+                </a:tc>
+                <a:tc>
+                  <a:txBody>
+                    <a:bodyPr/>
+                    <a:lstStyle/>
+                    <a:p>
+                      <a:pPr indent="0" marL="0">
+                        <a:buNone/>
+                      </a:pPr>
+                      <a:r>
+                        <a:rPr lang="en-US" sz="1250" dirty="0">
+                          <a:solidFill>
+                            <a:srgbClr val="2D2D2D"/>
+                          </a:solidFill>
+                          <a:latin typeface="Arial" pitchFamily="34" charset="0"/>
+                          <a:ea typeface="Arial" pitchFamily="34" charset="-122"/>
+                          <a:cs typeface="Arial" pitchFamily="34" charset="-120"/>
+                        </a:rPr>
+                        <a:t>4.4695</a:t>
+                      </a:r>
+                      <a:endParaRPr lang="en-US" sz="1250" dirty="0">
+                        <a:latin typeface="Arial" charset="0"/>
+                        <a:ea typeface="Arial" charset="0"/>
+                        <a:cs typeface="Arial" charset="0"/>
+                      </a:endParaRPr>
+                    </a:p>
+                  </a:txBody>
+                  <a:tcPr marL="91440" marR="91440" marT="45720" marB="45720" anchor="ctr">
+                    <a:lnL w="6350" cap="flat" cmpd="sng" algn="ctr">
+                      <a:solidFill>
+                        <a:srgbClr val="CCCCCC"/>
+                      </a:solidFill>
+                      <a:prstDash val="solid"/>
+                      <a:round/>
+                      <a:headEnd type="none" w="med" len="med"/>
+                      <a:tailEnd type="none" w="med" len="med"/>
+                    </a:lnL>
+                    <a:lnR w="6350" cap="flat" cmpd="sng" algn="ctr">
+                      <a:solidFill>
+                        <a:srgbClr val="CCCCCC"/>
+                      </a:solidFill>
+                      <a:prstDash val="solid"/>
+                      <a:round/>
+                      <a:headEnd type="none" w="med" len="med"/>
+                      <a:tailEnd type="none" w="med" len="med"/>
+                    </a:lnR>
+                    <a:lnT w="6350" cap="flat" cmpd="sng" algn="ctr">
+                      <a:solidFill>
+                        <a:srgbClr val="CCCCCC"/>
+                      </a:solidFill>
+                      <a:prstDash val="solid"/>
+                      <a:round/>
+                      <a:headEnd type="none" w="med" len="med"/>
+                      <a:tailEnd type="none" w="med" len="med"/>
+                    </a:lnT>
+                    <a:lnB w="6350" cap="flat" cmpd="sng" algn="ctr">
+                      <a:solidFill>
+                        <a:srgbClr val="CCCCCC"/>
+                      </a:solidFill>
+                      <a:prstDash val="solid"/>
+                      <a:round/>
+                      <a:headEnd type="none" w="med" len="med"/>
+                      <a:tailEnd type="none" w="med" len="med"/>
+                    </a:lnB>
+                  </a:tcPr>
+                </a:tc>
+                <a:tc>
+                  <a:txBody>
+                    <a:bodyPr/>
+                    <a:lstStyle/>
+                    <a:p>
+                      <a:pPr indent="0" marL="0">
+                        <a:buNone/>
+                      </a:pPr>
+                      <a:r>
+                        <a:rPr lang="en-US" sz="1250" b="1" dirty="0">
+                          <a:solidFill>
+                            <a:srgbClr val="C0392B"/>
+                          </a:solidFill>
+                          <a:latin typeface="Arial" pitchFamily="34" charset="0"/>
+                          <a:ea typeface="Arial" pitchFamily="34" charset="-122"/>
+                          <a:cs typeface="Arial" pitchFamily="34" charset="-120"/>
+                        </a:rPr>
+                        <a:t>worse</a:t>
+                      </a:r>
+                      <a:endParaRPr lang="en-US" sz="1250" dirty="0">
+                        <a:latin typeface="Arial" charset="0"/>
+                        <a:ea typeface="Arial" charset="0"/>
+                        <a:cs typeface="Arial" charset="0"/>
+                      </a:endParaRPr>
+                    </a:p>
+                  </a:txBody>
+                  <a:tcPr marL="91440" marR="91440" marT="45720" marB="45720" anchor="ctr">
+                    <a:lnL w="6350" cap="flat" cmpd="sng" algn="ctr">
+                      <a:solidFill>
+                        <a:srgbClr val="CCCCCC"/>
+                      </a:solidFill>
+                      <a:prstDash val="solid"/>
+                      <a:round/>
+                      <a:headEnd type="none" w="med" len="med"/>
+                      <a:tailEnd type="none" w="med" len="med"/>
+                    </a:lnL>
+                    <a:lnR w="6350" cap="flat" cmpd="sng" algn="ctr">
+                      <a:solidFill>
+                        <a:srgbClr val="CCCCCC"/>
+                      </a:solidFill>
+                      <a:prstDash val="solid"/>
+                      <a:round/>
+                      <a:headEnd type="none" w="med" len="med"/>
+                      <a:tailEnd type="none" w="med" len="med"/>
+                    </a:lnR>
+                    <a:lnT w="6350" cap="flat" cmpd="sng" algn="ctr">
+                      <a:solidFill>
+                        <a:srgbClr val="CCCCCC"/>
+                      </a:solidFill>
+                      <a:prstDash val="solid"/>
+                      <a:round/>
+                      <a:headEnd type="none" w="med" len="med"/>
+                      <a:tailEnd type="none" w="med" len="med"/>
+                    </a:lnT>
+                    <a:lnB w="6350" cap="flat" cmpd="sng" algn="ctr">
+                      <a:solidFill>
+                        <a:srgbClr val="CCCCCC"/>
+                      </a:solidFill>
+                      <a:prstDash val="solid"/>
+                      <a:round/>
+                      <a:headEnd type="none" w="med" len="med"/>
+                      <a:tailEnd type="none" w="med" len="med"/>
+                    </a:lnB>
+                  </a:tcPr>
+                </a:tc>
+              </a:tr>
+            </a:tbl>
+          </a:graphicData>
+        </a:graphic>
+      </p:graphicFrame>
+      <p:sp>
+        <p:nvSpPr>
+          <p:cNvPr id="7" name="Text 3"/>
+          <p:cNvSpPr/>
+          <p:nvPr/>
+        </p:nvSpPr>
+        <p:spPr>
+          <a:xfrm>
+            <a:off x="457200" y="3063240"/>
+            <a:ext cx="8229600" cy="1554480"/>
+          </a:xfrm>
+          <a:prstGeom prst="rect">
+            <a:avLst/>
+          </a:prstGeom>
+          <a:noFill/>
+          <a:ln/>
+        </p:spPr>
+        <p:txBody>
+          <a:bodyPr wrap="square" rtlCol="0" anchor="t"/>
+          <a:lstStyle/>
+          <a:p>
+            <a:pPr marL="342900" indent="-342900">
+              <a:spcAft>
+                <a:spcPts val="800"/>
+              </a:spcAft>
+              <a:buSzPct val="100000"/>
+              <a:buChar char="•"/>
+            </a:pPr>
+            <a:r>
+              <a:rPr lang="en-US" sz="1250" dirty="0">
+                <a:solidFill>
+                  <a:srgbClr val="2D2D2D"/>
+                </a:solidFill>
+                <a:latin typeface="Arial" pitchFamily="34" charset="0"/>
+                <a:ea typeface="Arial" pitchFamily="34" charset="-122"/>
+                <a:cs typeface="Arial" pitchFamily="34" charset="-120"/>
+              </a:rPr>
+              <a:t>A better fit to one observable does not imply agreement with another: SAXS averages intensity linearly; NOE upper bounds need r⁻⁶ averaging and one-sided treatment.</a:t>
+            </a:r>
+            <a:endParaRPr lang="en-US" sz="1250" dirty="0"/>
+          </a:p>
+          <a:p>
+            <a:pPr marL="342900" indent="-342900">
+              <a:spcAft>
+                <a:spcPts val="800"/>
+              </a:spcAft>
+              <a:buSzPct val="100000"/>
+              <a:buChar char="•"/>
+            </a:pPr>
+            <a:r>
+              <a:rPr lang="en-US" sz="1250" dirty="0">
+                <a:solidFill>
+                  <a:srgbClr val="2D2D2D"/>
+                </a:solidFill>
+                <a:latin typeface="Arial" pitchFamily="34" charset="0"/>
+                <a:ea typeface="Arial" pitchFamily="34" charset="-122"/>
+                <a:cs typeface="Arial" pitchFamily="34" charset="-120"/>
+              </a:rPr>
+              <a:t>Conditional answer, not proof that the two experiments contradict each other: restraint reuse, error model, candidate construction and NOE averaging still limit it.</a:t>
+            </a:r>
+            <a:endParaRPr lang="en-US" sz="1250" dirty="0"/>
+          </a:p>
+          <a:p>
+            <a:pPr marL="342900" indent="-342900">
+              <a:spcAft>
+                <a:spcPts val="800"/>
+              </a:spcAft>
+              <a:buSzPct val="100000"/>
+              <a:buChar char="•"/>
+            </a:pPr>
+            <a:r>
+              <a:rPr lang="en-US" sz="1250" dirty="0">
+                <a:solidFill>
+                  <a:srgbClr val="2D2D2D"/>
+                </a:solidFill>
+                <a:latin typeface="Arial" pitchFamily="34" charset="0"/>
+                <a:ea typeface="Arial" pitchFamily="34" charset="-122"/>
+                <a:cs typeface="Arial" pitchFamily="34" charset="-120"/>
+              </a:rPr>
+              <a:t>Developer-designed analysis; Agent runs on this case carried the result through, they did not show independent method discovery.</a:t>
+            </a:r>
+            <a:endParaRPr lang="en-US" sz="1250" dirty="0"/>
+          </a:p>
+        </p:txBody>
+      </p:sp>
+    </p:spTree>
+  </p:cSld>
+  <p:clrMapOvr>
+    <a:masterClrMapping/>
+  </p:clrMapOvr>
+</p:sld>
+</file>
+
+<file path=ppt/slides/slide27.xml><?xml version="1.0" encoding="utf-8"?>
+<p:sld xmlns:a="http://schemas.openxmlformats.org/drawingml/2006/main" xmlns:r="http://schemas.openxmlformats.org/officeDocument/2006/relationships" xmlns:p="http://schemas.openxmlformats.org/presentationml/2006/main">
+  <p:cSld name="Slide 27">
+    <p:bg>
+      <p:bgPr>
+        <a:solidFill>
+          <a:srgbClr val="FFFFFF"/>
+        </a:solidFill>
+      </p:bgPr>
+    </p:bg>
+    <p:spTree>
+      <p:nvGrpSpPr>
+        <p:cNvPr id="1" name=""/>
+        <p:cNvGrpSpPr/>
+        <p:nvPr/>
+      </p:nvGrpSpPr>
+      <p:grpSpPr>
+        <a:xfrm>
+          <a:off x="0" y="0"/>
+          <a:ext cx="0" cy="0"/>
+          <a:chOff x="0" y="0"/>
+          <a:chExt cx="0" cy="0"/>
+        </a:xfrm>
+      </p:grpSpPr>
+      <p:sp>
+        <p:nvSpPr>
+          <p:cNvPr id="2" name="Text 0"/>
+          <p:cNvSpPr/>
+          <p:nvPr/>
+        </p:nvSpPr>
+        <p:spPr>
+          <a:xfrm>
+            <a:off x="457200" y="228600"/>
+            <a:ext cx="8229600" cy="868680"/>
+          </a:xfrm>
+          <a:prstGeom prst="rect">
+            <a:avLst/>
+          </a:prstGeom>
+          <a:noFill/>
+          <a:ln/>
+        </p:spPr>
+        <p:txBody>
+          <a:bodyPr wrap="square" rtlCol="0" anchor="t"/>
+          <a:lstStyle/>
+          <a:p>
+            <a:pPr indent="0" marL="0">
+              <a:buNone/>
+            </a:pPr>
+            <a:r>
+              <a:rPr lang="en-US" sz="2100" b="1" dirty="0">
+                <a:solidFill>
+                  <a:srgbClr val="1F4E79"/>
+                </a:solidFill>
+                <a:latin typeface="Arial" pitchFamily="34" charset="0"/>
+                <a:ea typeface="Arial" pitchFamily="34" charset="-122"/>
+                <a:cs typeface="Arial" pitchFamily="34" charset="-120"/>
+              </a:rPr>
+              <a:t>A7. Terms as used in this deck</a:t>
+            </a:r>
+            <a:endParaRPr lang="en-US" sz="2100" dirty="0"/>
+          </a:p>
+        </p:txBody>
+      </p:sp>
+      <p:sp>
+        <p:nvSpPr>
+          <p:cNvPr id="3" name="Text 1"/>
+          <p:cNvSpPr/>
+          <p:nvPr/>
+        </p:nvSpPr>
+        <p:spPr>
+          <a:xfrm>
+            <a:off x="8412480" y="4736592"/>
+            <a:ext cx="274320" cy="274320"/>
+          </a:xfrm>
+          <a:prstGeom prst="rect">
+            <a:avLst/>
+          </a:prstGeom>
+          <a:noFill/>
+          <a:ln/>
+        </p:spPr>
+        <p:txBody>
+          <a:bodyPr wrap="square" rtlCol="0" anchor="ctr"/>
+          <a:lstStyle/>
+          <a:p>
+            <a:pPr algn="r" indent="0" marL="0">
+              <a:buNone/>
+            </a:pPr>
+            <a:r>
+              <a:rPr lang="en-US" sz="1000" dirty="0">
+                <a:solidFill>
+                  <a:srgbClr val="777777"/>
+                </a:solidFill>
+                <a:latin typeface="Arial" pitchFamily="34" charset="0"/>
+                <a:ea typeface="Arial" pitchFamily="34" charset="-122"/>
+                <a:cs typeface="Arial" pitchFamily="34" charset="-120"/>
+              </a:rPr>
+              <a:t>27</a:t>
+            </a:r>
+            <a:endParaRPr lang="en-US" sz="1000" dirty="0"/>
+          </a:p>
+        </p:txBody>
+      </p:sp>
+      <p:graphicFrame>
+        <p:nvGraphicFramePr>
+          <p:cNvPr id="28" name="Table 0"/>
           <p:cNvGraphicFramePr>
             <a:graphicFrameLocks noGrp="1"/>
           </p:cNvGraphicFramePr>
@@ -30686,7 +32422,7 @@
                 <a:ea typeface="Arial" pitchFamily="34" charset="-122"/>
                 <a:cs typeface="Arial" pitchFamily="34" charset="-120"/>
               </a:rPr>
-              <a:t>Where the Rules Table can act (four uses of the 33 rules; defined on slide 12)</a:t>
+              <a:t>Where the Rules Table can act (four uses; defined on slide 12)</a:t>
             </a:r>
             <a:endParaRPr lang="en-US" sz="1200" dirty="0"/>
           </a:p>
@@ -31177,7 +32913,7 @@
                 <a:ea typeface="Arial" pitchFamily="34" charset="-122"/>
                 <a:cs typeface="Arial" pitchFamily="34" charset="-120"/>
               </a:rPr>
-              <a:t>Version one (July–early September) used the table only at step 4, as text pasted into the Agent's prompt. The three systems on the next slides went through that version; the four uses were then tested one by one.</a:t>
+              <a:t>Before September the tests asked whether the selector picked the right checks (41/41 pre-registered checks selected among 146 generated), not whether answers improved. When the three systems ran, the table reached the Agent only at step 4, as selected rules pasted into the prompt.</a:t>
             </a:r>
             <a:endParaRPr lang="en-US" sz="1250" dirty="0"/>
           </a:p>
@@ -32568,7 +34304,7 @@
                           <a:ea typeface="Arial" pitchFamily="34" charset="-122"/>
                           <a:cs typeface="Arial" pitchFamily="34" charset="-120"/>
                         </a:rPr>
-                        <a:t>yes</a:t>
+                        <a:t>yes: SAXS and two NOE sets on shared weights</a:t>
                       </a:r>
                       <a:endParaRPr lang="en-US" sz="1050" dirty="0">
                         <a:latin typeface="Arial" charset="0"/>
@@ -32633,7 +34369,7 @@
                           <a:ea typeface="Arial" pitchFamily="34" charset="-122"/>
                           <a:cs typeface="Arial" pitchFamily="34" charset="-120"/>
                         </a:rPr>
-                        <a:t>development case; used in method-guidance test</a:t>
+                        <a:t>development case; cross-observable result in A6</a:t>
                       </a:r>
                       <a:endParaRPr lang="en-US" sz="1050" dirty="0">
                         <a:latin typeface="Arial" charset="0"/>
@@ -33494,7 +35230,7 @@
                 <a:ea typeface="Arial" pitchFamily="34" charset="-122"/>
                 <a:cs typeface="Arial" pitchFamily="34" charset="-120"/>
               </a:rPr>
-              <a:t>Closed-start trajectories: any sustained open-direction segment 10/20; later reversal 5/20. Counts are not transition rates.</a:t>
+              <a:t>Closed-start: any sustained open-direction segment 10/20; departure from the first sustained direction 5/20 (the same five that turned open later). Not transition rates.</a:t>
             </a:r>
             <a:endParaRPr lang="en-US" sz="900" dirty="0"/>
           </a:p>
@@ -34067,7 +35803,7 @@
                           <a:ea typeface="Arial" pitchFamily="34" charset="-122"/>
                           <a:cs typeface="Arial" pitchFamily="34" charset="-120"/>
                         </a:rPr>
-                        <a:t>10 open-direction (5 at start + 5 later) / 10 never</a:t>
+                        <a:t>10 open-direction (5 first segment open + 5 closed then open) / 10 never</a:t>
                       </a:r>
                       <a:endParaRPr lang="en-US" sz="950" dirty="0">
                         <a:latin typeface="Arial" charset="0"/>
@@ -34134,7 +35870,7 @@
                           <a:ea typeface="Arial" pitchFamily="34" charset="-122"/>
                           <a:cs typeface="Arial" pitchFamily="34" charset="-120"/>
                         </a:rPr>
-                        <a:t>reversals</a:t>
+                        <a:t>departures from first direction</a:t>
                       </a:r>
                       <a:endParaRPr lang="en-US" sz="950" dirty="0">
                         <a:latin typeface="Arial" charset="0"/>
@@ -34643,7 +36379,7 @@
                 <a:ea typeface="Arial" pitchFamily="34" charset="-122"/>
                 <a:cs typeface="Arial" pitchFamily="34" charset="-120"/>
               </a:rPr>
-              <a:t>HSP90, the measurement that mattered: at 1 Å tolerance, 9 of the 10 open-direction trajectories end far from both NOE references</a:t>
+              <a:t>HSP90, the measurement that mattered: at 1 Å tolerance, 9 of the 10 open-direction trajectories spend most of their open-direction time far from both NOE references</a:t>
             </a:r>
             <a:endParaRPr lang="en-US" sz="1900" dirty="0"/>
           </a:p>
@@ -34682,7 +36418,7 @@
                 <a:ea typeface="Arial" pitchFamily="34" charset="-122"/>
                 <a:cs typeface="Arial" pitchFamily="34" charset="-120"/>
               </a:rPr>
-              <a:t>Author-deposited NOE violation series (column 2); last 100 saved points per trajectory; tolerance lines 0.5 / 1 / 2 Å; controls 18/20 at 1 Å</a:t>
+              <a:t>Author-deposited NOE violation series (column 2); classification = share of open-direction points within tolerance; controls 18/20 at 1 Å; control band p95 = 1.32 Å</a:t>
             </a:r>
             <a:endParaRPr lang="en-US" sz="1000" dirty="0"/>
           </a:p>
@@ -34742,8 +36478,8 @@
         </p:blipFill>
         <p:spPr>
           <a:xfrm>
-            <a:off x="457200" y="1188720"/>
-            <a:ext cx="4206240" cy="3154680"/>
+            <a:off x="457200" y="1170432"/>
+            <a:ext cx="8229600" cy="2697480"/>
           </a:xfrm>
           <a:prstGeom prst="rect">
             <a:avLst/>
@@ -34758,8 +36494,8 @@
         </p:nvSpPr>
         <p:spPr>
           <a:xfrm>
-            <a:off x="457200" y="4361688"/>
-            <a:ext cx="4206240" cy="384048"/>
+            <a:off x="457200" y="3886200"/>
+            <a:ext cx="8229600" cy="384048"/>
           </a:xfrm>
           <a:prstGeom prst="rect">
             <a:avLst/>
@@ -34783,1047 +36519,22 @@
                 <a:ea typeface="Arial" pitchFamily="34" charset="-122"/>
                 <a:cs typeface="Arial" pitchFamily="34" charset="-120"/>
               </a:rPr>
-              <a:t>End-window mean NOE violation against closed (x) and open (y) references, all 40 trajectories.</a:t>
+              <a:t>Left: all 40 trajectories. Right: zoom on the open corner. Position = mean of the last 100 points (orientation only); colour = 1 Å classification by share of open-direction points within tolerance.</a:t>
             </a:r>
             <a:endParaRPr lang="en-US" sz="900" dirty="0"/>
           </a:p>
         </p:txBody>
       </p:sp>
-      <p:graphicFrame>
-        <p:nvGraphicFramePr>
-          <p:cNvPr id="7" name="Table 0"/>
-          <p:cNvGraphicFramePr>
-            <a:graphicFrameLocks noGrp="1"/>
-          </p:cNvGraphicFramePr>
-          <p:nvPr>
-            <p:extLst>
-              <p:ext uri="{D42A27DB-BD31-4B8C-83A1-F6EECF244321}">
-                <p14:modId xmlns:p14="http://schemas.microsoft.com/office/powerpoint/2010/main" val="1579011935"/>
-              </p:ext>
-            </p:extLst>
-          </p:nvPr>
-        </p:nvGraphicFramePr>
-        <p:xfrm>
-          <a:off x="4846320" y="1188720"/>
-          <a:ext cx="3840480" cy="914400"/>
-        </p:xfrm>
-        <a:graphic>
-          <a:graphicData uri="http://schemas.openxmlformats.org/drawingml/2006/table">
-            <a:tbl>
-              <a:tblPr/>
-              <a:tblGrid>
-                <a:gridCol w="1463040"/>
-                <a:gridCol w="1188720"/>
-                <a:gridCol w="1188720"/>
-              </a:tblGrid>
-              <a:tr h="310896">
-                <a:tc>
-                  <a:txBody>
-                    <a:bodyPr/>
-                    <a:lstStyle/>
-                    <a:p>
-                      <a:pPr indent="0" marL="0">
-                        <a:buNone/>
-                      </a:pPr>
-                      <a:r>
-                        <a:rPr lang="en-US" sz="1050" b="1" dirty="0">
-                          <a:solidFill>
-                            <a:srgbClr val="FFFFFF"/>
-                          </a:solidFill>
-                          <a:latin typeface="Arial" pitchFamily="34" charset="0"/>
-                          <a:ea typeface="Arial" pitchFamily="34" charset="-122"/>
-                          <a:cs typeface="Arial" pitchFamily="34" charset="-120"/>
-                        </a:rPr>
-                        <a:t>at 1 Å</a:t>
-                      </a:r>
-                      <a:endParaRPr lang="en-US" sz="1050" dirty="0">
-                        <a:latin typeface="Arial" charset="0"/>
-                        <a:ea typeface="Arial" charset="0"/>
-                        <a:cs typeface="Arial" charset="0"/>
-                      </a:endParaRPr>
-                    </a:p>
-                  </a:txBody>
-                  <a:tcPr marL="91440" marR="91440" marT="45720" marB="45720" anchor="ctr">
-                    <a:lnL w="6350" cap="flat" cmpd="sng" algn="ctr">
-                      <a:solidFill>
-                        <a:srgbClr val="CCCCCC"/>
-                      </a:solidFill>
-                      <a:prstDash val="solid"/>
-                      <a:round/>
-                      <a:headEnd type="none" w="med" len="med"/>
-                      <a:tailEnd type="none" w="med" len="med"/>
-                    </a:lnL>
-                    <a:lnR w="6350" cap="flat" cmpd="sng" algn="ctr">
-                      <a:solidFill>
-                        <a:srgbClr val="CCCCCC"/>
-                      </a:solidFill>
-                      <a:prstDash val="solid"/>
-                      <a:round/>
-                      <a:headEnd type="none" w="med" len="med"/>
-                      <a:tailEnd type="none" w="med" len="med"/>
-                    </a:lnR>
-                    <a:lnT w="6350" cap="flat" cmpd="sng" algn="ctr">
-                      <a:solidFill>
-                        <a:srgbClr val="CCCCCC"/>
-                      </a:solidFill>
-                      <a:prstDash val="solid"/>
-                      <a:round/>
-                      <a:headEnd type="none" w="med" len="med"/>
-                      <a:tailEnd type="none" w="med" len="med"/>
-                    </a:lnT>
-                    <a:lnB w="6350" cap="flat" cmpd="sng" algn="ctr">
-                      <a:solidFill>
-                        <a:srgbClr val="CCCCCC"/>
-                      </a:solidFill>
-                      <a:prstDash val="solid"/>
-                      <a:round/>
-                      <a:headEnd type="none" w="med" len="med"/>
-                      <a:tailEnd type="none" w="med" len="med"/>
-                    </a:lnB>
-                    <a:solidFill>
-                      <a:srgbClr val="1F4E79"/>
-                    </a:solidFill>
-                  </a:tcPr>
-                </a:tc>
-                <a:tc>
-                  <a:txBody>
-                    <a:bodyPr/>
-                    <a:lstStyle/>
-                    <a:p>
-                      <a:pPr indent="0" marL="0">
-                        <a:buNone/>
-                      </a:pPr>
-                      <a:r>
-                        <a:rPr lang="en-US" sz="1050" b="1" dirty="0">
-                          <a:solidFill>
-                            <a:srgbClr val="FFFFFF"/>
-                          </a:solidFill>
-                          <a:latin typeface="Arial" pitchFamily="34" charset="0"/>
-                          <a:ea typeface="Arial" pitchFamily="34" charset="-122"/>
-                          <a:cs typeface="Arial" pitchFamily="34" charset="-120"/>
-                        </a:rPr>
-                        <a:t>open-direction (10)</a:t>
-                      </a:r>
-                      <a:endParaRPr lang="en-US" sz="1050" dirty="0">
-                        <a:latin typeface="Arial" charset="0"/>
-                        <a:ea typeface="Arial" charset="0"/>
-                        <a:cs typeface="Arial" charset="0"/>
-                      </a:endParaRPr>
-                    </a:p>
-                  </a:txBody>
-                  <a:tcPr marL="91440" marR="91440" marT="45720" marB="45720" anchor="ctr">
-                    <a:lnL w="6350" cap="flat" cmpd="sng" algn="ctr">
-                      <a:solidFill>
-                        <a:srgbClr val="CCCCCC"/>
-                      </a:solidFill>
-                      <a:prstDash val="solid"/>
-                      <a:round/>
-                      <a:headEnd type="none" w="med" len="med"/>
-                      <a:tailEnd type="none" w="med" len="med"/>
-                    </a:lnL>
-                    <a:lnR w="6350" cap="flat" cmpd="sng" algn="ctr">
-                      <a:solidFill>
-                        <a:srgbClr val="CCCCCC"/>
-                      </a:solidFill>
-                      <a:prstDash val="solid"/>
-                      <a:round/>
-                      <a:headEnd type="none" w="med" len="med"/>
-                      <a:tailEnd type="none" w="med" len="med"/>
-                    </a:lnR>
-                    <a:lnT w="6350" cap="flat" cmpd="sng" algn="ctr">
-                      <a:solidFill>
-                        <a:srgbClr val="CCCCCC"/>
-                      </a:solidFill>
-                      <a:prstDash val="solid"/>
-                      <a:round/>
-                      <a:headEnd type="none" w="med" len="med"/>
-                      <a:tailEnd type="none" w="med" len="med"/>
-                    </a:lnT>
-                    <a:lnB w="6350" cap="flat" cmpd="sng" algn="ctr">
-                      <a:solidFill>
-                        <a:srgbClr val="CCCCCC"/>
-                      </a:solidFill>
-                      <a:prstDash val="solid"/>
-                      <a:round/>
-                      <a:headEnd type="none" w="med" len="med"/>
-                      <a:tailEnd type="none" w="med" len="med"/>
-                    </a:lnB>
-                    <a:solidFill>
-                      <a:srgbClr val="1F4E79"/>
-                    </a:solidFill>
-                  </a:tcPr>
-                </a:tc>
-                <a:tc>
-                  <a:txBody>
-                    <a:bodyPr/>
-                    <a:lstStyle/>
-                    <a:p>
-                      <a:pPr indent="0" marL="0">
-                        <a:buNone/>
-                      </a:pPr>
-                      <a:r>
-                        <a:rPr lang="en-US" sz="1050" b="1" dirty="0">
-                          <a:solidFill>
-                            <a:srgbClr val="FFFFFF"/>
-                          </a:solidFill>
-                          <a:latin typeface="Arial" pitchFamily="34" charset="0"/>
-                          <a:ea typeface="Arial" pitchFamily="34" charset="-122"/>
-                          <a:cs typeface="Arial" pitchFamily="34" charset="-120"/>
-                        </a:rPr>
-                        <a:t>open-start controls (20)</a:t>
-                      </a:r>
-                      <a:endParaRPr lang="en-US" sz="1050" dirty="0">
-                        <a:latin typeface="Arial" charset="0"/>
-                        <a:ea typeface="Arial" charset="0"/>
-                        <a:cs typeface="Arial" charset="0"/>
-                      </a:endParaRPr>
-                    </a:p>
-                  </a:txBody>
-                  <a:tcPr marL="91440" marR="91440" marT="45720" marB="45720" anchor="ctr">
-                    <a:lnL w="6350" cap="flat" cmpd="sng" algn="ctr">
-                      <a:solidFill>
-                        <a:srgbClr val="CCCCCC"/>
-                      </a:solidFill>
-                      <a:prstDash val="solid"/>
-                      <a:round/>
-                      <a:headEnd type="none" w="med" len="med"/>
-                      <a:tailEnd type="none" w="med" len="med"/>
-                    </a:lnL>
-                    <a:lnR w="6350" cap="flat" cmpd="sng" algn="ctr">
-                      <a:solidFill>
-                        <a:srgbClr val="CCCCCC"/>
-                      </a:solidFill>
-                      <a:prstDash val="solid"/>
-                      <a:round/>
-                      <a:headEnd type="none" w="med" len="med"/>
-                      <a:tailEnd type="none" w="med" len="med"/>
-                    </a:lnR>
-                    <a:lnT w="6350" cap="flat" cmpd="sng" algn="ctr">
-                      <a:solidFill>
-                        <a:srgbClr val="CCCCCC"/>
-                      </a:solidFill>
-                      <a:prstDash val="solid"/>
-                      <a:round/>
-                      <a:headEnd type="none" w="med" len="med"/>
-                      <a:tailEnd type="none" w="med" len="med"/>
-                    </a:lnT>
-                    <a:lnB w="6350" cap="flat" cmpd="sng" algn="ctr">
-                      <a:solidFill>
-                        <a:srgbClr val="CCCCCC"/>
-                      </a:solidFill>
-                      <a:prstDash val="solid"/>
-                      <a:round/>
-                      <a:headEnd type="none" w="med" len="med"/>
-                      <a:tailEnd type="none" w="med" len="med"/>
-                    </a:lnB>
-                    <a:solidFill>
-                      <a:srgbClr val="1F4E79"/>
-                    </a:solidFill>
-                  </a:tcPr>
-                </a:tc>
-              </a:tr>
-              <a:tr h="310896">
-                <a:tc>
-                  <a:txBody>
-                    <a:bodyPr/>
-                    <a:lstStyle/>
-                    <a:p>
-                      <a:pPr indent="0" marL="0">
-                        <a:buNone/>
-                      </a:pPr>
-                      <a:r>
-                        <a:rPr lang="en-US" sz="1050" dirty="0">
-                          <a:solidFill>
-                            <a:srgbClr val="2D2D2D"/>
-                          </a:solidFill>
-                          <a:latin typeface="Arial" pitchFamily="34" charset="0"/>
-                          <a:ea typeface="Arial" pitchFamily="34" charset="-122"/>
-                          <a:cs typeface="Arial" pitchFamily="34" charset="-120"/>
-                        </a:rPr>
-                        <a:t>far from both</a:t>
-                      </a:r>
-                      <a:endParaRPr lang="en-US" sz="1050" dirty="0">
-                        <a:latin typeface="Arial" charset="0"/>
-                        <a:ea typeface="Arial" charset="0"/>
-                        <a:cs typeface="Arial" charset="0"/>
-                      </a:endParaRPr>
-                    </a:p>
-                  </a:txBody>
-                  <a:tcPr marL="91440" marR="91440" marT="45720" marB="45720" anchor="ctr">
-                    <a:lnL w="6350" cap="flat" cmpd="sng" algn="ctr">
-                      <a:solidFill>
-                        <a:srgbClr val="CCCCCC"/>
-                      </a:solidFill>
-                      <a:prstDash val="solid"/>
-                      <a:round/>
-                      <a:headEnd type="none" w="med" len="med"/>
-                      <a:tailEnd type="none" w="med" len="med"/>
-                    </a:lnL>
-                    <a:lnR w="6350" cap="flat" cmpd="sng" algn="ctr">
-                      <a:solidFill>
-                        <a:srgbClr val="CCCCCC"/>
-                      </a:solidFill>
-                      <a:prstDash val="solid"/>
-                      <a:round/>
-                      <a:headEnd type="none" w="med" len="med"/>
-                      <a:tailEnd type="none" w="med" len="med"/>
-                    </a:lnR>
-                    <a:lnT w="6350" cap="flat" cmpd="sng" algn="ctr">
-                      <a:solidFill>
-                        <a:srgbClr val="CCCCCC"/>
-                      </a:solidFill>
-                      <a:prstDash val="solid"/>
-                      <a:round/>
-                      <a:headEnd type="none" w="med" len="med"/>
-                      <a:tailEnd type="none" w="med" len="med"/>
-                    </a:lnT>
-                    <a:lnB w="6350" cap="flat" cmpd="sng" algn="ctr">
-                      <a:solidFill>
-                        <a:srgbClr val="CCCCCC"/>
-                      </a:solidFill>
-                      <a:prstDash val="solid"/>
-                      <a:round/>
-                      <a:headEnd type="none" w="med" len="med"/>
-                      <a:tailEnd type="none" w="med" len="med"/>
-                    </a:lnB>
-                  </a:tcPr>
-                </a:tc>
-                <a:tc>
-                  <a:txBody>
-                    <a:bodyPr/>
-                    <a:lstStyle/>
-                    <a:p>
-                      <a:pPr indent="0" marL="0">
-                        <a:buNone/>
-                      </a:pPr>
-                      <a:r>
-                        <a:rPr lang="en-US" sz="1050" dirty="0">
-                          <a:solidFill>
-                            <a:srgbClr val="2D2D2D"/>
-                          </a:solidFill>
-                          <a:latin typeface="Arial" pitchFamily="34" charset="0"/>
-                          <a:ea typeface="Arial" pitchFamily="34" charset="-122"/>
-                          <a:cs typeface="Arial" pitchFamily="34" charset="-120"/>
-                        </a:rPr>
-                        <a:t>9</a:t>
-                      </a:r>
-                      <a:endParaRPr lang="en-US" sz="1050" dirty="0">
-                        <a:latin typeface="Arial" charset="0"/>
-                        <a:ea typeface="Arial" charset="0"/>
-                        <a:cs typeface="Arial" charset="0"/>
-                      </a:endParaRPr>
-                    </a:p>
-                  </a:txBody>
-                  <a:tcPr marL="91440" marR="91440" marT="45720" marB="45720" anchor="ctr">
-                    <a:lnL w="6350" cap="flat" cmpd="sng" algn="ctr">
-                      <a:solidFill>
-                        <a:srgbClr val="CCCCCC"/>
-                      </a:solidFill>
-                      <a:prstDash val="solid"/>
-                      <a:round/>
-                      <a:headEnd type="none" w="med" len="med"/>
-                      <a:tailEnd type="none" w="med" len="med"/>
-                    </a:lnL>
-                    <a:lnR w="6350" cap="flat" cmpd="sng" algn="ctr">
-                      <a:solidFill>
-                        <a:srgbClr val="CCCCCC"/>
-                      </a:solidFill>
-                      <a:prstDash val="solid"/>
-                      <a:round/>
-                      <a:headEnd type="none" w="med" len="med"/>
-                      <a:tailEnd type="none" w="med" len="med"/>
-                    </a:lnR>
-                    <a:lnT w="6350" cap="flat" cmpd="sng" algn="ctr">
-                      <a:solidFill>
-                        <a:srgbClr val="CCCCCC"/>
-                      </a:solidFill>
-                      <a:prstDash val="solid"/>
-                      <a:round/>
-                      <a:headEnd type="none" w="med" len="med"/>
-                      <a:tailEnd type="none" w="med" len="med"/>
-                    </a:lnT>
-                    <a:lnB w="6350" cap="flat" cmpd="sng" algn="ctr">
-                      <a:solidFill>
-                        <a:srgbClr val="CCCCCC"/>
-                      </a:solidFill>
-                      <a:prstDash val="solid"/>
-                      <a:round/>
-                      <a:headEnd type="none" w="med" len="med"/>
-                      <a:tailEnd type="none" w="med" len="med"/>
-                    </a:lnB>
-                  </a:tcPr>
-                </a:tc>
-                <a:tc>
-                  <a:txBody>
-                    <a:bodyPr/>
-                    <a:lstStyle/>
-                    <a:p>
-                      <a:pPr indent="0" marL="0">
-                        <a:buNone/>
-                      </a:pPr>
-                      <a:r>
-                        <a:rPr lang="en-US" sz="1050" dirty="0">
-                          <a:solidFill>
-                            <a:srgbClr val="2D2D2D"/>
-                          </a:solidFill>
-                          <a:latin typeface="Arial" pitchFamily="34" charset="0"/>
-                          <a:ea typeface="Arial" pitchFamily="34" charset="-122"/>
-                          <a:cs typeface="Arial" pitchFamily="34" charset="-120"/>
-                        </a:rPr>
-                        <a:t>1</a:t>
-                      </a:r>
-                      <a:endParaRPr lang="en-US" sz="1050" dirty="0">
-                        <a:latin typeface="Arial" charset="0"/>
-                        <a:ea typeface="Arial" charset="0"/>
-                        <a:cs typeface="Arial" charset="0"/>
-                      </a:endParaRPr>
-                    </a:p>
-                  </a:txBody>
-                  <a:tcPr marL="91440" marR="91440" marT="45720" marB="45720" anchor="ctr">
-                    <a:lnL w="6350" cap="flat" cmpd="sng" algn="ctr">
-                      <a:solidFill>
-                        <a:srgbClr val="CCCCCC"/>
-                      </a:solidFill>
-                      <a:prstDash val="solid"/>
-                      <a:round/>
-                      <a:headEnd type="none" w="med" len="med"/>
-                      <a:tailEnd type="none" w="med" len="med"/>
-                    </a:lnL>
-                    <a:lnR w="6350" cap="flat" cmpd="sng" algn="ctr">
-                      <a:solidFill>
-                        <a:srgbClr val="CCCCCC"/>
-                      </a:solidFill>
-                      <a:prstDash val="solid"/>
-                      <a:round/>
-                      <a:headEnd type="none" w="med" len="med"/>
-                      <a:tailEnd type="none" w="med" len="med"/>
-                    </a:lnR>
-                    <a:lnT w="6350" cap="flat" cmpd="sng" algn="ctr">
-                      <a:solidFill>
-                        <a:srgbClr val="CCCCCC"/>
-                      </a:solidFill>
-                      <a:prstDash val="solid"/>
-                      <a:round/>
-                      <a:headEnd type="none" w="med" len="med"/>
-                      <a:tailEnd type="none" w="med" len="med"/>
-                    </a:lnT>
-                    <a:lnB w="6350" cap="flat" cmpd="sng" algn="ctr">
-                      <a:solidFill>
-                        <a:srgbClr val="CCCCCC"/>
-                      </a:solidFill>
-                      <a:prstDash val="solid"/>
-                      <a:round/>
-                      <a:headEnd type="none" w="med" len="med"/>
-                      <a:tailEnd type="none" w="med" len="med"/>
-                    </a:lnB>
-                  </a:tcPr>
-                </a:tc>
-              </a:tr>
-              <a:tr h="310896">
-                <a:tc>
-                  <a:txBody>
-                    <a:bodyPr/>
-                    <a:lstStyle/>
-                    <a:p>
-                      <a:pPr indent="0" marL="0">
-                        <a:buNone/>
-                      </a:pPr>
-                      <a:r>
-                        <a:rPr lang="en-US" sz="1050" dirty="0">
-                          <a:solidFill>
-                            <a:srgbClr val="2D2D2D"/>
-                          </a:solidFill>
-                          <a:latin typeface="Arial" pitchFamily="34" charset="0"/>
-                          <a:ea typeface="Arial" pitchFamily="34" charset="-122"/>
-                          <a:cs typeface="Arial" pitchFamily="34" charset="-120"/>
-                        </a:rPr>
-                        <a:t>partially at open</a:t>
-                      </a:r>
-                      <a:endParaRPr lang="en-US" sz="1050" dirty="0">
-                        <a:latin typeface="Arial" charset="0"/>
-                        <a:ea typeface="Arial" charset="0"/>
-                        <a:cs typeface="Arial" charset="0"/>
-                      </a:endParaRPr>
-                    </a:p>
-                  </a:txBody>
-                  <a:tcPr marL="91440" marR="91440" marT="45720" marB="45720" anchor="ctr">
-                    <a:lnL w="6350" cap="flat" cmpd="sng" algn="ctr">
-                      <a:solidFill>
-                        <a:srgbClr val="CCCCCC"/>
-                      </a:solidFill>
-                      <a:prstDash val="solid"/>
-                      <a:round/>
-                      <a:headEnd type="none" w="med" len="med"/>
-                      <a:tailEnd type="none" w="med" len="med"/>
-                    </a:lnL>
-                    <a:lnR w="6350" cap="flat" cmpd="sng" algn="ctr">
-                      <a:solidFill>
-                        <a:srgbClr val="CCCCCC"/>
-                      </a:solidFill>
-                      <a:prstDash val="solid"/>
-                      <a:round/>
-                      <a:headEnd type="none" w="med" len="med"/>
-                      <a:tailEnd type="none" w="med" len="med"/>
-                    </a:lnR>
-                    <a:lnT w="6350" cap="flat" cmpd="sng" algn="ctr">
-                      <a:solidFill>
-                        <a:srgbClr val="CCCCCC"/>
-                      </a:solidFill>
-                      <a:prstDash val="solid"/>
-                      <a:round/>
-                      <a:headEnd type="none" w="med" len="med"/>
-                      <a:tailEnd type="none" w="med" len="med"/>
-                    </a:lnT>
-                    <a:lnB w="6350" cap="flat" cmpd="sng" algn="ctr">
-                      <a:solidFill>
-                        <a:srgbClr val="CCCCCC"/>
-                      </a:solidFill>
-                      <a:prstDash val="solid"/>
-                      <a:round/>
-                      <a:headEnd type="none" w="med" len="med"/>
-                      <a:tailEnd type="none" w="med" len="med"/>
-                    </a:lnB>
-                  </a:tcPr>
-                </a:tc>
-                <a:tc>
-                  <a:txBody>
-                    <a:bodyPr/>
-                    <a:lstStyle/>
-                    <a:p>
-                      <a:pPr indent="0" marL="0">
-                        <a:buNone/>
-                      </a:pPr>
-                      <a:r>
-                        <a:rPr lang="en-US" sz="1050" dirty="0">
-                          <a:solidFill>
-                            <a:srgbClr val="2D2D2D"/>
-                          </a:solidFill>
-                          <a:latin typeface="Arial" pitchFamily="34" charset="0"/>
-                          <a:ea typeface="Arial" pitchFamily="34" charset="-122"/>
-                          <a:cs typeface="Arial" pitchFamily="34" charset="-120"/>
-                        </a:rPr>
-                        <a:t>1</a:t>
-                      </a:r>
-                      <a:endParaRPr lang="en-US" sz="1050" dirty="0">
-                        <a:latin typeface="Arial" charset="0"/>
-                        <a:ea typeface="Arial" charset="0"/>
-                        <a:cs typeface="Arial" charset="0"/>
-                      </a:endParaRPr>
-                    </a:p>
-                  </a:txBody>
-                  <a:tcPr marL="91440" marR="91440" marT="45720" marB="45720" anchor="ctr">
-                    <a:lnL w="6350" cap="flat" cmpd="sng" algn="ctr">
-                      <a:solidFill>
-                        <a:srgbClr val="CCCCCC"/>
-                      </a:solidFill>
-                      <a:prstDash val="solid"/>
-                      <a:round/>
-                      <a:headEnd type="none" w="med" len="med"/>
-                      <a:tailEnd type="none" w="med" len="med"/>
-                    </a:lnL>
-                    <a:lnR w="6350" cap="flat" cmpd="sng" algn="ctr">
-                      <a:solidFill>
-                        <a:srgbClr val="CCCCCC"/>
-                      </a:solidFill>
-                      <a:prstDash val="solid"/>
-                      <a:round/>
-                      <a:headEnd type="none" w="med" len="med"/>
-                      <a:tailEnd type="none" w="med" len="med"/>
-                    </a:lnR>
-                    <a:lnT w="6350" cap="flat" cmpd="sng" algn="ctr">
-                      <a:solidFill>
-                        <a:srgbClr val="CCCCCC"/>
-                      </a:solidFill>
-                      <a:prstDash val="solid"/>
-                      <a:round/>
-                      <a:headEnd type="none" w="med" len="med"/>
-                      <a:tailEnd type="none" w="med" len="med"/>
-                    </a:lnT>
-                    <a:lnB w="6350" cap="flat" cmpd="sng" algn="ctr">
-                      <a:solidFill>
-                        <a:srgbClr val="CCCCCC"/>
-                      </a:solidFill>
-                      <a:prstDash val="solid"/>
-                      <a:round/>
-                      <a:headEnd type="none" w="med" len="med"/>
-                      <a:tailEnd type="none" w="med" len="med"/>
-                    </a:lnB>
-                  </a:tcPr>
-                </a:tc>
-                <a:tc>
-                  <a:txBody>
-                    <a:bodyPr/>
-                    <a:lstStyle/>
-                    <a:p>
-                      <a:pPr indent="0" marL="0">
-                        <a:buNone/>
-                      </a:pPr>
-                      <a:r>
-                        <a:rPr lang="en-US" sz="1050" dirty="0">
-                          <a:solidFill>
-                            <a:srgbClr val="2D2D2D"/>
-                          </a:solidFill>
-                          <a:latin typeface="Arial" pitchFamily="34" charset="0"/>
-                          <a:ea typeface="Arial" pitchFamily="34" charset="-122"/>
-                          <a:cs typeface="Arial" pitchFamily="34" charset="-120"/>
-                        </a:rPr>
-                        <a:t>1</a:t>
-                      </a:r>
-                      <a:endParaRPr lang="en-US" sz="1050" dirty="0">
-                        <a:latin typeface="Arial" charset="0"/>
-                        <a:ea typeface="Arial" charset="0"/>
-                        <a:cs typeface="Arial" charset="0"/>
-                      </a:endParaRPr>
-                    </a:p>
-                  </a:txBody>
-                  <a:tcPr marL="91440" marR="91440" marT="45720" marB="45720" anchor="ctr">
-                    <a:lnL w="6350" cap="flat" cmpd="sng" algn="ctr">
-                      <a:solidFill>
-                        <a:srgbClr val="CCCCCC"/>
-                      </a:solidFill>
-                      <a:prstDash val="solid"/>
-                      <a:round/>
-                      <a:headEnd type="none" w="med" len="med"/>
-                      <a:tailEnd type="none" w="med" len="med"/>
-                    </a:lnL>
-                    <a:lnR w="6350" cap="flat" cmpd="sng" algn="ctr">
-                      <a:solidFill>
-                        <a:srgbClr val="CCCCCC"/>
-                      </a:solidFill>
-                      <a:prstDash val="solid"/>
-                      <a:round/>
-                      <a:headEnd type="none" w="med" len="med"/>
-                      <a:tailEnd type="none" w="med" len="med"/>
-                    </a:lnR>
-                    <a:lnT w="6350" cap="flat" cmpd="sng" algn="ctr">
-                      <a:solidFill>
-                        <a:srgbClr val="CCCCCC"/>
-                      </a:solidFill>
-                      <a:prstDash val="solid"/>
-                      <a:round/>
-                      <a:headEnd type="none" w="med" len="med"/>
-                      <a:tailEnd type="none" w="med" len="med"/>
-                    </a:lnT>
-                    <a:lnB w="6350" cap="flat" cmpd="sng" algn="ctr">
-                      <a:solidFill>
-                        <a:srgbClr val="CCCCCC"/>
-                      </a:solidFill>
-                      <a:prstDash val="solid"/>
-                      <a:round/>
-                      <a:headEnd type="none" w="med" len="med"/>
-                      <a:tailEnd type="none" w="med" len="med"/>
-                    </a:lnB>
-                  </a:tcPr>
-                </a:tc>
-              </a:tr>
-              <a:tr h="310896">
-                <a:tc>
-                  <a:txBody>
-                    <a:bodyPr/>
-                    <a:lstStyle/>
-                    <a:p>
-                      <a:pPr indent="0" marL="0">
-                        <a:buNone/>
-                      </a:pPr>
-                      <a:r>
-                        <a:rPr lang="en-US" sz="1050" dirty="0">
-                          <a:solidFill>
-                            <a:srgbClr val="2D2D2D"/>
-                          </a:solidFill>
-                          <a:latin typeface="Arial" pitchFamily="34" charset="0"/>
-                          <a:ea typeface="Arial" pitchFamily="34" charset="-122"/>
-                          <a:cs typeface="Arial" pitchFamily="34" charset="-120"/>
-                        </a:rPr>
-                        <a:t>at open reference</a:t>
-                      </a:r>
-                      <a:endParaRPr lang="en-US" sz="1050" dirty="0">
-                        <a:latin typeface="Arial" charset="0"/>
-                        <a:ea typeface="Arial" charset="0"/>
-                        <a:cs typeface="Arial" charset="0"/>
-                      </a:endParaRPr>
-                    </a:p>
-                  </a:txBody>
-                  <a:tcPr marL="91440" marR="91440" marT="45720" marB="45720" anchor="ctr">
-                    <a:lnL w="6350" cap="flat" cmpd="sng" algn="ctr">
-                      <a:solidFill>
-                        <a:srgbClr val="CCCCCC"/>
-                      </a:solidFill>
-                      <a:prstDash val="solid"/>
-                      <a:round/>
-                      <a:headEnd type="none" w="med" len="med"/>
-                      <a:tailEnd type="none" w="med" len="med"/>
-                    </a:lnL>
-                    <a:lnR w="6350" cap="flat" cmpd="sng" algn="ctr">
-                      <a:solidFill>
-                        <a:srgbClr val="CCCCCC"/>
-                      </a:solidFill>
-                      <a:prstDash val="solid"/>
-                      <a:round/>
-                      <a:headEnd type="none" w="med" len="med"/>
-                      <a:tailEnd type="none" w="med" len="med"/>
-                    </a:lnR>
-                    <a:lnT w="6350" cap="flat" cmpd="sng" algn="ctr">
-                      <a:solidFill>
-                        <a:srgbClr val="CCCCCC"/>
-                      </a:solidFill>
-                      <a:prstDash val="solid"/>
-                      <a:round/>
-                      <a:headEnd type="none" w="med" len="med"/>
-                      <a:tailEnd type="none" w="med" len="med"/>
-                    </a:lnT>
-                    <a:lnB w="6350" cap="flat" cmpd="sng" algn="ctr">
-                      <a:solidFill>
-                        <a:srgbClr val="CCCCCC"/>
-                      </a:solidFill>
-                      <a:prstDash val="solid"/>
-                      <a:round/>
-                      <a:headEnd type="none" w="med" len="med"/>
-                      <a:tailEnd type="none" w="med" len="med"/>
-                    </a:lnB>
-                  </a:tcPr>
-                </a:tc>
-                <a:tc>
-                  <a:txBody>
-                    <a:bodyPr/>
-                    <a:lstStyle/>
-                    <a:p>
-                      <a:pPr indent="0" marL="0">
-                        <a:buNone/>
-                      </a:pPr>
-                      <a:r>
-                        <a:rPr lang="en-US" sz="1050" dirty="0">
-                          <a:solidFill>
-                            <a:srgbClr val="2D2D2D"/>
-                          </a:solidFill>
-                          <a:latin typeface="Arial" pitchFamily="34" charset="0"/>
-                          <a:ea typeface="Arial" pitchFamily="34" charset="-122"/>
-                          <a:cs typeface="Arial" pitchFamily="34" charset="-120"/>
-                        </a:rPr>
-                        <a:t>0</a:t>
-                      </a:r>
-                      <a:endParaRPr lang="en-US" sz="1050" dirty="0">
-                        <a:latin typeface="Arial" charset="0"/>
-                        <a:ea typeface="Arial" charset="0"/>
-                        <a:cs typeface="Arial" charset="0"/>
-                      </a:endParaRPr>
-                    </a:p>
-                  </a:txBody>
-                  <a:tcPr marL="91440" marR="91440" marT="45720" marB="45720" anchor="ctr">
-                    <a:lnL w="6350" cap="flat" cmpd="sng" algn="ctr">
-                      <a:solidFill>
-                        <a:srgbClr val="CCCCCC"/>
-                      </a:solidFill>
-                      <a:prstDash val="solid"/>
-                      <a:round/>
-                      <a:headEnd type="none" w="med" len="med"/>
-                      <a:tailEnd type="none" w="med" len="med"/>
-                    </a:lnL>
-                    <a:lnR w="6350" cap="flat" cmpd="sng" algn="ctr">
-                      <a:solidFill>
-                        <a:srgbClr val="CCCCCC"/>
-                      </a:solidFill>
-                      <a:prstDash val="solid"/>
-                      <a:round/>
-                      <a:headEnd type="none" w="med" len="med"/>
-                      <a:tailEnd type="none" w="med" len="med"/>
-                    </a:lnR>
-                    <a:lnT w="6350" cap="flat" cmpd="sng" algn="ctr">
-                      <a:solidFill>
-                        <a:srgbClr val="CCCCCC"/>
-                      </a:solidFill>
-                      <a:prstDash val="solid"/>
-                      <a:round/>
-                      <a:headEnd type="none" w="med" len="med"/>
-                      <a:tailEnd type="none" w="med" len="med"/>
-                    </a:lnT>
-                    <a:lnB w="6350" cap="flat" cmpd="sng" algn="ctr">
-                      <a:solidFill>
-                        <a:srgbClr val="CCCCCC"/>
-                      </a:solidFill>
-                      <a:prstDash val="solid"/>
-                      <a:round/>
-                      <a:headEnd type="none" w="med" len="med"/>
-                      <a:tailEnd type="none" w="med" len="med"/>
-                    </a:lnB>
-                  </a:tcPr>
-                </a:tc>
-                <a:tc>
-                  <a:txBody>
-                    <a:bodyPr/>
-                    <a:lstStyle/>
-                    <a:p>
-                      <a:pPr indent="0" marL="0">
-                        <a:buNone/>
-                      </a:pPr>
-                      <a:r>
-                        <a:rPr lang="en-US" sz="1050" dirty="0">
-                          <a:solidFill>
-                            <a:srgbClr val="2D2D2D"/>
-                          </a:solidFill>
-                          <a:latin typeface="Arial" pitchFamily="34" charset="0"/>
-                          <a:ea typeface="Arial" pitchFamily="34" charset="-122"/>
-                          <a:cs typeface="Arial" pitchFamily="34" charset="-120"/>
-                        </a:rPr>
-                        <a:t>18</a:t>
-                      </a:r>
-                      <a:endParaRPr lang="en-US" sz="1050" dirty="0">
-                        <a:latin typeface="Arial" charset="0"/>
-                        <a:ea typeface="Arial" charset="0"/>
-                        <a:cs typeface="Arial" charset="0"/>
-                      </a:endParaRPr>
-                    </a:p>
-                  </a:txBody>
-                  <a:tcPr marL="91440" marR="91440" marT="45720" marB="45720" anchor="ctr">
-                    <a:lnL w="6350" cap="flat" cmpd="sng" algn="ctr">
-                      <a:solidFill>
-                        <a:srgbClr val="CCCCCC"/>
-                      </a:solidFill>
-                      <a:prstDash val="solid"/>
-                      <a:round/>
-                      <a:headEnd type="none" w="med" len="med"/>
-                      <a:tailEnd type="none" w="med" len="med"/>
-                    </a:lnL>
-                    <a:lnR w="6350" cap="flat" cmpd="sng" algn="ctr">
-                      <a:solidFill>
-                        <a:srgbClr val="CCCCCC"/>
-                      </a:solidFill>
-                      <a:prstDash val="solid"/>
-                      <a:round/>
-                      <a:headEnd type="none" w="med" len="med"/>
-                      <a:tailEnd type="none" w="med" len="med"/>
-                    </a:lnR>
-                    <a:lnT w="6350" cap="flat" cmpd="sng" algn="ctr">
-                      <a:solidFill>
-                        <a:srgbClr val="CCCCCC"/>
-                      </a:solidFill>
-                      <a:prstDash val="solid"/>
-                      <a:round/>
-                      <a:headEnd type="none" w="med" len="med"/>
-                      <a:tailEnd type="none" w="med" len="med"/>
-                    </a:lnT>
-                    <a:lnB w="6350" cap="flat" cmpd="sng" algn="ctr">
-                      <a:solidFill>
-                        <a:srgbClr val="CCCCCC"/>
-                      </a:solidFill>
-                      <a:prstDash val="solid"/>
-                      <a:round/>
-                      <a:headEnd type="none" w="med" len="med"/>
-                      <a:tailEnd type="none" w="med" len="med"/>
-                    </a:lnB>
-                  </a:tcPr>
-                </a:tc>
-              </a:tr>
-              <a:tr h="310896">
-                <a:tc>
-                  <a:txBody>
-                    <a:bodyPr/>
-                    <a:lstStyle/>
-                    <a:p>
-                      <a:pPr indent="0" marL="0">
-                        <a:buNone/>
-                      </a:pPr>
-                      <a:r>
-                        <a:rPr lang="en-US" sz="1050" dirty="0">
-                          <a:solidFill>
-                            <a:srgbClr val="2D2D2D"/>
-                          </a:solidFill>
-                          <a:latin typeface="Arial" pitchFamily="34" charset="0"/>
-                          <a:ea typeface="Arial" pitchFamily="34" charset="-122"/>
-                          <a:cs typeface="Arial" pitchFamily="34" charset="-120"/>
-                        </a:rPr>
-                        <a:t>at 2 Å: at open</a:t>
-                      </a:r>
-                      <a:endParaRPr lang="en-US" sz="1050" dirty="0">
-                        <a:latin typeface="Arial" charset="0"/>
-                        <a:ea typeface="Arial" charset="0"/>
-                        <a:cs typeface="Arial" charset="0"/>
-                      </a:endParaRPr>
-                    </a:p>
-                  </a:txBody>
-                  <a:tcPr marL="91440" marR="91440" marT="45720" marB="45720" anchor="ctr">
-                    <a:lnL w="6350" cap="flat" cmpd="sng" algn="ctr">
-                      <a:solidFill>
-                        <a:srgbClr val="CCCCCC"/>
-                      </a:solidFill>
-                      <a:prstDash val="solid"/>
-                      <a:round/>
-                      <a:headEnd type="none" w="med" len="med"/>
-                      <a:tailEnd type="none" w="med" len="med"/>
-                    </a:lnL>
-                    <a:lnR w="6350" cap="flat" cmpd="sng" algn="ctr">
-                      <a:solidFill>
-                        <a:srgbClr val="CCCCCC"/>
-                      </a:solidFill>
-                      <a:prstDash val="solid"/>
-                      <a:round/>
-                      <a:headEnd type="none" w="med" len="med"/>
-                      <a:tailEnd type="none" w="med" len="med"/>
-                    </a:lnR>
-                    <a:lnT w="6350" cap="flat" cmpd="sng" algn="ctr">
-                      <a:solidFill>
-                        <a:srgbClr val="CCCCCC"/>
-                      </a:solidFill>
-                      <a:prstDash val="solid"/>
-                      <a:round/>
-                      <a:headEnd type="none" w="med" len="med"/>
-                      <a:tailEnd type="none" w="med" len="med"/>
-                    </a:lnT>
-                    <a:lnB w="6350" cap="flat" cmpd="sng" algn="ctr">
-                      <a:solidFill>
-                        <a:srgbClr val="CCCCCC"/>
-                      </a:solidFill>
-                      <a:prstDash val="solid"/>
-                      <a:round/>
-                      <a:headEnd type="none" w="med" len="med"/>
-                      <a:tailEnd type="none" w="med" len="med"/>
-                    </a:lnB>
-                  </a:tcPr>
-                </a:tc>
-                <a:tc>
-                  <a:txBody>
-                    <a:bodyPr/>
-                    <a:lstStyle/>
-                    <a:p>
-                      <a:pPr indent="0" marL="0">
-                        <a:buNone/>
-                      </a:pPr>
-                      <a:r>
-                        <a:rPr lang="en-US" sz="1050" dirty="0">
-                          <a:solidFill>
-                            <a:srgbClr val="2D2D2D"/>
-                          </a:solidFill>
-                          <a:latin typeface="Arial" pitchFamily="34" charset="0"/>
-                          <a:ea typeface="Arial" pitchFamily="34" charset="-122"/>
-                          <a:cs typeface="Arial" pitchFamily="34" charset="-120"/>
-                        </a:rPr>
-                        <a:t>3</a:t>
-                      </a:r>
-                      <a:endParaRPr lang="en-US" sz="1050" dirty="0">
-                        <a:latin typeface="Arial" charset="0"/>
-                        <a:ea typeface="Arial" charset="0"/>
-                        <a:cs typeface="Arial" charset="0"/>
-                      </a:endParaRPr>
-                    </a:p>
-                  </a:txBody>
-                  <a:tcPr marL="91440" marR="91440" marT="45720" marB="45720" anchor="ctr">
-                    <a:lnL w="6350" cap="flat" cmpd="sng" algn="ctr">
-                      <a:solidFill>
-                        <a:srgbClr val="CCCCCC"/>
-                      </a:solidFill>
-                      <a:prstDash val="solid"/>
-                      <a:round/>
-                      <a:headEnd type="none" w="med" len="med"/>
-                      <a:tailEnd type="none" w="med" len="med"/>
-                    </a:lnL>
-                    <a:lnR w="6350" cap="flat" cmpd="sng" algn="ctr">
-                      <a:solidFill>
-                        <a:srgbClr val="CCCCCC"/>
-                      </a:solidFill>
-                      <a:prstDash val="solid"/>
-                      <a:round/>
-                      <a:headEnd type="none" w="med" len="med"/>
-                      <a:tailEnd type="none" w="med" len="med"/>
-                    </a:lnR>
-                    <a:lnT w="6350" cap="flat" cmpd="sng" algn="ctr">
-                      <a:solidFill>
-                        <a:srgbClr val="CCCCCC"/>
-                      </a:solidFill>
-                      <a:prstDash val="solid"/>
-                      <a:round/>
-                      <a:headEnd type="none" w="med" len="med"/>
-                      <a:tailEnd type="none" w="med" len="med"/>
-                    </a:lnT>
-                    <a:lnB w="6350" cap="flat" cmpd="sng" algn="ctr">
-                      <a:solidFill>
-                        <a:srgbClr val="CCCCCC"/>
-                      </a:solidFill>
-                      <a:prstDash val="solid"/>
-                      <a:round/>
-                      <a:headEnd type="none" w="med" len="med"/>
-                      <a:tailEnd type="none" w="med" len="med"/>
-                    </a:lnB>
-                  </a:tcPr>
-                </a:tc>
-                <a:tc>
-                  <a:txBody>
-                    <a:bodyPr/>
-                    <a:lstStyle/>
-                    <a:p>
-                      <a:pPr indent="0" marL="0">
-                        <a:buNone/>
-                      </a:pPr>
-                      <a:r>
-                        <a:rPr lang="en-US" sz="1050" dirty="0">
-                          <a:solidFill>
-                            <a:srgbClr val="2D2D2D"/>
-                          </a:solidFill>
-                          <a:latin typeface="Arial" pitchFamily="34" charset="0"/>
-                          <a:ea typeface="Arial" pitchFamily="34" charset="-122"/>
-                          <a:cs typeface="Arial" pitchFamily="34" charset="-120"/>
-                        </a:rPr>
-                        <a:t>—</a:t>
-                      </a:r>
-                      <a:endParaRPr lang="en-US" sz="1050" dirty="0">
-                        <a:latin typeface="Arial" charset="0"/>
-                        <a:ea typeface="Arial" charset="0"/>
-                        <a:cs typeface="Arial" charset="0"/>
-                      </a:endParaRPr>
-                    </a:p>
-                  </a:txBody>
-                  <a:tcPr marL="91440" marR="91440" marT="45720" marB="45720" anchor="ctr">
-                    <a:lnL w="6350" cap="flat" cmpd="sng" algn="ctr">
-                      <a:solidFill>
-                        <a:srgbClr val="CCCCCC"/>
-                      </a:solidFill>
-                      <a:prstDash val="solid"/>
-                      <a:round/>
-                      <a:headEnd type="none" w="med" len="med"/>
-                      <a:tailEnd type="none" w="med" len="med"/>
-                    </a:lnL>
-                    <a:lnR w="6350" cap="flat" cmpd="sng" algn="ctr">
-                      <a:solidFill>
-                        <a:srgbClr val="CCCCCC"/>
-                      </a:solidFill>
-                      <a:prstDash val="solid"/>
-                      <a:round/>
-                      <a:headEnd type="none" w="med" len="med"/>
-                      <a:tailEnd type="none" w="med" len="med"/>
-                    </a:lnR>
-                    <a:lnT w="6350" cap="flat" cmpd="sng" algn="ctr">
-                      <a:solidFill>
-                        <a:srgbClr val="CCCCCC"/>
-                      </a:solidFill>
-                      <a:prstDash val="solid"/>
-                      <a:round/>
-                      <a:headEnd type="none" w="med" len="med"/>
-                      <a:tailEnd type="none" w="med" len="med"/>
-                    </a:lnT>
-                    <a:lnB w="6350" cap="flat" cmpd="sng" algn="ctr">
-                      <a:solidFill>
-                        <a:srgbClr val="CCCCCC"/>
-                      </a:solidFill>
-                      <a:prstDash val="solid"/>
-                      <a:round/>
-                      <a:headEnd type="none" w="med" len="med"/>
-                      <a:tailEnd type="none" w="med" len="med"/>
-                    </a:lnB>
-                  </a:tcPr>
-                </a:tc>
-              </a:tr>
-            </a:tbl>
-          </a:graphicData>
-        </a:graphic>
-      </p:graphicFrame>
       <p:sp>
         <p:nvSpPr>
-          <p:cNvPr id="9" name="Shape 4"/>
+          <p:cNvPr id="8" name="Shape 4"/>
           <p:cNvSpPr/>
           <p:nvPr/>
         </p:nvSpPr>
         <p:spPr>
           <a:xfrm>
-            <a:off x="4846320" y="2880360"/>
-            <a:ext cx="3840480" cy="1600200"/>
+            <a:off x="457200" y="4279392"/>
+            <a:ext cx="8229600" cy="411480"/>
           </a:xfrm>
           <a:prstGeom prst="rect">
             <a:avLst/>
@@ -35841,14 +36552,14 @@
       </p:sp>
       <p:sp>
         <p:nvSpPr>
-          <p:cNvPr id="10" name="Text 5"/>
+          <p:cNvPr id="9" name="Text 5"/>
           <p:cNvSpPr/>
           <p:nvPr/>
         </p:nvSpPr>
         <p:spPr>
           <a:xfrm>
-            <a:off x="4846320" y="2880360"/>
-            <a:ext cx="3840480" cy="1600200"/>
+            <a:off x="457200" y="4279392"/>
+            <a:ext cx="8229600" cy="411480"/>
           </a:xfrm>
           <a:prstGeom prst="rect">
             <a:avLst/>
@@ -35872,24 +36583,7 @@
                 <a:ea typeface="Arial" pitchFamily="34" charset="-122"/>
                 <a:cs typeface="Arial" pitchFamily="34" charset="-120"/>
               </a:rPr>
-              <a:t>Leaving the closed state ≠ arriving at the open state.</a:t>
-            </a:r>
-            <a:endParaRPr lang="en-US" sz="1100" dirty="0"/>
-          </a:p>
-          <a:p>
-            <a:pPr indent="0" marL="0">
-              <a:buNone/>
-            </a:pPr>
-            <a:r>
-              <a:rPr lang="en-US" sz="1100" dirty="0">
-                <a:solidFill>
-                  <a:srgbClr val="2D2D2D"/>
-                </a:solidFill>
-                <a:latin typeface="Arial" pitchFamily="34" charset="0"/>
-                <a:ea typeface="Arial" pitchFamily="34" charset="-122"/>
-                <a:cs typeface="Arial" pitchFamily="34" charset="-120"/>
-              </a:rPr>
-              <a:t>The Agent reproduced direction counts; the arrival question was added by a person, not by any rule. Populations and rates are not estimated: 1 µs runs, no returns, CPMG exchange is milliseconds.</a:t>
+              <a:t>1 Å: relative only 9 · partial 1 · agreement 0 (controls 1 · 1 · 18). At 2 Å, 3 of 10 agree. Runs move closer to the open reference; none meets the 1 Å tolerance for most of its open-direction time.</a:t>
             </a:r>
             <a:endParaRPr lang="en-US" sz="1100" dirty="0"/>
           </a:p>
@@ -37217,7 +37911,7 @@
                           <a:ea typeface="Arial" pitchFamily="34" charset="-122"/>
                           <a:cs typeface="Arial" pitchFamily="34" charset="-120"/>
                         </a:rPr>
-                        <a:t>correct</a:t>
+                        <a:t>correct; one local binning wording error</a:t>
                       </a:r>
                       <a:endParaRPr lang="en-US" sz="1150" dirty="0">
                         <a:latin typeface="Arial" charset="0"/>
@@ -37347,7 +38041,7 @@
                           <a:ea typeface="Arial" pitchFamily="34" charset="-122"/>
                           <a:cs typeface="Arial" pitchFamily="34" charset="-120"/>
                         </a:rPr>
-                        <a:t>RMP restraint, prior ensemble</a:t>
+                        <a:t>RMP-restraint conditions</a:t>
                       </a:r>
                       <a:endParaRPr lang="en-US" sz="1150" dirty="0">
                         <a:latin typeface="Arial" charset="0"/>
@@ -37544,7 +38238,7 @@
                           <a:ea typeface="Arial" pitchFamily="34" charset="-122"/>
                           <a:cs typeface="Arial" pitchFamily="34" charset="-120"/>
                         </a:rPr>
-                        <a:t>correct</a:t>
+                        <a:t>correct; added a useful 10/20 count</a:t>
                       </a:r>
                       <a:endParaRPr lang="en-US" sz="1150" dirty="0">
                         <a:latin typeface="Arial" charset="0"/>
@@ -37674,7 +38368,7 @@
                           <a:ea typeface="Arial" pitchFamily="34" charset="-122"/>
                           <a:cs typeface="Arial" pitchFamily="34" charset="-120"/>
                         </a:rPr>
-                        <a:t>RMP restraint, fit objective</a:t>
+                        <a:t>RMP-restraint conditions</a:t>
                       </a:r>
                       <a:endParaRPr lang="en-US" sz="1150" dirty="0">
                         <a:latin typeface="Arial" charset="0"/>
@@ -37785,7 +38479,7 @@
                 <a:ea typeface="Arial" pitchFamily="34" charset="-122"/>
                 <a:cs typeface="Arial" pitchFamily="34" charset="-120"/>
               </a:rPr>
-              <a:t>Where the leak came from: the selector matches rules by method family. A generic "MD uncertainty" check was mapped onto a FRET calibration rule (R0, inter-lab variation) and a FRET-assisted modeling rule (RMP restraint, prior ensemble). Matching by method name is not the same as applicability to the operation the question asks for.</a:t>
+              <a:t>Where it came from: an NMR reference-source check was mapped onto a FRET-assisted-modeling rule (RMP restraint, prior ensemble, fit objective); an MD-uncertainty check onto a smFRET calibration rule (R0, dye volume). Both texts reached the prompt; the answers carried the RMP terms. A rule can be retrieved correctly and still be wrong for the task.</a:t>
             </a:r>
             <a:endParaRPr lang="en-US" sz="1200" dirty="0"/>
           </a:p>
@@ -38877,7 +39571,7 @@
                 <a:ea typeface="Arial" pitchFamily="34" charset="-122"/>
                 <a:cs typeface="Arial" pitchFamily="34" charset="-120"/>
               </a:rPr>
-              <a:t>Both Agent answers accepted the 50–90 Å values (defect noticed 0/2). No reminder text catches a wrong input; the check belongs at step 2, in code, before freezing. Original answers kept, not scored as science; corrected numbers are a developer calculation.</a:t>
+              <a:t>Both Agent answers accepted the 46–94 Å values (defect noticed 0/2). No reminder text catches a wrong input; the check belongs at step 2, in code, before freezing. Original answers kept, not scored as science; corrected numbers are a developer calculation.</a:t>
             </a:r>
             <a:endParaRPr lang="en-US" sz="1150" dirty="0"/>
           </a:p>
@@ -39969,7 +40663,7 @@
                 <a:ea typeface="Arial" pitchFamily="34" charset="-122"/>
                 <a:cs typeface="Arial" pitchFamily="34" charset="-120"/>
               </a:rPr>
-              <a:t>My half-box rule (49–50 Å) flagged real 62 and 70 Å distances: the open molecule spans 56 Å. Replaced by: whole reconstructed molecule, adjacent Cα ≤ 4.5 Å, GROMACS agreement ≤ 0.01 Å.</a:t>
+              <a:t>DHFR asks a protein–ligand contact: nearest ligand image. ADK asks a distance inside one protein: keep the molecule whole. My half-box rule (49–50 Å) flagged real 62 and 70 Å distances. The check must follow the observable.</a:t>
             </a:r>
             <a:endParaRPr lang="en-US" sz="1050" dirty="0"/>
           </a:p>

</xml_diff>

<commit_message>
Add Rules Table overview page; fix R0/dye rule attribution to C001-RULE-002 in deck and scripts
Co-Authored-By: Claude Opus 5 <noreply@anthropic.com>
</commit_message>
<xml_diff>
--- a/review/rules-agent-study-20260909/development-results/SOOJUNG_DISCUSSION_20260910_EN.pptx
+++ b/review/rules-agent-study-20260909/development-results/SOOJUNG_DISCUSSION_20260910_EN.pptx
@@ -2653,7 +2653,7 @@
           <a:p>
             <a:r>
               <a:rPr lang="en-US" dirty="0"/>
-              <a:t>SAY: This was the first real use of the table, in the form the three systems ran under. Same question, four answers: two with only the data, two with the selected rules rendered into the prompt, seven rules, eight obligations, about 7,600 characters. Three of four got the main counts right; one mixed the five-point and fifty-point thresholds and did no calculation. The two rule answers were not more accurate. One of them, B2, added a useful 10 of 20 count. Both carried RMP-restraint conditions that belong to FRET-assisted modeling. That text reached the prompt because an NMR reference-source check was mapped onto Dimura's FRET-assisted modeling rule, and an MD-uncertainty check onto a smFRET calibration rule with R0 and dye volume. The paper supports those conditions for its own method; making them required fields for any NMR or MD analysis was our addition. Two runs per arm, and both arms shared the hand-written question, tables and field notes, so this cannot separate the selector from the protocol, the curation or the text length. It was enough to stop expanding this form and ask where the errors actually live.</a:t>
+              <a:t>SAY: This was the first real use of the table, in the form the three systems ran under. Same question, four answers: two with only the data, two with the selected rules rendered into the prompt, seven rules, eight obligations, about 7,600 characters. Three of four got the main counts right; one mixed the five-point and fifty-point thresholds and did no calculation. The two rule answers were not more accurate. One of them, B2, added a useful 10 of 20 count. Both carried RMP-restraint conditions that belong to FRET-assisted modeling. That text reached the prompt because an NMR reference-source check was mapped onto Dimura's FRET-assisted modeling rule, and an MD-uncertainty check onto a smFRET uncertainty-provenance rule with R0 and dye volume. The paper supports those conditions for its own method; making them required fields for any NMR or MD analysis was our addition. Two runs per arm, and both arms shared the hand-written question, tables and field notes, so this cannot separate the selector from the protocol, the curation or the text length. It was enough to stop expanding this form and ask where the errors actually live.</a:t>
             </a:r>
             <a:endParaRPr lang="en-US" dirty="0"/>
           </a:p>
@@ -36693,7 +36693,7 @@
                 <a:ea typeface="Arial" pitchFamily="34" charset="-122"/>
                 <a:cs typeface="Arial" pitchFamily="34" charset="-120"/>
               </a:rPr>
-              <a:t>HSP90_Q01_VERIFIED_REPORT_ZH.md; 4 answers, 10 Sep 2026, $0.076; leaked rules C001-RULE-003 (Hellenkamp 2018), C003-RULE-002 (Dimura 2020)</a:t>
+              <a:t>HSP90_Q01_VERIFIED_REPORT_ZH.md; 4 answers, 10 Sep 2026, $0.076; prompt text from C003-RULE-002 (Dimura 2020, RMP) and C001-RULE-002 (Hellenkamp 2018, R0 and dye volume)</a:t>
             </a:r>
             <a:endParaRPr lang="en-US" sz="1000" dirty="0"/>
           </a:p>
@@ -38479,7 +38479,7 @@
                 <a:ea typeface="Arial" pitchFamily="34" charset="-122"/>
                 <a:cs typeface="Arial" pitchFamily="34" charset="-120"/>
               </a:rPr>
-              <a:t>Where it came from: an NMR reference-source check was mapped onto a FRET-assisted-modeling rule (RMP restraint, prior ensemble, fit objective); an MD-uncertainty check onto a smFRET calibration rule (R0, dye volume). Both texts reached the prompt; the answers carried the RMP terms. A rule can be retrieved correctly and still be wrong for the task.</a:t>
+              <a:t>Where it came from: an NMR reference-source check was mapped onto a FRET-assisted-modeling rule (RMP restraint, prior ensemble, fit objective); an MD-uncertainty check onto a smFRET uncertainty-provenance rule (R0, dye volume). Both texts reached the prompt; the answers carried the RMP terms. A rule can be retrieved correctly and still be wrong for the task.</a:t>
             </a:r>
             <a:endParaRPr lang="en-US" sz="1200" dirty="0"/>
           </a:p>

</xml_diff>